<commit_message>
docs: migliora presentazione APR2026 v2 — layout, GRL, note relatore
- Slide 3: testo eps² spostato sopra il grafo (eliminato overlap con barre)
- Slide 6: Temporal Encoder box espanso con 3 righe (contributo originale,
  pesi condivisi, pipeline CNN); footnote leggibile (sz 1000→1100)
- Slide 7: GRL box espanso con meccanismo adversarial (forward/backward/
  alpha schedule DANN, v1 vs v2 confronto)
- Slide 8: colonne Chance e Delta ora a larghezza corretta (nessun wrap)
- Slide 11: footnote DHSLP leggibile (sz 1000→1100)
- Tutte le 13 slide: note relatore aggiunte in italiano

Co-Authored-By: Claude Sonnet 4.6 <noreply@anthropic.com>
</commit_message>
<xml_diff>
--- a/docs/presentation_stato_lavori_apr2026.pptx
+++ b/docs/presentation_stato_lavori_apr2026.pptx
@@ -513,10 +513,31 @@
           <a:lstStyle/>
           <a:p>
             <a:r>
-              <a:rPr lang="en-US" dirty="0"/>
-              <a:t/>
-            </a:r>
-            <a:endParaRPr lang="en-US" dirty="0"/>
+              <a:rPr lang="it-IT" dirty="0"/>
+              <a:t>Questa presentazione riassume lo stato dei lavori della tesi magistrale su decodifica dell'imagined speech da EEG con Graph Neural Networks.</a:t>
+            </a:r>
+            <a:endParaRPr lang="it-IT" dirty="0"/>
+          </a:p>
+          <a:p>
+            <a:r>
+              <a:rPr lang="it-IT" dirty="0"/>
+              <a:t>Il progetto e' in corso da circa 9 mesi presso il DEIB del Politecnico di Milano.</a:t>
+            </a:r>
+            <a:endParaRPr lang="it-IT" dirty="0"/>
+          </a:p>
+          <a:p>
+            <a:r>
+              <a:rPr lang="it-IT" dirty="0"/>
+              <a:t>L'obiettivo finale e' costruire un modello che riconosca la categoria semantica di una parola immaginata da segnali cerebrali.</a:t>
+            </a:r>
+            <a:endParaRPr lang="it-IT" dirty="0"/>
+          </a:p>
+          <a:p>
+            <a:r>
+              <a:rPr lang="it-IT" dirty="0"/>
+              <a:t>Sono stati completati 9 notebook sperimentali (EEG_00 - EEG_09); il prossimo passo e' EEG_10 con Hypergraph Neural Networks.</a:t>
+            </a:r>
+            <a:endParaRPr lang="it-IT" dirty="0"/>
           </a:p>
         </p:txBody>
       </p:sp>
@@ -601,10 +622,31 @@
           <a:lstStyle/>
           <a:p>
             <a:r>
-              <a:rPr lang="en-US" dirty="0"/>
-              <a:t/>
-            </a:r>
-            <a:endParaRPr lang="en-US" dirty="0"/>
+              <a:rPr lang="it-IT" dirty="0"/>
+              <a:t>EEG_10 e' il passo centrale della tesi: implementare Hypergraph Neural Networks per catturare relazioni di ordine superiore tra gruppi di elettrodi.</a:t>
+            </a:r>
+            <a:endParaRPr lang="it-IT" dirty="0"/>
+          </a:p>
+          <a:p>
+            <a:r>
+              <a:rPr lang="it-IT" dirty="0"/>
+              <a:t>Un iperedge connette 3+ nodi simultaneamente -- non solo coppie. Questo permette di modellare reti funzionali cerebrali come unita' (es. rete frontale: F3, F4, Fz, FCz tutti insieme in un iperedge).</a:t>
+            </a:r>
+            <a:endParaRPr lang="it-IT" dirty="0"/>
+          </a:p>
+          <a:p>
+            <a:r>
+              <a:rPr lang="it-IT" dirty="0"/>
+              <a:t>Instance Normalization e' un quick win a basso sforzo: una riga di codice che normalizza ogni trial indipendentemente, rimuovendo il DC offset di ampiezza specifico del soggetto.</a:t>
+            </a:r>
+            <a:endParaRPr lang="it-IT" dirty="0"/>
+          </a:p>
+          <a:p>
+            <a:r>
+              <a:rPr lang="it-IT" dirty="0"/>
+              <a:t>Il contrastive learning (CLISA) e' il passo piu' ambizioso: sfrutta i 70 soggetti come vantaggio costruendo coppie positive cross-subject (stessa parola, soggetti diversi).</a:t>
+            </a:r>
+            <a:endParaRPr lang="it-IT" dirty="0"/>
           </a:p>
         </p:txBody>
       </p:sp>
@@ -689,10 +731,31 @@
           <a:lstStyle/>
           <a:p>
             <a:r>
-              <a:rPr lang="en-US" dirty="0"/>
-              <a:t/>
-            </a:r>
-            <a:endParaRPr lang="en-US" dirty="0"/>
+              <a:rPr lang="it-IT" dirty="0"/>
+              <a:t>Il limite fondamentale dei grafi classici e' l'arco binario: ogni arco connette esattamente 2 nodi. Le interazioni cerebrali reali spesso coinvolgono gruppi di regioni.</a:t>
+            </a:r>
+            <a:endParaRPr lang="it-IT" dirty="0"/>
+          </a:p>
+          <a:p>
+            <a:r>
+              <a:rPr lang="it-IT" dirty="0"/>
+              <a:t>Esempio concreto: la rete frontale (F3, F4, Fz, FCz) e' una unita' funzionale attiva nel linguaggio immaginato. Con un grafo classico si modellano solo le coppie F3-F4, F3-Fz, ecc. -- non la dinamica collettiva.</a:t>
+            </a:r>
+            <a:endParaRPr lang="it-IT" dirty="0"/>
+          </a:p>
+          <a:p>
+            <a:r>
+              <a:rPr lang="it-IT" dirty="0"/>
+              <a:t>Con un hypergraph, un singolo iperedge {F3, F4, Fz, FCz} cattura la co-attivazione simultanea dell'intera rete -- informazione non recuperabile da nessuna combinazione di archi pairwise.</a:t>
+            </a:r>
+            <a:endParaRPr lang="it-IT" dirty="0"/>
+          </a:p>
+          <a:p>
+            <a:r>
+              <a:rPr lang="it-IT" dirty="0"/>
+              <a:t>Li et al. 2025 (DHSLP) raggiungono 78% su imagined speech con hypergraph dinamico -- anche se in setting piu' facile (subject-dependent, feature-based), dimostra il potenziale.</a:t>
+            </a:r>
+            <a:endParaRPr lang="it-IT" dirty="0"/>
           </a:p>
         </p:txBody>
       </p:sp>
@@ -777,10 +840,31 @@
           <a:lstStyle/>
           <a:p>
             <a:r>
-              <a:rPr lang="en-US" dirty="0"/>
-              <a:t/>
-            </a:r>
-            <a:endParaRPr lang="en-US" dirty="0"/>
+              <a:rPr lang="it-IT" dirty="0"/>
+              <a:t>La domanda principale e' empirica: vogliamo misurare se le iperedge aggiungono potere discriminativo rispetto ai grafi pairwise nello stesso setting sperimentale.</a:t>
+            </a:r>
+            <a:endParaRPr lang="it-IT" dirty="0"/>
+          </a:p>
+          <a:p>
+            <a:r>
+              <a:rPr lang="it-IT" dirty="0"/>
+              <a:t>La sotto-domanda 2 (domain adaptation su hypergraph) e' la novita' metodologica: nessun paper ha combinato GRL con rappresentazioni ipergrafiche per EEG.</a:t>
+            </a:r>
+            <a:endParaRPr lang="it-IT" dirty="0"/>
+          </a:p>
+          <a:p>
+            <a:r>
+              <a:rPr lang="it-IT" dirty="0"/>
+              <a:t>La sotto-domanda 3 (limite con 70 soggetti) e' di interesse per la comunita': stabilisce un lower bound empirico per questo tipo di dataset.</a:t>
+            </a:r>
+            <a:endParaRPr lang="it-IT" dirty="0"/>
+          </a:p>
+          <a:p>
+            <a:r>
+              <a:rPr lang="it-IT" dirty="0"/>
+              <a:t>Risposta attesa: anche se non si supera il chance level in modo netto, il contributo e' documentare sistematicamente cosa funziona e cosa no in questo setting.</a:t>
+            </a:r>
+            <a:endParaRPr lang="it-IT" dirty="0"/>
           </a:p>
         </p:txBody>
       </p:sp>
@@ -865,10 +949,38 @@
           <a:lstStyle/>
           <a:p>
             <a:r>
-              <a:rPr lang="en-US" dirty="0"/>
-              <a:t/>
-            </a:r>
-            <a:endParaRPr lang="en-US" dirty="0"/>
+              <a:rPr lang="it-IT" dirty="0"/>
+              <a:t>Il contributo principale e' metodologico: una progressione sperimentale rigorosa che documenta ogni passo e identifica i limiti strutturali del problema.</a:t>
+            </a:r>
+            <a:endParaRPr lang="it-IT" dirty="0"/>
+          </a:p>
+          <a:p>
+            <a:r>
+              <a:rPr lang="it-IT" dirty="0"/>
+              <a:t>La progressione ML - DL - GCN - GAT+adversarial e' completa e confrontabile: ogni modello usa lo stesso split, la stessa metrica, lo stesso dataset.</a:t>
+            </a:r>
+            <a:endParaRPr lang="it-IT" dirty="0"/>
+          </a:p>
+          <a:p>
+            <a:r>
+              <a:rPr lang="it-IT" dirty="0"/>
+              <a:t>Il fatto che anche FAST 2025 (il miglior paper dello stato dell'arte) ottiene solo +6.9% su chance in strict LOSO valida i nostri risultati -- non e' un errore implementativo.</a:t>
+            </a:r>
+            <a:endParaRPr lang="it-IT" dirty="0"/>
+          </a:p>
+          <a:p>
+            <a:r>
+              <a:rPr lang="it-IT" dirty="0"/>
+              <a:t>Prossimo milestone realistico: EEG_10 Hypergraph con 27-30% test_bacc -- anche un piccolo miglioramento stabile avrebbe valore scientifico.</a:t>
+            </a:r>
+            <a:endParaRPr lang="it-IT" dirty="0"/>
+          </a:p>
+          <a:p>
+            <a:r>
+              <a:rPr lang="it-IT" dirty="0"/>
+              <a:t>Contributo atteso per la tesi: primo studio che combina Hypergraph end-to-end con domain adversarial su imagined speech in strict cross-subject evaluation con 70 soggetti.</a:t>
+            </a:r>
+            <a:endParaRPr lang="it-IT" dirty="0"/>
           </a:p>
         </p:txBody>
       </p:sp>
@@ -953,10 +1065,31 @@
           <a:lstStyle/>
           <a:p>
             <a:r>
-              <a:rPr lang="en-US" dirty="0"/>
-              <a:t/>
-            </a:r>
-            <a:endParaRPr lang="en-US" dirty="0"/>
+              <a:rPr lang="it-IT" dirty="0"/>
+              <a:t>Il task e' classificare la parola immaginata in 4 categorie: CONCRETO (oggetti fisici), AZIONE (verbi di movimento), STATO (verbi stativi), ASTRATTO (concetti).</a:t>
+            </a:r>
+            <a:endParaRPr lang="it-IT" dirty="0"/>
+          </a:p>
+          <a:p>
+            <a:r>
+              <a:rPr lang="it-IT" dirty="0"/>
+              <a:t>Il dataset contiene 70 soggetti con circa 1100 trial ciascuno (5 sessioni x ~220 epoche) -- e' insolitamente grande per questo dominio.</a:t>
+            </a:r>
+            <a:endParaRPr lang="it-IT" dirty="0"/>
+          </a:p>
+          <a:p>
+            <a:r>
+              <a:rPr lang="it-IT" dirty="0"/>
+              <a:t>L'approccio end-to-end e' fondamentale: non usiamo feature engineering manuale, il modello impara direttamente dal segnale grezzo (59 canali x 384 campioni).</a:t>
+            </a:r>
+            <a:endParaRPr lang="it-IT" dirty="0"/>
+          </a:p>
+          <a:p>
+            <a:r>
+              <a:rPr lang="it-IT" dirty="0"/>
+              <a:t>Domanda probabile: "Perche 4 classi?" -- Risposta: le 110 parole originali sono troppo poche per trial per classe; il clustering semantico riduce a 4 categorie affidabili.</a:t>
+            </a:r>
+            <a:endParaRPr lang="it-IT" dirty="0"/>
           </a:p>
         </p:txBody>
       </p:sp>
@@ -1041,10 +1174,38 @@
           <a:lstStyle/>
           <a:p>
             <a:r>
-              <a:rPr lang="en-US" dirty="0"/>
-              <a:t/>
-            </a:r>
-            <a:endParaRPr lang="en-US" dirty="0"/>
+              <a:rPr lang="it-IT" dirty="0"/>
+              <a:t>Questo e' il risultato piu importante dell'analisi esplorativa (EEG_00): la varianza inter-soggetto domina completamente.</a:t>
+            </a:r>
+            <a:endParaRPr lang="it-IT" dirty="0"/>
+          </a:p>
+          <a:p>
+            <a:r>
+              <a:rPr lang="it-IT" dirty="0"/>
+              <a:t>eps2(soggetto)=0.85 significa che l'85% della varianza nei dati EEG e' spiegata dall'identita' del soggetto, non dalla parola immaginata.</a:t>
+            </a:r>
+            <a:endParaRPr lang="it-IT" dirty="0"/>
+          </a:p>
+          <a:p>
+            <a:r>
+              <a:rPr lang="it-IT" dirty="0"/>
+              <a:t>eps2(parola)=0.03 -- solo il 3% della varianza contiene informazione semantica -- questo e' il segnale che vogliamo estrarre.</a:t>
+            </a:r>
+            <a:endParaRPr lang="it-IT" dirty="0"/>
+          </a:p>
+          <a:p>
+            <a:r>
+              <a:rPr lang="it-IT" dirty="0"/>
+              <a:t>La scelta del setting strict subject-independent e' metodologicamente obbligata: altrimenti si classificherebbe il soggetto, non la parola.</a:t>
+            </a:r>
+            <a:endParaRPr lang="it-IT" dirty="0"/>
+          </a:p>
+          <a:p>
+            <a:r>
+              <a:rPr lang="it-IT" dirty="0"/>
+              <a:t>Domanda probabile: "E' possibile fare meglio con piu dati?" -- Si', Bomatter 2025 (NeurIPS) suggerisce che servono piu di 200 soggetti.</a:t>
+            </a:r>
+            <a:endParaRPr lang="it-IT" dirty="0"/>
           </a:p>
         </p:txBody>
       </p:sp>
@@ -1129,10 +1290,31 @@
           <a:lstStyle/>
           <a:p>
             <a:r>
-              <a:rPr lang="en-US" dirty="0"/>
-              <a:t/>
-            </a:r>
-            <a:endParaRPr lang="en-US" dirty="0"/>
+              <a:rPr lang="it-IT" dirty="0"/>
+              <a:t>Il preprocessing e' gia' completato: i dati sono in HDF5 con 59 canali validi (rimossi A1, A2 di riferimento) e 384 campioni per trial a 256 Hz.</a:t>
+            </a:r>
+            <a:endParaRPr lang="it-IT" dirty="0"/>
+          </a:p>
+          <a:p>
+            <a:r>
+              <a:rPr lang="it-IT" dirty="0"/>
+              <a:t>Il clustering semantico concr4 usa la concretezza lessicale delle parole come criterio di raggruppamento -- schema validato da psicolinguistica.</a:t>
+            </a:r>
+            <a:endParaRPr lang="it-IT" dirty="0"/>
+          </a:p>
+          <a:p>
+            <a:r>
+              <a:rPr lang="it-IT" dirty="0"/>
+              <a:t>La Balanced Accuracy e' la metrica corretta perche le classi non sono perfettamente bilanciate (ASTRATTO e' piu frequente delle altre).</a:t>
+            </a:r>
+            <a:endParaRPr lang="it-IT" dirty="0"/>
+          </a:p>
+          <a:p>
+            <a:r>
+              <a:rPr lang="it-IT" dirty="0"/>
+              <a:t>Lo split e' sempre lo stesso in tutti gli esperimenti: train sogg. 0-49, val 50-59, test 60-73 -- i soggetti test non vengono mai visti durante il training.</a:t>
+            </a:r>
+            <a:endParaRPr lang="it-IT" dirty="0"/>
           </a:p>
         </p:txBody>
       </p:sp>
@@ -1217,10 +1399,38 @@
           <a:lstStyle/>
           <a:p>
             <a:r>
-              <a:rPr lang="en-US" dirty="0"/>
-              <a:t/>
-            </a:r>
-            <a:endParaRPr lang="en-US" dirty="0"/>
+              <a:rPr lang="it-IT" dirty="0"/>
+              <a:t>Ogni notebook documenta sistematicamente perche' una famiglia di approcci non funziona -- e' una progressione metodologica deliberata.</a:t>
+            </a:r>
+            <a:endParaRPr lang="it-IT" dirty="0"/>
+          </a:p>
+          <a:p>
+            <a:r>
+              <a:rPr lang="it-IT" dirty="0"/>
+              <a:t>EEG_00/01: l'analisi ANOVA ha rivelato il problema strutturale (eps2=0.85) prima di sprecare tempo su modelli complessi.</a:t>
+            </a:r>
+            <a:endParaRPr lang="it-IT" dirty="0"/>
+          </a:p>
+          <a:p>
+            <a:r>
+              <a:rPr lang="it-IT" dirty="0"/>
+              <a:t>EEG_05-07 (Braindecode): 6 architetture state-of-the-art testate in 5-fold CV -- tutte a chance esatto (std &lt;= 0.001). Non e' variabilita' casuale.</a:t>
+            </a:r>
+            <a:endParaRPr lang="it-IT" dirty="0"/>
+          </a:p>
+          <a:p>
+            <a:r>
+              <a:rPr lang="it-IT" dirty="0"/>
+              <a:t>EEG_08/09: modelli GNN originali con grafo su elettrodi -- stessa conclusione ma con architetture motivate da letteratura specifica.</a:t>
+            </a:r>
+            <a:endParaRPr lang="it-IT" dirty="0"/>
+          </a:p>
+          <a:p>
+            <a:r>
+              <a:rPr lang="it-IT" dirty="0"/>
+              <a:t>EEG_10 (prossimo): hypergraph per catturare relazioni di ordine superiore tra gruppi di elettrodi.</a:t>
+            </a:r>
+            <a:endParaRPr lang="it-IT" dirty="0"/>
           </a:p>
         </p:txBody>
       </p:sp>
@@ -1305,10 +1515,45 @@
           <a:lstStyle/>
           <a:p>
             <a:r>
-              <a:rPr lang="en-US" dirty="0"/>
-              <a:t/>
-            </a:r>
-            <a:endParaRPr lang="en-US" dirty="0"/>
+              <a:rPr lang="it-IT" dirty="0"/>
+              <a:t>Il Temporal Encoder e' il contributo originale di EEG_08: una 1D CNN applicata a ogni elettrodo indipendentemente con pesi condivisi tra i 59 canali.</a:t>
+            </a:r>
+            <a:endParaRPr lang="it-IT" dirty="0"/>
+          </a:p>
+          <a:p>
+            <a:r>
+              <a:rPr lang="it-IT" dirty="0"/>
+              <a:t>Questo significa che la rete impara filtri temporali universali -- la stessa CNN che estrae pattern da F3 viene applicata identica a Oz, Cz, ecc.</a:t>
+            </a:r>
+            <a:endParaRPr lang="it-IT" dirty="0"/>
+          </a:p>
+          <a:p>
+            <a:r>
+              <a:rPr lang="it-IT" dirty="0"/>
+              <a:t>L'output e' un embedding 64-dim per nodo: il segnale temporale (384 campioni) viene compresso in un vettore che cattura oscillazioni e transitori.</a:t>
+            </a:r>
+            <a:endParaRPr lang="it-IT" dirty="0"/>
+          </a:p>
+          <a:p>
+            <a:r>
+              <a:rPr lang="it-IT" dirty="0"/>
+              <a:t>Il grafo PCC k-NN connette i 59 elettrodi in base alla correlazione di Pearson media calcolata su 1000 trial di training -- connettivita' funzionale media del gruppo.</a:t>
+            </a:r>
+            <a:endParaRPr lang="it-IT" dirty="0"/>
+          </a:p>
+          <a:p>
+            <a:r>
+              <a:rPr lang="it-IT" dirty="0"/>
+              <a:t>La differenza rispetto a GCNs-Net (Lun 2022): essi processano ogni timestep separatamente (time-resolved); noi produciamo un embedding per l'intero trial.</a:t>
+            </a:r>
+            <a:endParaRPr lang="it-IT" dirty="0"/>
+          </a:p>
+          <a:p>
+            <a:r>
+              <a:rPr lang="it-IT" dirty="0"/>
+              <a:t>Il class collapse su STATO e' il problema principale: il grafo e' identico per tutti i soggetti, quindi perde la topologia funzionale individuale.</a:t>
+            </a:r>
+            <a:endParaRPr lang="it-IT" dirty="0"/>
           </a:p>
         </p:txBody>
       </p:sp>
@@ -1393,10 +1638,45 @@
           <a:lstStyle/>
           <a:p>
             <a:r>
-              <a:rPr lang="en-US" dirty="0"/>
-              <a:t/>
-            </a:r>
-            <a:endParaRPr lang="en-US" dirty="0"/>
+              <a:rPr lang="it-IT" dirty="0"/>
+              <a:t>Il Gradient Reversal Layer (GRL) e' il cuore del meccanismo adversarial: nel forward pass il segnale passa invariato; nel backward pass il gradiente viene moltiplicato per -alpha.</a:t>
+            </a:r>
+            <a:endParaRPr lang="it-IT" dirty="0"/>
+          </a:p>
+          <a:p>
+            <a:r>
+              <a:rPr lang="it-IT" dirty="0"/>
+              <a:t>Questo crea un gioco minimax: il task classifier vuole minimizzare l'errore sulla parola; il subject discriminator vuole classificare il soggetto; il GRL forza l'encoder a massimizzare l'errore del discriminatore.</a:t>
+            </a:r>
+            <a:endParaRPr lang="it-IT" dirty="0"/>
+          </a:p>
+          <a:p>
+            <a:r>
+              <a:rPr lang="it-IT" dirty="0"/>
+              <a:t>Il risultato atteso e' un embedding h che non contiene informazione sull'identita' del soggetto -- subject-invariant.</a:t>
+            </a:r>
+            <a:endParaRPr lang="it-IT" dirty="0"/>
+          </a:p>
+          <a:p>
+            <a:r>
+              <a:rPr lang="it-IT" dirty="0"/>
+              <a:t>Il parametro alpha segue uno schedule DANN: alpha = 2/(1+exp(-10*p))-1 dove p e' la frazione di training completata. Cresce da 0 a 1, quindi all'inizio il GRL non agisce.</a:t>
+            </a:r>
+            <a:endParaRPr lang="it-IT" dirty="0"/>
+          </a:p>
+          <a:p>
+            <a:r>
+              <a:rPr lang="it-IT" dirty="0"/>
+              <a:t>Il problema della v1 (patience=15): il training si fermava all'epoch ~19 con alpha~0.38 -- il GRL non aveva ancora sufficiente forza per riorganizzare le rappresentazioni.</a:t>
+            </a:r>
+            <a:endParaRPr lang="it-IT" dirty="0"/>
+          </a:p>
+          <a:p>
+            <a:r>
+              <a:rPr lang="it-IT" dirty="0"/>
+              <a:t>La v2 (patience=40, lambda=0.5) ha dato al GRL tutto il tempo necessario: alpha verso 1.0, ma il risultato non e' migliorato. Diagnosi: il segnale semantico (eps2=0.03) non e' abbastanza forte nemmeno con domain adaptation.</a:t>
+            </a:r>
+            <a:endParaRPr lang="it-IT" dirty="0"/>
           </a:p>
         </p:txBody>
       </p:sp>
@@ -1481,10 +1761,38 @@
           <a:lstStyle/>
           <a:p>
             <a:r>
-              <a:rPr lang="en-US" dirty="0"/>
-              <a:t/>
-            </a:r>
-            <a:endParaRPr lang="en-US" dirty="0"/>
+              <a:rPr lang="it-IT" dirty="0"/>
+              <a:t>Questo confronto e' fondamentale per contestualizzare i risultati: il problema e' aperto in letteratura.</a:t>
+            </a:r>
+            <a:endParaRPr lang="it-IT" dirty="0"/>
+          </a:p>
+          <a:p>
+            <a:r>
+              <a:rPr lang="it-IT" dirty="0"/>
+              <a:t>FAST (Jiang 2025) e' il lavoro piu simile al nostro: 57 soggetti, 5 classi, strict LOSO, end-to-end -- ottiene solo +6.9% su chance (26.9% con chance=20%).</a:t>
+            </a:r>
+            <a:endParaRPr lang="it-IT" dirty="0"/>
+          </a:p>
+          <a:p>
+            <a:r>
+              <a:rPr lang="it-IT" dirty="0"/>
+              <a:t>MRF-EEGNet (Ko 2025) raggiunge 67% ma su task binario con solo 6 soggetti -- non comparabile con il nostro setting.</a:t>
+            </a:r>
+            <a:endParaRPr lang="it-IT" dirty="0"/>
+          </a:p>
+          <a:p>
+            <a:r>
+              <a:rPr lang="it-IT" dirty="0"/>
+              <a:t>DHSLP (Li 2025) usa feature engineering e valutazione subject-dependent -- 78% ma con condizioni molto piu' favorevoli.</a:t>
+            </a:r>
+            <a:endParaRPr lang="it-IT" dirty="0"/>
+          </a:p>
+          <a:p>
+            <a:r>
+              <a:rPr lang="it-IT" dirty="0"/>
+              <a:t>Il punto chiave da comunicare: i paper con alta accuracy non usano strict cross-subject end-to-end su dataset grandi. Il nostro setting e' piu' rigoroso.</a:t>
+            </a:r>
+            <a:endParaRPr lang="it-IT" dirty="0"/>
           </a:p>
         </p:txBody>
       </p:sp>
@@ -1569,10 +1877,38 @@
           <a:lstStyle/>
           <a:p>
             <a:r>
-              <a:rPr lang="en-US" dirty="0"/>
-              <a:t/>
-            </a:r>
-            <a:endParaRPr lang="en-US" dirty="0"/>
+              <a:rPr lang="it-IT" dirty="0"/>
+              <a:t>Queste 3 cause sono indipendenti e cumulative: anche risolverne una non garantisce il successo.</a:t>
+            </a:r>
+            <a:endParaRPr lang="it-IT" dirty="0"/>
+          </a:p>
+          <a:p>
+            <a:r>
+              <a:rPr lang="it-IT" dirty="0"/>
+              <a:t>Causa 1 (segnale debole): il fatto che train_acc max sia 0.32 e' la prova piu' forte -- il modello non riesce a fittare nemmeno il training set, quindi non e' un problema di generalizzazione.</a:t>
+            </a:r>
+            <a:endParaRPr lang="it-IT" dirty="0"/>
+          </a:p>
+          <a:p>
+            <a:r>
+              <a:rPr lang="it-IT" dirty="0"/>
+              <a:t>Causa 2 (grafo statico): il grafo PCC e' calcolato una volta sulla media di tutti i soggetti di training -- non cattura la topologia funzionale individuale che cambia da soggetto a soggetto.</a:t>
+            </a:r>
+            <a:endParaRPr lang="it-IT" dirty="0"/>
+          </a:p>
+          <a:p>
+            <a:r>
+              <a:rPr lang="it-IT" dirty="0"/>
+              <a:t>Causa 3 (limite dati): Bomatter 2025 dimostra empiricamente che con meno di 200 soggetti la generalizzazione cross-subject e' strutturalmente limitata. Con 70 soggetti siamo sotto questa soglia.</a:t>
+            </a:r>
+            <a:endParaRPr lang="it-IT" dirty="0"/>
+          </a:p>
+          <a:p>
+            <a:r>
+              <a:rPr lang="it-IT" dirty="0"/>
+              <a:t>Domanda probabile: "Cosa faresti con piu' soggetti?" -- Il dataset attuale ha 70 soggetti, che e' gia' eccezionalmente grande per imagined speech. Non e' possibile acquisirne altri nel contesto della tesi.</a:t>
+            </a:r>
+            <a:endParaRPr lang="it-IT" dirty="0"/>
           </a:p>
         </p:txBody>
       </p:sp>
@@ -3555,7 +3891,7 @@
               <a:buNone/>
             </a:pPr>
             <a:r>
-              <a:rPr lang="en-US" sz="1000" i="1" dirty="0">
+              <a:rPr lang="en-US" sz="1100" i="1" dirty="0">
                 <a:solidFill>
                   <a:srgbClr val="1E2761"/>
                 </a:solidFill>
@@ -3565,7 +3901,7 @@
               </a:rPr>
               <a:t>DHSLP (Li et al. 2025): 78% su imagined speech con hypergraph — dimostra che ordine superiore cattura qualcosa che i grafi classici non vedono</a:t>
             </a:r>
-            <a:endParaRPr lang="en-US" sz="1000" dirty="0"/>
+            <a:endParaRPr lang="en-US" sz="1100" dirty="0"/>
           </a:p>
         </p:txBody>
       </p:sp>
@@ -5304,8 +5640,8 @@
         </p:nvSpPr>
         <p:spPr>
           <a:xfrm>
-            <a:off x="457200" y="1463040"/>
-            <a:ext cx="3657600" cy="1005840"/>
+            <a:off x="457200" y="1390000"/>
+            <a:ext cx="3657600" cy="580000"/>
           </a:xfrm>
           <a:prstGeom prst="rect">
             <a:avLst/>
@@ -5314,7 +5650,7 @@
           <a:ln/>
         </p:spPr>
         <p:txBody>
-          <a:bodyPr wrap="square" rtlCol="0" anchor="ctr"/>
+          <a:bodyPr wrap="square" rtlCol="0" anchor="t"/>
           <a:lstStyle/>
           <a:p>
             <a:pPr indent="0" marL="0">
@@ -8453,7 +8789,7 @@
                 <a:ea typeface="Calibri" pitchFamily="34" charset="-122"/>
                 <a:cs typeface="Calibri" pitchFamily="34" charset="-120"/>
               </a:rPr>
-              <a:t>Temporal Encoder</a:t>
+              <a:t>Temporal Encoder (contributo originale)</a:t>
             </a:r>
             <a:endParaRPr lang="en-US" sz="1100" dirty="0"/>
           </a:p>
@@ -8470,7 +8806,24 @@
                 <a:ea typeface="Calibri" pitchFamily="34" charset="-122"/>
                 <a:cs typeface="Calibri" pitchFamily="34" charset="-120"/>
               </a:rPr>
-              <a:t>1D CNN per-nodo → 64-dim</a:t>
+              <a:t>1D CNN pesi condivisi, per-nodo</a:t>
+            </a:r>
+            <a:endParaRPr lang="en-US" sz="1100" dirty="0"/>
+          </a:p>
+          <a:p>
+            <a:pPr algn="ctr" indent="0" marL="0">
+              <a:buNone/>
+            </a:pPr>
+            <a:r>
+              <a:rPr lang="en-US" sz="1100" b="1" dirty="0">
+                <a:solidFill>
+                  <a:srgbClr val="FFFFFF"/>
+                </a:solidFill>
+                <a:latin typeface="Calibri" pitchFamily="34" charset="0"/>
+                <a:ea typeface="Calibri" pitchFamily="34" charset="-122"/>
+                <a:cs typeface="Calibri" pitchFamily="34" charset="-120"/>
+              </a:rPr>
+              <a:t>(1, 384) → Conv1d → Pool → 64-dim</a:t>
             </a:r>
             <a:endParaRPr lang="en-US" sz="1100" dirty="0"/>
           </a:p>
@@ -9527,7 +9880,7 @@
                 <a:ea typeface="Calibri" pitchFamily="34" charset="-122"/>
                 <a:cs typeface="Calibri" pitchFamily="34" charset="-120"/>
               </a:rPr>
-              <a:t>⚠ Class collapse su STATO (~68% predizioni)</a:t>
+              <a:t>⚠ Class collapse su STATO (~68% predizioni) — grafo statico identico per tutti i soggetti</a:t>
             </a:r>
             <a:endParaRPr lang="en-US" sz="1200" dirty="0"/>
           </a:p>
@@ -9558,7 +9911,7 @@
               <a:buNone/>
             </a:pPr>
             <a:r>
-              <a:rPr lang="en-US" sz="1000" i="1" dirty="0">
+              <a:rPr lang="en-US" sz="1100" i="1" dirty="0">
                 <a:solidFill>
                   <a:srgbClr val="8899AA"/>
                 </a:solidFill>
@@ -9566,9 +9919,9 @@
                 <a:ea typeface="Calibri" pitchFamily="34" charset="-122"/>
                 <a:cs typeface="Calibri" pitchFamily="34" charset="-120"/>
               </a:rPr>
-              <a:t>Riferimento: Lun et al. 2022 — GCNs-Net (Temporal GCN per EEG)</a:t>
-            </a:r>
-            <a:endParaRPr lang="en-US" sz="1000" dirty="0"/>
+              <a:t>Riferimento: Lun et al. 2022 — GCNs-Net | Contributo originale: Temporal Encoder 1D CNN con pesi condivisi tra i 59 canali — a differenza di GCNs-Net (time-resolved), qui ogni canale produce un embedding statico 64-dim che il GCN poi aggrega sul grafo PCC</a:t>
+            </a:r>
+            <a:endParaRPr lang="en-US" sz="1100" dirty="0"/>
           </a:p>
         </p:txBody>
       </p:sp>
@@ -10236,6 +10589,57 @@
                 <a:ea typeface="Calibri" pitchFamily="34" charset="-122"/>
                 <a:cs typeface="Calibri" pitchFamily="34" charset="-120"/>
               </a:rPr>
+              <a:t>Forward: segnale invariato</a:t>
+            </a:r>
+            <a:endParaRPr lang="en-US" sz="900" dirty="0"/>
+          </a:p>
+          <a:p>
+            <a:pPr algn="ctr" indent="0" marL="0">
+              <a:buNone/>
+            </a:pPr>
+            <a:r>
+              <a:rPr lang="en-US" sz="900" dirty="0">
+                <a:solidFill>
+                  <a:srgbClr val="FFFFFF"/>
+                </a:solidFill>
+                <a:latin typeface="Calibri" pitchFamily="34" charset="0"/>
+                <a:ea typeface="Calibri" pitchFamily="34" charset="-122"/>
+                <a:cs typeface="Calibri" pitchFamily="34" charset="-120"/>
+              </a:rPr>
+              <a:t>Backward: grad × (−α)</a:t>
+            </a:r>
+            <a:endParaRPr lang="en-US" sz="900" dirty="0"/>
+          </a:p>
+          <a:p>
+            <a:pPr algn="ctr" indent="0" marL="0">
+              <a:buNone/>
+            </a:pPr>
+            <a:r>
+              <a:rPr lang="en-US" sz="900" dirty="0">
+                <a:solidFill>
+                  <a:srgbClr val="FFFFFF"/>
+                </a:solidFill>
+                <a:latin typeface="Calibri" pitchFamily="34" charset="0"/>
+                <a:ea typeface="Calibri" pitchFamily="34" charset="-122"/>
+                <a:cs typeface="Calibri" pitchFamily="34" charset="-120"/>
+              </a:rPr>
+              <a:t>→ encoder inganna il discriminatore</a:t>
+            </a:r>
+            <a:endParaRPr lang="en-US" sz="900" dirty="0"/>
+          </a:p>
+          <a:p>
+            <a:pPr algn="ctr" indent="0" marL="0">
+              <a:buNone/>
+            </a:pPr>
+            <a:r>
+              <a:rPr lang="en-US" sz="900" dirty="0">
+                <a:solidFill>
+                  <a:srgbClr val="FFFFFF"/>
+                </a:solidFill>
+                <a:latin typeface="Calibri" pitchFamily="34" charset="0"/>
+                <a:ea typeface="Calibri" pitchFamily="34" charset="-122"/>
+                <a:cs typeface="Calibri" pitchFamily="34" charset="-120"/>
+              </a:rPr>
               <a:t>50 soggetti — L_subj</a:t>
             </a:r>
             <a:endParaRPr lang="en-US" sz="900" dirty="0"/>
@@ -10300,7 +10704,24 @@
                 <a:ea typeface="Calibri" pitchFamily="34" charset="-122"/>
                 <a:cs typeface="Calibri" pitchFamily="34" charset="-120"/>
               </a:rPr>
-              <a:t>Loss = L_task + λ·L_subj</a:t>
+              <a:t>Loss totale = L_task + λ·L_subj (λ=0.5)</a:t>
+            </a:r>
+            <a:endParaRPr lang="en-US" sz="1100" dirty="0"/>
+          </a:p>
+          <a:p>
+            <a:pPr algn="ctr" indent="0" marL="0">
+              <a:buNone/>
+            </a:pPr>
+            <a:r>
+              <a:rPr lang="en-US" sz="1100" b="1" dirty="0">
+                <a:solidFill>
+                  <a:srgbClr val="CADCFC"/>
+                </a:solidFill>
+                <a:latin typeface="Calibri" pitchFamily="34" charset="0"/>
+                <a:ea typeface="Calibri" pitchFamily="34" charset="-122"/>
+                <a:cs typeface="Calibri" pitchFamily="34" charset="-120"/>
+              </a:rPr>
+              <a:t>α schedule: 0→1 durante il training</a:t>
             </a:r>
             <a:endParaRPr lang="en-US" sz="1100" dirty="0"/>
           </a:p>
@@ -11610,7 +12031,24 @@
                 <a:ea typeface="Calibri" pitchFamily="34" charset="-122"/>
                 <a:cs typeface="Calibri" pitchFamily="34" charset="-120"/>
               </a:rPr>
-              <a:t>⚠ train_acc max 0.32 — underfitting semantico</a:t>
+              <a:t>⚠ train_acc max 0.32 — underfitting semantico (nessun gap train/val)</a:t>
+            </a:r>
+            <a:endParaRPr lang="en-US" sz="1100" dirty="0"/>
+          </a:p>
+          <a:p>
+            <a:pPr indent="0" marL="0">
+              <a:buNone/>
+            </a:pPr>
+            <a:r>
+              <a:rPr lang="en-US" sz="1100" dirty="0">
+                <a:solidFill>
+                  <a:srgbClr val="8A6D3B"/>
+                </a:solidFill>
+                <a:latin typeface="Calibri" pitchFamily="34" charset="0"/>
+                <a:ea typeface="Calibri" pitchFamily="34" charset="-122"/>
+                <a:cs typeface="Calibri" pitchFamily="34" charset="-120"/>
+              </a:rPr>
+              <a:t>v1: patience=15 → alpha≈0.38, GRL non efficace | v2: patience=40 → alpha→1.0, stesso risultato</a:t>
             </a:r>
             <a:endParaRPr lang="en-US" sz="1100" dirty="0"/>
           </a:p>
@@ -11735,7 +12173,7 @@
             <a:tbl>
               <a:tblPr/>
               <a:tblGrid>
-                <a:gridCol w="2103120"/>
+                <a:gridCol w="1920240"/>
                 <a:gridCol w="548640"/>
                 <a:gridCol w="548640"/>
                 <a:gridCol w="640080"/>
@@ -11743,7 +12181,7 @@
                 <a:gridCol w="1097280"/>
                 <a:gridCol w="731520"/>
                 <a:gridCol w="731520"/>
-                <a:gridCol w="548640"/>
+                <a:gridCol w="731520"/>
               </a:tblGrid>
               <a:tr h="594360">
                 <a:tc>

</xml_diff>

<commit_message>
docs: redesign slide 7 — architettura adversarial con layout verticale chiaro
- Slide 7 completamente ridisegnata: flusso verticale esplicito
  Input → Temporal Encoder → GATConv(8h)×2 → Embedding h
  poi split ↙↘ in Task Classifier (verde) | GRL→Subject Disc. (rosso)
  poi merge ↗↖ in Loss formula
- Pannello GRL separato con spiegazione forward/backward/alpha schedule
- Tabella risultati con colonne allineate + warning box diagnosi v1/v2

Co-Authored-By: Claude Sonnet 4.6 <noreply@anthropic.com>
</commit_message>
<xml_diff>
--- a/docs/presentation_stato_lavori_apr2026.pptx
+++ b/docs/presentation_stato_lavori_apr2026.pptx
@@ -10023,20 +10023,964 @@
       </p:sp>
       <p:sp>
         <p:nvSpPr>
-          <p:cNvPr id="4" name="Shape 2"/>
-          <p:cNvSpPr/>
-          <p:nvPr/>
-        </p:nvSpPr>
-        <p:spPr>
-          <a:xfrm>
-            <a:off x="457200" y="960120"/>
-            <a:ext cx="1097280" cy="457200"/>
+          <p:cNvPr id="10" name="BgInput"/>
+          <p:cNvSpPr/>
+          <p:nvPr/>
+        </p:nvSpPr>
+        <p:spPr>
+          <a:xfrm>
+            <a:off x="320000" y="780000"/>
+            <a:ext cx="3700000" cy="360000"/>
           </a:xfrm>
           <a:prstGeom prst="rect">
             <a:avLst/>
           </a:prstGeom>
           <a:solidFill>
             <a:srgbClr val="1E2761"/>
+          </a:solidFill>
+          <a:ln w="25400">
+            <a:solidFill>
+              <a:srgbClr val="CADCFC"/>
+            </a:solidFill>
+            <a:prstDash val="solid"/>
+          </a:ln>
+        </p:spPr>
+      </p:sp>
+      <p:sp>
+        <p:nvSpPr>
+          <p:cNvPr id="11" name="TxtInput"/>
+          <p:cNvSpPr/>
+          <p:nvPr/>
+        </p:nvSpPr>
+        <p:spPr>
+          <a:xfrm>
+            <a:off x="320000" y="780000"/>
+            <a:ext cx="3700000" cy="360000"/>
+          </a:xfrm>
+          <a:prstGeom prst="rect">
+            <a:avLst/>
+          </a:prstGeom>
+          <a:noFill/>
+          <a:ln/>
+        </p:spPr>
+        <p:txBody>
+          <a:bodyPr wrap="square" rtlCol="0" anchor="ctr"/>
+          <a:lstStyle/>
+          <a:p>
+            <a:pPr algn="ctr" indent="0" marL="0">
+              <a:buNone/>
+            </a:pPr>
+            <a:r>
+              <a:rPr lang="it-IT" sz="1300" b="1" dirty="0">
+                <a:solidFill>
+                  <a:srgbClr val="FFFFFF"/>
+                </a:solidFill>
+                <a:latin typeface="Calibri" pitchFamily="34" charset="0"/>
+              </a:rPr>
+              <a:t>Input — 59 nodi × 384 campioni</a:t>
+            </a:r>
+            <a:endParaRPr lang="it-IT" sz="1300" dirty="0"/>
+          </a:p>
+        </p:txBody>
+      </p:sp>
+      <p:sp>
+        <p:nvSpPr>
+          <p:cNvPr id="12" name="Arr1"/>
+          <p:cNvSpPr/>
+          <p:nvPr/>
+        </p:nvSpPr>
+        <p:spPr>
+          <a:xfrm>
+            <a:off x="2020000" y="1140000"/>
+            <a:ext cx="300000" cy="160000"/>
+          </a:xfrm>
+          <a:prstGeom prst="rect">
+            <a:avLst/>
+          </a:prstGeom>
+          <a:noFill/>
+          <a:ln/>
+        </p:spPr>
+        <p:txBody>
+          <a:bodyPr wrap="square" rtlCol="0" anchor="ctr"/>
+          <a:lstStyle/>
+          <a:p>
+            <a:pPr algn="ctr" indent="0" marL="0">
+              <a:buNone/>
+            </a:pPr>
+            <a:r>
+              <a:rPr lang="it-IT" sz="1600" dirty="0">
+                <a:solidFill>
+                  <a:srgbClr val="1E2761"/>
+                </a:solidFill>
+                <a:latin typeface="Calibri" pitchFamily="34" charset="0"/>
+              </a:rPr>
+              <a:t>↓</a:t>
+            </a:r>
+            <a:endParaRPr lang="it-IT" sz="1600" dirty="0"/>
+          </a:p>
+        </p:txBody>
+      </p:sp>
+      <p:sp>
+        <p:nvSpPr>
+          <p:cNvPr id="13" name="BgTempEnc"/>
+          <p:cNvSpPr/>
+          <p:nvPr/>
+        </p:nvSpPr>
+        <p:spPr>
+          <a:xfrm>
+            <a:off x="320000" y="1300000"/>
+            <a:ext cx="3700000" cy="420000"/>
+          </a:xfrm>
+          <a:prstGeom prst="rect">
+            <a:avLst/>
+          </a:prstGeom>
+          <a:solidFill>
+            <a:srgbClr val="2A5298"/>
+          </a:solidFill>
+          <a:ln w="25400">
+            <a:solidFill>
+              <a:srgbClr val="CADCFC"/>
+            </a:solidFill>
+            <a:prstDash val="solid"/>
+          </a:ln>
+        </p:spPr>
+      </p:sp>
+      <p:sp>
+        <p:nvSpPr>
+          <p:cNvPr id="14" name="TxtTempEnc"/>
+          <p:cNvSpPr/>
+          <p:nvPr/>
+        </p:nvSpPr>
+        <p:spPr>
+          <a:xfrm>
+            <a:off x="320000" y="1300000"/>
+            <a:ext cx="3700000" cy="420000"/>
+          </a:xfrm>
+          <a:prstGeom prst="rect">
+            <a:avLst/>
+          </a:prstGeom>
+          <a:noFill/>
+          <a:ln/>
+        </p:spPr>
+        <p:txBody>
+          <a:bodyPr wrap="square" rtlCol="0" anchor="ctr"/>
+          <a:lstStyle/>
+          <a:p>
+            <a:pPr algn="ctr" indent="0" marL="0">
+              <a:buNone/>
+            </a:pPr>
+            <a:r>
+              <a:rPr lang="it-IT" sz="1200" b="1" dirty="0">
+                <a:solidFill>
+                  <a:srgbClr val="FFFFFF"/>
+                </a:solidFill>
+                <a:latin typeface="Calibri" pitchFamily="34" charset="0"/>
+              </a:rPr>
+              <a:t>Temporal Encoder (contributo originale)</a:t>
+            </a:r>
+            <a:endParaRPr lang="it-IT" sz="1200" dirty="0"/>
+          </a:p>
+          <a:p>
+            <a:pPr algn="ctr" indent="0" marL="0">
+              <a:buNone/>
+            </a:pPr>
+            <a:r>
+              <a:rPr lang="it-IT" sz="1100" dirty="0">
+                <a:solidFill>
+                  <a:srgbClr val="CADCFC"/>
+                </a:solidFill>
+                <a:latin typeface="Calibri" pitchFamily="34" charset="0"/>
+              </a:rPr>
+              <a:t>1D CNN pesi condivisi — 384 camp. → emb. 64-dim per nodo</a:t>
+            </a:r>
+            <a:endParaRPr lang="it-IT" sz="1100" dirty="0"/>
+          </a:p>
+        </p:txBody>
+      </p:sp>
+      <p:sp>
+        <p:nvSpPr>
+          <p:cNvPr id="15" name="Arr2"/>
+          <p:cNvSpPr/>
+          <p:nvPr/>
+        </p:nvSpPr>
+        <p:spPr>
+          <a:xfrm>
+            <a:off x="2020000" y="1720000"/>
+            <a:ext cx="300000" cy="160000"/>
+          </a:xfrm>
+          <a:prstGeom prst="rect">
+            <a:avLst/>
+          </a:prstGeom>
+          <a:noFill/>
+          <a:ln/>
+        </p:spPr>
+        <p:txBody>
+          <a:bodyPr wrap="square" rtlCol="0" anchor="ctr"/>
+          <a:lstStyle/>
+          <a:p>
+            <a:pPr algn="ctr" indent="0" marL="0">
+              <a:buNone/>
+            </a:pPr>
+            <a:r>
+              <a:rPr lang="it-IT" sz="1600" dirty="0">
+                <a:solidFill>
+                  <a:srgbClr val="1E2761"/>
+                </a:solidFill>
+                <a:latin typeface="Calibri" pitchFamily="34" charset="0"/>
+              </a:rPr>
+              <a:t>↓</a:t>
+            </a:r>
+            <a:endParaRPr lang="it-IT" sz="1600" dirty="0"/>
+          </a:p>
+        </p:txBody>
+      </p:sp>
+      <p:sp>
+        <p:nvSpPr>
+          <p:cNvPr id="16" name="BgGAT"/>
+          <p:cNvSpPr/>
+          <p:nvPr/>
+        </p:nvSpPr>
+        <p:spPr>
+          <a:xfrm>
+            <a:off x="320000" y="1880000"/>
+            <a:ext cx="3700000" cy="360000"/>
+          </a:xfrm>
+          <a:prstGeom prst="rect">
+            <a:avLst/>
+          </a:prstGeom>
+          <a:solidFill>
+            <a:srgbClr val="1A9688"/>
+          </a:solidFill>
+          <a:ln w="25400">
+            <a:solidFill>
+              <a:srgbClr val="CADCFC"/>
+            </a:solidFill>
+            <a:prstDash val="solid"/>
+          </a:ln>
+        </p:spPr>
+      </p:sp>
+      <p:sp>
+        <p:nvSpPr>
+          <p:cNvPr id="17" name="TxtGAT"/>
+          <p:cNvSpPr/>
+          <p:nvPr/>
+        </p:nvSpPr>
+        <p:spPr>
+          <a:xfrm>
+            <a:off x="320000" y="1880000"/>
+            <a:ext cx="3700000" cy="360000"/>
+          </a:xfrm>
+          <a:prstGeom prst="rect">
+            <a:avLst/>
+          </a:prstGeom>
+          <a:noFill/>
+          <a:ln/>
+        </p:spPr>
+        <p:txBody>
+          <a:bodyPr wrap="square" rtlCol="0" anchor="ctr"/>
+          <a:lstStyle/>
+          <a:p>
+            <a:pPr algn="ctr" indent="0" marL="0">
+              <a:buNone/>
+            </a:pPr>
+            <a:r>
+              <a:rPr lang="it-IT" sz="1200" b="1" dirty="0">
+                <a:solidFill>
+                  <a:srgbClr val="FFFFFF"/>
+                </a:solidFill>
+                <a:latin typeface="Calibri" pitchFamily="34" charset="0"/>
+              </a:rPr>
+              <a:t>GATConv (8 head) × 2 — attention dinamica sui vicini</a:t>
+            </a:r>
+            <a:endParaRPr lang="it-IT" sz="1200" dirty="0"/>
+          </a:p>
+        </p:txBody>
+      </p:sp>
+      <p:sp>
+        <p:nvSpPr>
+          <p:cNvPr id="18" name="Arr3"/>
+          <p:cNvSpPr/>
+          <p:nvPr/>
+        </p:nvSpPr>
+        <p:spPr>
+          <a:xfrm>
+            <a:off x="2020000" y="2240000"/>
+            <a:ext cx="300000" cy="160000"/>
+          </a:xfrm>
+          <a:prstGeom prst="rect">
+            <a:avLst/>
+          </a:prstGeom>
+          <a:noFill/>
+          <a:ln/>
+        </p:spPr>
+        <p:txBody>
+          <a:bodyPr wrap="square" rtlCol="0" anchor="ctr"/>
+          <a:lstStyle/>
+          <a:p>
+            <a:pPr algn="ctr" indent="0" marL="0">
+              <a:buNone/>
+            </a:pPr>
+            <a:r>
+              <a:rPr lang="it-IT" sz="1600" dirty="0">
+                <a:solidFill>
+                  <a:srgbClr val="1E2761"/>
+                </a:solidFill>
+                <a:latin typeface="Calibri" pitchFamily="34" charset="0"/>
+              </a:rPr>
+              <a:t>↓</a:t>
+            </a:r>
+            <a:endParaRPr lang="it-IT" sz="1600" dirty="0"/>
+          </a:p>
+        </p:txBody>
+      </p:sp>
+      <p:sp>
+        <p:nvSpPr>
+          <p:cNvPr id="19" name="BgEmb"/>
+          <p:cNvSpPr/>
+          <p:nvPr/>
+        </p:nvSpPr>
+        <p:spPr>
+          <a:xfrm>
+            <a:off x="320000" y="2400000"/>
+            <a:ext cx="3700000" cy="360000"/>
+          </a:xfrm>
+          <a:prstGeom prst="rect">
+            <a:avLst/>
+          </a:prstGeom>
+          <a:solidFill>
+            <a:srgbClr val="1E2761"/>
+          </a:solidFill>
+          <a:ln w="25400">
+            <a:solidFill>
+              <a:srgbClr val="CADCFC"/>
+            </a:solidFill>
+            <a:prstDash val="solid"/>
+          </a:ln>
+        </p:spPr>
+      </p:sp>
+      <p:sp>
+        <p:nvSpPr>
+          <p:cNvPr id="20" name="TxtEmb"/>
+          <p:cNvSpPr/>
+          <p:nvPr/>
+        </p:nvSpPr>
+        <p:spPr>
+          <a:xfrm>
+            <a:off x="320000" y="2400000"/>
+            <a:ext cx="3700000" cy="360000"/>
+          </a:xfrm>
+          <a:prstGeom prst="rect">
+            <a:avLst/>
+          </a:prstGeom>
+          <a:noFill/>
+          <a:ln/>
+        </p:spPr>
+        <p:txBody>
+          <a:bodyPr wrap="square" rtlCol="0" anchor="ctr"/>
+          <a:lstStyle/>
+          <a:p>
+            <a:pPr algn="ctr" indent="0" marL="0">
+              <a:buNone/>
+            </a:pPr>
+            <a:r>
+              <a:rPr lang="it-IT" sz="1300" b="1" dirty="0">
+                <a:solidFill>
+                  <a:srgbClr val="FFFFFF"/>
+                </a:solidFill>
+                <a:latin typeface="Calibri" pitchFamily="34" charset="0"/>
+              </a:rPr>
+              <a:t>Global Mean Pool  →  Embedding h</a:t>
+            </a:r>
+            <a:endParaRPr lang="it-IT" sz="1300" dirty="0"/>
+          </a:p>
+        </p:txBody>
+      </p:sp>
+      <p:sp>
+        <p:nvSpPr>
+          <p:cNvPr id="21" name="ArrSplit"/>
+          <p:cNvSpPr/>
+          <p:nvPr/>
+        </p:nvSpPr>
+        <p:spPr>
+          <a:xfrm>
+            <a:off x="320000" y="2760000"/>
+            <a:ext cx="3700000" cy="200000"/>
+          </a:xfrm>
+          <a:prstGeom prst="rect">
+            <a:avLst/>
+          </a:prstGeom>
+          <a:noFill/>
+          <a:ln/>
+        </p:spPr>
+        <p:txBody>
+          <a:bodyPr wrap="square" rtlCol="0" anchor="ctr"/>
+          <a:lstStyle/>
+          <a:p>
+            <a:pPr algn="ctr" indent="0" marL="0">
+              <a:buNone/>
+            </a:pPr>
+            <a:r>
+              <a:rPr lang="it-IT" sz="1300" dirty="0">
+                <a:solidFill>
+                  <a:srgbClr val="1E2761"/>
+                </a:solidFill>
+                <a:latin typeface="Calibri" pitchFamily="34" charset="0"/>
+              </a:rPr>
+              <a:t>↙   (h si divide)   ↘</a:t>
+            </a:r>
+            <a:endParaRPr lang="it-IT" sz="1300" dirty="0"/>
+          </a:p>
+        </p:txBody>
+      </p:sp>
+      <p:sp>
+        <p:nvSpPr>
+          <p:cNvPr id="22" name="BgTask"/>
+          <p:cNvSpPr/>
+          <p:nvPr/>
+        </p:nvSpPr>
+        <p:spPr>
+          <a:xfrm>
+            <a:off x="320000" y="2960000"/>
+            <a:ext cx="1790000" cy="420000"/>
+          </a:xfrm>
+          <a:prstGeom prst="rect">
+            <a:avLst/>
+          </a:prstGeom>
+          <a:solidFill>
+            <a:srgbClr val="1E7E34"/>
+          </a:solidFill>
+          <a:ln w="25400">
+            <a:solidFill>
+              <a:srgbClr val="27AE60"/>
+            </a:solidFill>
+            <a:prstDash val="solid"/>
+          </a:ln>
+        </p:spPr>
+      </p:sp>
+      <p:sp>
+        <p:nvSpPr>
+          <p:cNvPr id="23" name="TxtTask"/>
+          <p:cNvSpPr/>
+          <p:nvPr/>
+        </p:nvSpPr>
+        <p:spPr>
+          <a:xfrm>
+            <a:off x="320000" y="2960000"/>
+            <a:ext cx="1790000" cy="420000"/>
+          </a:xfrm>
+          <a:prstGeom prst="rect">
+            <a:avLst/>
+          </a:prstGeom>
+          <a:noFill/>
+          <a:ln/>
+        </p:spPr>
+        <p:txBody>
+          <a:bodyPr wrap="square" rtlCol="0" anchor="ctr"/>
+          <a:lstStyle/>
+          <a:p>
+            <a:pPr algn="ctr" indent="0" marL="0">
+              <a:buNone/>
+            </a:pPr>
+            <a:r>
+              <a:rPr lang="it-IT" sz="1200" b="1" dirty="0">
+                <a:solidFill>
+                  <a:srgbClr val="FFFFFF"/>
+                </a:solidFill>
+                <a:latin typeface="Calibri" pitchFamily="34" charset="0"/>
+              </a:rPr>
+              <a:t>Task Classifier</a:t>
+            </a:r>
+            <a:endParaRPr lang="it-IT" sz="1200" dirty="0"/>
+          </a:p>
+          <a:p>
+            <a:pPr algn="ctr" indent="0" marL="0">
+              <a:buNone/>
+            </a:pPr>
+            <a:r>
+              <a:rPr lang="it-IT" sz="1100" dirty="0">
+                <a:solidFill>
+                  <a:srgbClr val="FFFFFF"/>
+                </a:solidFill>
+                <a:latin typeface="Calibri" pitchFamily="34" charset="0"/>
+              </a:rPr>
+              <a:t>4 classi → L_task</a:t>
+            </a:r>
+            <a:endParaRPr lang="it-IT" sz="1100" dirty="0"/>
+          </a:p>
+        </p:txBody>
+      </p:sp>
+      <p:sp>
+        <p:nvSpPr>
+          <p:cNvPr id="24" name="BgGRL"/>
+          <p:cNvSpPr/>
+          <p:nvPr/>
+        </p:nvSpPr>
+        <p:spPr>
+          <a:xfrm>
+            <a:off x="2230000" y="2960000"/>
+            <a:ext cx="1790000" cy="420000"/>
+          </a:xfrm>
+          <a:prstGeom prst="rect">
+            <a:avLst/>
+          </a:prstGeom>
+          <a:solidFill>
+            <a:srgbClr val="A93226"/>
+          </a:solidFill>
+          <a:ln w="25400">
+            <a:solidFill>
+              <a:srgbClr val="E74C3C"/>
+            </a:solidFill>
+            <a:prstDash val="solid"/>
+          </a:ln>
+        </p:spPr>
+      </p:sp>
+      <p:sp>
+        <p:nvSpPr>
+          <p:cNvPr id="25" name="TxtGRL"/>
+          <p:cNvSpPr/>
+          <p:nvPr/>
+        </p:nvSpPr>
+        <p:spPr>
+          <a:xfrm>
+            <a:off x="2230000" y="2960000"/>
+            <a:ext cx="1790000" cy="420000"/>
+          </a:xfrm>
+          <a:prstGeom prst="rect">
+            <a:avLst/>
+          </a:prstGeom>
+          <a:noFill/>
+          <a:ln/>
+        </p:spPr>
+        <p:txBody>
+          <a:bodyPr wrap="square" rtlCol="0" anchor="ctr"/>
+          <a:lstStyle/>
+          <a:p>
+            <a:pPr algn="ctr" indent="0" marL="0">
+              <a:buNone/>
+            </a:pPr>
+            <a:r>
+              <a:rPr lang="it-IT" sz="1200" b="1" dirty="0">
+                <a:solidFill>
+                  <a:srgbClr val="FFFFFF"/>
+                </a:solidFill>
+                <a:latin typeface="Calibri" pitchFamily="34" charset="0"/>
+              </a:rPr>
+              <a:t>GRL(α) → Subject Disc.</a:t>
+            </a:r>
+            <a:endParaRPr lang="it-IT" sz="1200" dirty="0"/>
+          </a:p>
+          <a:p>
+            <a:pPr algn="ctr" indent="0" marL="0">
+              <a:buNone/>
+            </a:pPr>
+            <a:r>
+              <a:rPr lang="it-IT" sz="1100" dirty="0">
+                <a:solidFill>
+                  <a:srgbClr val="FFFFFF"/>
+                </a:solidFill>
+                <a:latin typeface="Calibri" pitchFamily="34" charset="0"/>
+              </a:rPr>
+              <a:t>50 soggetti → L_subj</a:t>
+            </a:r>
+            <a:endParaRPr lang="it-IT" sz="1100" dirty="0"/>
+          </a:p>
+        </p:txBody>
+      </p:sp>
+      <p:sp>
+        <p:nvSpPr>
+          <p:cNvPr id="26" name="ArrMerge"/>
+          <p:cNvSpPr/>
+          <p:nvPr/>
+        </p:nvSpPr>
+        <p:spPr>
+          <a:xfrm>
+            <a:off x="320000" y="3380000"/>
+            <a:ext cx="3700000" cy="200000"/>
+          </a:xfrm>
+          <a:prstGeom prst="rect">
+            <a:avLst/>
+          </a:prstGeom>
+          <a:noFill/>
+          <a:ln/>
+        </p:spPr>
+        <p:txBody>
+          <a:bodyPr wrap="square" rtlCol="0" anchor="ctr"/>
+          <a:lstStyle/>
+          <a:p>
+            <a:pPr algn="ctr" indent="0" marL="0">
+              <a:buNone/>
+            </a:pPr>
+            <a:r>
+              <a:rPr lang="it-IT" sz="1300" dirty="0">
+                <a:solidFill>
+                  <a:srgbClr val="1E2761"/>
+                </a:solidFill>
+                <a:latin typeface="Calibri" pitchFamily="34" charset="0"/>
+              </a:rPr>
+              <a:t>↘   (gradiente unificato)   ↙</a:t>
+            </a:r>
+            <a:endParaRPr lang="it-IT" sz="1300" dirty="0"/>
+          </a:p>
+        </p:txBody>
+      </p:sp>
+      <p:sp>
+        <p:nvSpPr>
+          <p:cNvPr id="27" name="BgLoss"/>
+          <p:cNvSpPr/>
+          <p:nvPr/>
+        </p:nvSpPr>
+        <p:spPr>
+          <a:xfrm>
+            <a:off x="320000" y="3580000"/>
+            <a:ext cx="3700000" cy="380000"/>
+          </a:xfrm>
+          <a:prstGeom prst="rect">
+            <a:avLst/>
+          </a:prstGeom>
+          <a:solidFill>
+            <a:srgbClr val="1E2761"/>
+          </a:solidFill>
+          <a:ln w="25400">
+            <a:solidFill>
+              <a:srgbClr val="CADCFC"/>
+            </a:solidFill>
+            <a:prstDash val="solid"/>
+          </a:ln>
+        </p:spPr>
+      </p:sp>
+      <p:sp>
+        <p:nvSpPr>
+          <p:cNvPr id="28" name="TxtLoss"/>
+          <p:cNvSpPr/>
+          <p:nvPr/>
+        </p:nvSpPr>
+        <p:spPr>
+          <a:xfrm>
+            <a:off x="320000" y="3580000"/>
+            <a:ext cx="3700000" cy="380000"/>
+          </a:xfrm>
+          <a:prstGeom prst="rect">
+            <a:avLst/>
+          </a:prstGeom>
+          <a:noFill/>
+          <a:ln/>
+        </p:spPr>
+        <p:txBody>
+          <a:bodyPr wrap="square" rtlCol="0" anchor="ctr"/>
+          <a:lstStyle/>
+          <a:p>
+            <a:pPr algn="ctr" indent="0" marL="0">
+              <a:buNone/>
+            </a:pPr>
+            <a:r>
+              <a:rPr lang="it-IT" sz="1200" b="1" dirty="0">
+                <a:solidFill>
+                  <a:srgbClr val="FFFFFF"/>
+                </a:solidFill>
+                <a:latin typeface="Calibri" pitchFamily="34" charset="0"/>
+              </a:rPr>
+              <a:t>Loss = L_task + λ·L_subj   (λ=0.5)</a:t>
+            </a:r>
+            <a:endParaRPr lang="it-IT" sz="1200" dirty="0"/>
+          </a:p>
+        </p:txBody>
+      </p:sp>
+      <p:sp>
+        <p:nvSpPr>
+          <p:cNvPr id="29" name="BgGRLNote"/>
+          <p:cNvSpPr/>
+          <p:nvPr/>
+        </p:nvSpPr>
+        <p:spPr>
+          <a:xfrm>
+            <a:off x="320000" y="4100000"/>
+            <a:ext cx="3700000" cy="620000"/>
+          </a:xfrm>
+          <a:prstGeom prst="rect">
+            <a:avLst/>
+          </a:prstGeom>
+          <a:solidFill>
+            <a:srgbClr val="E8F4FD"/>
+          </a:solidFill>
+          <a:ln w="25400">
+            <a:solidFill>
+              <a:srgbClr val="CADCFC"/>
+            </a:solidFill>
+            <a:prstDash val="solid"/>
+          </a:ln>
+        </p:spPr>
+      </p:sp>
+      <p:sp>
+        <p:nvSpPr>
+          <p:cNvPr id="30" name="TxtGRLNote"/>
+          <p:cNvSpPr/>
+          <p:nvPr/>
+        </p:nvSpPr>
+        <p:spPr>
+          <a:xfrm>
+            <a:off x="440000" y="4160000"/>
+            <a:ext cx="3460000" cy="500000"/>
+          </a:xfrm>
+          <a:prstGeom prst="rect">
+            <a:avLst/>
+          </a:prstGeom>
+          <a:noFill/>
+          <a:ln/>
+        </p:spPr>
+        <p:txBody>
+          <a:bodyPr wrap="square" rtlCol="0" anchor="t"/>
+          <a:lstStyle/>
+          <a:p>
+            <a:pPr algn="l" indent="0" marL="0">
+              <a:buNone/>
+            </a:pPr>
+            <a:r>
+              <a:rPr lang="it-IT" sz="1100" b="1" dirty="0">
+                <a:solidFill>
+                  <a:srgbClr val="1E2761"/>
+                </a:solidFill>
+                <a:latin typeface="Calibri" pitchFamily="34" charset="0"/>
+              </a:rPr>
+              <a:t>Come funziona il GRL:</a:t>
+            </a:r>
+            <a:endParaRPr lang="it-IT" sz="1100" dirty="0"/>
+          </a:p>
+          <a:p>
+            <a:pPr algn="l" indent="0" marL="0">
+              <a:buNone/>
+            </a:pPr>
+            <a:r>
+              <a:rPr lang="it-IT" sz="1050" dirty="0">
+                <a:solidFill>
+                  <a:srgbClr val="1E2761"/>
+                </a:solidFill>
+                <a:latin typeface="Calibri" pitchFamily="34" charset="0"/>
+              </a:rPr>
+              <a:t>→ Forward: segnale invariato (identità)</a:t>
+            </a:r>
+            <a:endParaRPr lang="it-IT" sz="1050" dirty="0"/>
+          </a:p>
+          <a:p>
+            <a:pPr algn="l" indent="0" marL="0">
+              <a:buNone/>
+            </a:pPr>
+            <a:r>
+              <a:rPr lang="it-IT" sz="1050" dirty="0">
+                <a:solidFill>
+                  <a:srgbClr val="1E2761"/>
+                </a:solidFill>
+                <a:latin typeface="Calibri" pitchFamily="34" charset="0"/>
+              </a:rPr>
+              <a:t>→ Backward: gradiente × (−α) — encoder impara a ingannare il discriminatore</a:t>
+            </a:r>
+            <a:endParaRPr lang="it-IT" sz="1050" dirty="0"/>
+          </a:p>
+          <a:p>
+            <a:pPr algn="l" indent="0" marL="0">
+              <a:buNone/>
+            </a:pPr>
+            <a:r>
+              <a:rPr lang="it-IT" sz="1050" dirty="0">
+                <a:solidFill>
+                  <a:srgbClr val="1E2761"/>
+                </a:solidFill>
+                <a:latin typeface="Calibri" pitchFamily="34" charset="0"/>
+              </a:rPr>
+              <a:t>→ α cresce 0→1 durante il training: GRL inizialmente inattivo, poi forza l'invarianza</a:t>
+            </a:r>
+            <a:endParaRPr lang="it-IT" sz="1050" dirty="0"/>
+          </a:p>
+        </p:txBody>
+      </p:sp>
+      <p:sp>
+        <p:nvSpPr>
+          <p:cNvPr id="31" name="TblHdr"/>
+          <p:cNvSpPr/>
+          <p:nvPr/>
+        </p:nvSpPr>
+        <p:spPr>
+          <a:xfrm>
+            <a:off x="4300000" y="780000"/>
+            <a:ext cx="4600000" cy="380000"/>
+          </a:xfrm>
+          <a:prstGeom prst="rect">
+            <a:avLst/>
+          </a:prstGeom>
+          <a:solidFill>
+            <a:srgbClr val="1E2761"/>
+          </a:solidFill>
+          <a:ln w="19050">
+            <a:solidFill>
+              <a:srgbClr val="1E2761"/>
+            </a:solidFill>
+            <a:prstDash val="solid"/>
+          </a:ln>
+        </p:spPr>
+      </p:sp>
+      <p:sp>
+        <p:nvSpPr>
+          <p:cNvPr id="200" name="TblHdrCol0"/>
+          <p:cNvSpPr/>
+          <p:nvPr/>
+        </p:nvSpPr>
+        <p:spPr>
+          <a:xfrm>
+            <a:off x="4380000" y="780000"/>
+            <a:ext cx="2020000" cy="380000"/>
+          </a:xfrm>
+          <a:prstGeom prst="rect">
+            <a:avLst/>
+          </a:prstGeom>
+          <a:noFill/>
+          <a:ln/>
+        </p:spPr>
+        <p:txBody>
+          <a:bodyPr wrap="square" rtlCol="0" anchor="ctr"/>
+          <a:lstStyle/>
+          <a:p>
+            <a:pPr algn="l" indent="0" marL="0">
+              <a:buNone/>
+            </a:pPr>
+            <a:r>
+              <a:rPr lang="it-IT" sz="1100" b="1" dirty="0">
+                <a:solidFill>
+                  <a:srgbClr val="FFFFFF"/>
+                </a:solidFill>
+                <a:latin typeface="Calibri" pitchFamily="34" charset="0"/>
+              </a:rPr>
+              <a:t>Modello</a:t>
+            </a:r>
+            <a:endParaRPr lang="it-IT" sz="1100" dirty="0"/>
+          </a:p>
+        </p:txBody>
+      </p:sp>
+      <p:sp>
+        <p:nvSpPr>
+          <p:cNvPr id="201" name="TblHdrCol1"/>
+          <p:cNvSpPr/>
+          <p:nvPr/>
+        </p:nvSpPr>
+        <p:spPr>
+          <a:xfrm>
+            <a:off x="6480000" y="780000"/>
+            <a:ext cx="370000" cy="380000"/>
+          </a:xfrm>
+          <a:prstGeom prst="rect">
+            <a:avLst/>
+          </a:prstGeom>
+          <a:noFill/>
+          <a:ln/>
+        </p:spPr>
+        <p:txBody>
+          <a:bodyPr wrap="square" rtlCol="0" anchor="ctr"/>
+          <a:lstStyle/>
+          <a:p>
+            <a:pPr algn="ctr" indent="0" marL="0">
+              <a:buNone/>
+            </a:pPr>
+            <a:r>
+              <a:rPr lang="it-IT" sz="1100" b="1" dirty="0">
+                <a:solidFill>
+                  <a:srgbClr val="FFFFFF"/>
+                </a:solidFill>
+                <a:latin typeface="Calibri" pitchFamily="34" charset="0"/>
+              </a:rPr>
+              <a:t>ADV</a:t>
+            </a:r>
+            <a:endParaRPr lang="it-IT" sz="1100" dirty="0"/>
+          </a:p>
+        </p:txBody>
+      </p:sp>
+      <p:sp>
+        <p:nvSpPr>
+          <p:cNvPr id="202" name="TblHdrCol2"/>
+          <p:cNvSpPr/>
+          <p:nvPr/>
+        </p:nvSpPr>
+        <p:spPr>
+          <a:xfrm>
+            <a:off x="6930000" y="780000"/>
+            <a:ext cx="1020000" cy="380000"/>
+          </a:xfrm>
+          <a:prstGeom prst="rect">
+            <a:avLst/>
+          </a:prstGeom>
+          <a:noFill/>
+          <a:ln/>
+        </p:spPr>
+        <p:txBody>
+          <a:bodyPr wrap="square" rtlCol="0" anchor="ctr"/>
+          <a:lstStyle/>
+          <a:p>
+            <a:pPr algn="ctr" indent="0" marL="0">
+              <a:buNone/>
+            </a:pPr>
+            <a:r>
+              <a:rPr lang="it-IT" sz="1100" b="1" dirty="0">
+                <a:solidFill>
+                  <a:srgbClr val="FFFFFF"/>
+                </a:solidFill>
+                <a:latin typeface="Calibri" pitchFamily="34" charset="0"/>
+              </a:rPr>
+              <a:t>test_bacc</a:t>
+            </a:r>
+            <a:endParaRPr lang="it-IT" sz="1100" dirty="0"/>
+          </a:p>
+        </p:txBody>
+      </p:sp>
+      <p:sp>
+        <p:nvSpPr>
+          <p:cNvPr id="203" name="TblHdrCol3"/>
+          <p:cNvSpPr/>
+          <p:nvPr/>
+        </p:nvSpPr>
+        <p:spPr>
+          <a:xfrm>
+            <a:off x="8030000" y="780000"/>
+            <a:ext cx="870000" cy="380000"/>
+          </a:xfrm>
+          <a:prstGeom prst="rect">
+            <a:avLst/>
+          </a:prstGeom>
+          <a:noFill/>
+          <a:ln/>
+        </p:spPr>
+        <p:txBody>
+          <a:bodyPr wrap="square" rtlCol="0" anchor="ctr"/>
+          <a:lstStyle/>
+          <a:p>
+            <a:pPr algn="ctr" indent="0" marL="0">
+              <a:buNone/>
+            </a:pPr>
+            <a:r>
+              <a:rPr lang="it-IT" sz="1100" b="1" dirty="0">
+                <a:solidFill>
+                  <a:srgbClr val="FFFFFF"/>
+                </a:solidFill>
+                <a:latin typeface="Calibri" pitchFamily="34" charset="0"/>
+              </a:rPr>
+              <a:t>epoche</a:t>
+            </a:r>
+            <a:endParaRPr lang="it-IT" sz="1100" dirty="0"/>
+          </a:p>
+        </p:txBody>
+      </p:sp>
+      <p:sp>
+        <p:nvSpPr>
+          <p:cNvPr id="33" name="TblRowBg0"/>
+          <p:cNvSpPr/>
+          <p:nvPr/>
+        </p:nvSpPr>
+        <p:spPr>
+          <a:xfrm>
+            <a:off x="4300000" y="1160000"/>
+            <a:ext cx="4600000" cy="380000"/>
+          </a:xfrm>
+          <a:prstGeom prst="rect">
+            <a:avLst/>
+          </a:prstGeom>
+          <a:solidFill>
+            <a:srgbClr val="FFFFFF"/>
           </a:solidFill>
           <a:ln w="12700">
             <a:solidFill>
@@ -10048,14 +10992,14 @@
       </p:sp>
       <p:sp>
         <p:nvSpPr>
-          <p:cNvPr id="5" name="Text 3"/>
-          <p:cNvSpPr/>
-          <p:nvPr/>
-        </p:nvSpPr>
-        <p:spPr>
-          <a:xfrm>
-            <a:off x="457200" y="960120"/>
-            <a:ext cx="1097280" cy="457200"/>
+          <p:cNvPr id="34" name="TblCell0_0"/>
+          <p:cNvSpPr/>
+          <p:nvPr/>
+        </p:nvSpPr>
+        <p:spPr>
+          <a:xfrm>
+            <a:off x="4380000" y="1160000"/>
+            <a:ext cx="2020000" cy="380000"/>
           </a:xfrm>
           <a:prstGeom prst="rect">
             <a:avLst/>
@@ -10067,34 +11011,32 @@
           <a:bodyPr wrap="square" rtlCol="0" anchor="ctr"/>
           <a:lstStyle/>
           <a:p>
-            <a:pPr algn="ctr" indent="0" marL="0">
+            <a:pPr algn="l" indent="0" marL="0">
               <a:buNone/>
             </a:pPr>
             <a:r>
-              <a:rPr lang="en-US" sz="900" b="1" dirty="0">
-                <a:solidFill>
-                  <a:srgbClr val="FFFFFF"/>
-                </a:solidFill>
-                <a:latin typeface="Calibri" pitchFamily="34" charset="0"/>
-                <a:ea typeface="Calibri" pitchFamily="34" charset="-122"/>
-                <a:cs typeface="Calibri" pitchFamily="34" charset="-120"/>
-              </a:rPr>
-              <a:t>Input</a:t>
-            </a:r>
-            <a:endParaRPr lang="en-US" sz="900" dirty="0"/>
+              <a:rPr lang="it-IT" sz="1100" dirty="0">
+                <a:solidFill>
+                  <a:srgbClr val="333333"/>
+                </a:solidFill>
+                <a:latin typeface="Calibri" pitchFamily="34" charset="0"/>
+              </a:rPr>
+              <a:t>GAT_2L</a:t>
+            </a:r>
+            <a:endParaRPr lang="it-IT" sz="1100" dirty="0"/>
           </a:p>
         </p:txBody>
       </p:sp>
       <p:sp>
         <p:nvSpPr>
-          <p:cNvPr id="6" name="Text 4"/>
-          <p:cNvSpPr/>
-          <p:nvPr/>
-        </p:nvSpPr>
-        <p:spPr>
-          <a:xfrm>
-            <a:off x="1554480" y="960120"/>
-            <a:ext cx="274320" cy="457200"/>
+          <p:cNvPr id="35" name="TblCell0_1"/>
+          <p:cNvSpPr/>
+          <p:nvPr/>
+        </p:nvSpPr>
+        <p:spPr>
+          <a:xfrm>
+            <a:off x="6480000" y="1160000"/>
+            <a:ext cx="370000" cy="380000"/>
           </a:xfrm>
           <a:prstGeom prst="rect">
             <a:avLst/>
@@ -10110,36 +11052,108 @@
               <a:buNone/>
             </a:pPr>
             <a:r>
-              <a:rPr lang="en-US" sz="1400" dirty="0">
-                <a:solidFill>
-                  <a:srgbClr val="1E2761"/>
-                </a:solidFill>
-                <a:latin typeface="Calibri" pitchFamily="34" charset="0"/>
-                <a:ea typeface="Calibri" pitchFamily="34" charset="-122"/>
-                <a:cs typeface="Calibri" pitchFamily="34" charset="-120"/>
-              </a:rPr>
-              <a:t>→</a:t>
-            </a:r>
-            <a:endParaRPr lang="en-US" sz="1400" dirty="0"/>
+              <a:rPr lang="it-IT" sz="1100" dirty="0">
+                <a:solidFill>
+                  <a:srgbClr val="333333"/>
+                </a:solidFill>
+                <a:latin typeface="Calibri" pitchFamily="34" charset="0"/>
+              </a:rPr>
+              <a:t>✗</a:t>
+            </a:r>
+            <a:endParaRPr lang="it-IT" sz="1100" dirty="0"/>
           </a:p>
         </p:txBody>
       </p:sp>
       <p:sp>
         <p:nvSpPr>
-          <p:cNvPr id="7" name="Shape 5"/>
-          <p:cNvSpPr/>
-          <p:nvPr/>
-        </p:nvSpPr>
-        <p:spPr>
-          <a:xfrm>
-            <a:off x="1645920" y="960120"/>
-            <a:ext cx="1097280" cy="457200"/>
+          <p:cNvPr id="36" name="TblCell0_2"/>
+          <p:cNvSpPr/>
+          <p:nvPr/>
+        </p:nvSpPr>
+        <p:spPr>
+          <a:xfrm>
+            <a:off x="6930000" y="1160000"/>
+            <a:ext cx="1020000" cy="380000"/>
+          </a:xfrm>
+          <a:prstGeom prst="rect">
+            <a:avLst/>
+          </a:prstGeom>
+          <a:noFill/>
+          <a:ln/>
+        </p:spPr>
+        <p:txBody>
+          <a:bodyPr wrap="square" rtlCol="0" anchor="ctr"/>
+          <a:lstStyle/>
+          <a:p>
+            <a:pPr algn="ctr" indent="0" marL="0">
+              <a:buNone/>
+            </a:pPr>
+            <a:r>
+              <a:rPr lang="it-IT" sz="1100" dirty="0">
+                <a:solidFill>
+                  <a:srgbClr val="333333"/>
+                </a:solidFill>
+                <a:latin typeface="Calibri" pitchFamily="34" charset="0"/>
+              </a:rPr>
+              <a:t>0.253</a:t>
+            </a:r>
+            <a:endParaRPr lang="it-IT" sz="1100" dirty="0"/>
+          </a:p>
+        </p:txBody>
+      </p:sp>
+      <p:sp>
+        <p:nvSpPr>
+          <p:cNvPr id="37" name="TblCell0_3"/>
+          <p:cNvSpPr/>
+          <p:nvPr/>
+        </p:nvSpPr>
+        <p:spPr>
+          <a:xfrm>
+            <a:off x="8030000" y="1160000"/>
+            <a:ext cx="870000" cy="380000"/>
+          </a:xfrm>
+          <a:prstGeom prst="rect">
+            <a:avLst/>
+          </a:prstGeom>
+          <a:noFill/>
+          <a:ln/>
+        </p:spPr>
+        <p:txBody>
+          <a:bodyPr wrap="square" rtlCol="0" anchor="ctr"/>
+          <a:lstStyle/>
+          <a:p>
+            <a:pPr algn="ctr" indent="0" marL="0">
+              <a:buNone/>
+            </a:pPr>
+            <a:r>
+              <a:rPr lang="it-IT" sz="1100" dirty="0">
+                <a:solidFill>
+                  <a:srgbClr val="333333"/>
+                </a:solidFill>
+                <a:latin typeface="Calibri" pitchFamily="34" charset="0"/>
+              </a:rPr>
+              <a:t>25</a:t>
+            </a:r>
+            <a:endParaRPr lang="it-IT" sz="1100" dirty="0"/>
+          </a:p>
+        </p:txBody>
+      </p:sp>
+      <p:sp>
+        <p:nvSpPr>
+          <p:cNvPr id="38" name="TblRowBg1"/>
+          <p:cNvSpPr/>
+          <p:nvPr/>
+        </p:nvSpPr>
+        <p:spPr>
+          <a:xfrm>
+            <a:off x="4300000" y="1540000"/>
+            <a:ext cx="4600000" cy="380000"/>
           </a:xfrm>
           <a:prstGeom prst="rect">
             <a:avLst/>
           </a:prstGeom>
           <a:solidFill>
-            <a:srgbClr val="1E2761"/>
+            <a:srgbClr val="EEF2FA"/>
           </a:solidFill>
           <a:ln w="12700">
             <a:solidFill>
@@ -10151,14 +11165,14 @@
       </p:sp>
       <p:sp>
         <p:nvSpPr>
-          <p:cNvPr id="8" name="Text 6"/>
-          <p:cNvSpPr/>
-          <p:nvPr/>
-        </p:nvSpPr>
-        <p:spPr>
-          <a:xfrm>
-            <a:off x="1645920" y="960120"/>
-            <a:ext cx="1097280" cy="457200"/>
+          <p:cNvPr id="39" name="TblCell1_0"/>
+          <p:cNvSpPr/>
+          <p:nvPr/>
+        </p:nvSpPr>
+        <p:spPr>
+          <a:xfrm>
+            <a:off x="4380000" y="1540000"/>
+            <a:ext cx="2020000" cy="380000"/>
           </a:xfrm>
           <a:prstGeom prst="rect">
             <a:avLst/>
@@ -10170,34 +11184,32 @@
           <a:bodyPr wrap="square" rtlCol="0" anchor="ctr"/>
           <a:lstStyle/>
           <a:p>
-            <a:pPr algn="ctr" indent="0" marL="0">
+            <a:pPr algn="l" indent="0" marL="0">
               <a:buNone/>
             </a:pPr>
             <a:r>
-              <a:rPr lang="en-US" sz="900" b="1" dirty="0">
-                <a:solidFill>
-                  <a:srgbClr val="FFFFFF"/>
-                </a:solidFill>
-                <a:latin typeface="Calibri" pitchFamily="34" charset="0"/>
-                <a:ea typeface="Calibri" pitchFamily="34" charset="-122"/>
-                <a:cs typeface="Calibri" pitchFamily="34" charset="-120"/>
-              </a:rPr>
-              <a:t>Temporal Encoder</a:t>
-            </a:r>
-            <a:endParaRPr lang="en-US" sz="900" dirty="0"/>
+              <a:rPr lang="it-IT" sz="1100" b="1" dirty="0">
+                <a:solidFill>
+                  <a:srgbClr val="333333"/>
+                </a:solidFill>
+                <a:latin typeface="Calibri" pitchFamily="34" charset="0"/>
+              </a:rPr>
+              <a:t>GAT_2L_ADV ★</a:t>
+            </a:r>
+            <a:endParaRPr lang="it-IT" sz="1100" dirty="0"/>
           </a:p>
         </p:txBody>
       </p:sp>
       <p:sp>
         <p:nvSpPr>
-          <p:cNvPr id="9" name="Text 7"/>
-          <p:cNvSpPr/>
-          <p:nvPr/>
-        </p:nvSpPr>
-        <p:spPr>
-          <a:xfrm>
-            <a:off x="2743200" y="960120"/>
-            <a:ext cx="274320" cy="457200"/>
+          <p:cNvPr id="40" name="TblCell1_1"/>
+          <p:cNvSpPr/>
+          <p:nvPr/>
+        </p:nvSpPr>
+        <p:spPr>
+          <a:xfrm>
+            <a:off x="6480000" y="1540000"/>
+            <a:ext cx="370000" cy="380000"/>
           </a:xfrm>
           <a:prstGeom prst="rect">
             <a:avLst/>
@@ -10213,36 +11225,108 @@
               <a:buNone/>
             </a:pPr>
             <a:r>
-              <a:rPr lang="en-US" sz="1400" dirty="0">
-                <a:solidFill>
-                  <a:srgbClr val="1E2761"/>
-                </a:solidFill>
-                <a:latin typeface="Calibri" pitchFamily="34" charset="0"/>
-                <a:ea typeface="Calibri" pitchFamily="34" charset="-122"/>
-                <a:cs typeface="Calibri" pitchFamily="34" charset="-120"/>
-              </a:rPr>
-              <a:t>→</a:t>
-            </a:r>
-            <a:endParaRPr lang="en-US" sz="1400" dirty="0"/>
+              <a:rPr lang="it-IT" sz="1100" dirty="0">
+                <a:solidFill>
+                  <a:srgbClr val="333333"/>
+                </a:solidFill>
+                <a:latin typeface="Calibri" pitchFamily="34" charset="0"/>
+              </a:rPr>
+              <a:t>✓</a:t>
+            </a:r>
+            <a:endParaRPr lang="it-IT" sz="1100" dirty="0"/>
           </a:p>
         </p:txBody>
       </p:sp>
       <p:sp>
         <p:nvSpPr>
-          <p:cNvPr id="10" name="Shape 8"/>
-          <p:cNvSpPr/>
-          <p:nvPr/>
-        </p:nvSpPr>
-        <p:spPr>
-          <a:xfrm>
-            <a:off x="3200400" y="960120"/>
-            <a:ext cx="1097280" cy="457200"/>
+          <p:cNvPr id="41" name="TblCell1_2"/>
+          <p:cNvSpPr/>
+          <p:nvPr/>
+        </p:nvSpPr>
+        <p:spPr>
+          <a:xfrm>
+            <a:off x="6930000" y="1540000"/>
+            <a:ext cx="1020000" cy="380000"/>
+          </a:xfrm>
+          <a:prstGeom prst="rect">
+            <a:avLst/>
+          </a:prstGeom>
+          <a:noFill/>
+          <a:ln/>
+        </p:spPr>
+        <p:txBody>
+          <a:bodyPr wrap="square" rtlCol="0" anchor="ctr"/>
+          <a:lstStyle/>
+          <a:p>
+            <a:pPr algn="ctr" indent="0" marL="0">
+              <a:buNone/>
+            </a:pPr>
+            <a:r>
+              <a:rPr lang="it-IT" sz="1100" dirty="0">
+                <a:solidFill>
+                  <a:srgbClr val="27AE60"/>
+                </a:solidFill>
+                <a:latin typeface="Calibri" pitchFamily="34" charset="0"/>
+              </a:rPr>
+              <a:t>0.254</a:t>
+            </a:r>
+            <a:endParaRPr lang="it-IT" sz="1100" dirty="0"/>
+          </a:p>
+        </p:txBody>
+      </p:sp>
+      <p:sp>
+        <p:nvSpPr>
+          <p:cNvPr id="42" name="TblCell1_3"/>
+          <p:cNvSpPr/>
+          <p:nvPr/>
+        </p:nvSpPr>
+        <p:spPr>
+          <a:xfrm>
+            <a:off x="8030000" y="1540000"/>
+            <a:ext cx="870000" cy="380000"/>
+          </a:xfrm>
+          <a:prstGeom prst="rect">
+            <a:avLst/>
+          </a:prstGeom>
+          <a:noFill/>
+          <a:ln/>
+        </p:spPr>
+        <p:txBody>
+          <a:bodyPr wrap="square" rtlCol="0" anchor="ctr"/>
+          <a:lstStyle/>
+          <a:p>
+            <a:pPr algn="ctr" indent="0" marL="0">
+              <a:buNone/>
+            </a:pPr>
+            <a:r>
+              <a:rPr lang="it-IT" sz="1100" dirty="0">
+                <a:solidFill>
+                  <a:srgbClr val="333333"/>
+                </a:solidFill>
+                <a:latin typeface="Calibri" pitchFamily="34" charset="0"/>
+              </a:rPr>
+              <a:t>45</a:t>
+            </a:r>
+            <a:endParaRPr lang="it-IT" sz="1100" dirty="0"/>
+          </a:p>
+        </p:txBody>
+      </p:sp>
+      <p:sp>
+        <p:nvSpPr>
+          <p:cNvPr id="43" name="TblRowBg2"/>
+          <p:cNvSpPr/>
+          <p:nvPr/>
+        </p:nvSpPr>
+        <p:spPr>
+          <a:xfrm>
+            <a:off x="4300000" y="1920000"/>
+            <a:ext cx="4600000" cy="380000"/>
           </a:xfrm>
           <a:prstGeom prst="rect">
             <a:avLst/>
           </a:prstGeom>
           <a:solidFill>
-            <a:srgbClr val="1E2761"/>
+            <a:srgbClr val="FFFFFF"/>
           </a:solidFill>
           <a:ln w="12700">
             <a:solidFill>
@@ -10254,14 +11338,14 @@
       </p:sp>
       <p:sp>
         <p:nvSpPr>
-          <p:cNvPr id="11" name="Text 9"/>
-          <p:cNvSpPr/>
-          <p:nvPr/>
-        </p:nvSpPr>
-        <p:spPr>
-          <a:xfrm>
-            <a:off x="3200400" y="960120"/>
-            <a:ext cx="1097280" cy="457200"/>
+          <p:cNvPr id="44" name="TblCell2_0"/>
+          <p:cNvSpPr/>
+          <p:nvPr/>
+        </p:nvSpPr>
+        <p:spPr>
+          <a:xfrm>
+            <a:off x="4380000" y="1920000"/>
+            <a:ext cx="2020000" cy="380000"/>
           </a:xfrm>
           <a:prstGeom prst="rect">
             <a:avLst/>
@@ -10273,34 +11357,32 @@
           <a:bodyPr wrap="square" rtlCol="0" anchor="ctr"/>
           <a:lstStyle/>
           <a:p>
-            <a:pPr algn="ctr" indent="0" marL="0">
+            <a:pPr algn="l" indent="0" marL="0">
               <a:buNone/>
             </a:pPr>
             <a:r>
-              <a:rPr lang="en-US" sz="900" b="1" dirty="0">
-                <a:solidFill>
-                  <a:srgbClr val="FFFFFF"/>
-                </a:solidFill>
-                <a:latin typeface="Calibri" pitchFamily="34" charset="0"/>
-                <a:ea typeface="Calibri" pitchFamily="34" charset="-122"/>
-                <a:cs typeface="Calibri" pitchFamily="34" charset="-120"/>
-              </a:rPr>
-              <a:t>GATConv 8-head × 2</a:t>
-            </a:r>
-            <a:endParaRPr lang="en-US" sz="900" dirty="0"/>
+              <a:rPr lang="it-IT" sz="1100" dirty="0">
+                <a:solidFill>
+                  <a:srgbClr val="333333"/>
+                </a:solidFill>
+                <a:latin typeface="Calibri" pitchFamily="34" charset="0"/>
+              </a:rPr>
+              <a:t>GAT_3L_ADV</a:t>
+            </a:r>
+            <a:endParaRPr lang="it-IT" sz="1100" dirty="0"/>
           </a:p>
         </p:txBody>
       </p:sp>
       <p:sp>
         <p:nvSpPr>
-          <p:cNvPr id="12" name="Text 10"/>
-          <p:cNvSpPr/>
-          <p:nvPr/>
-        </p:nvSpPr>
-        <p:spPr>
-          <a:xfrm>
-            <a:off x="4297680" y="960120"/>
-            <a:ext cx="274320" cy="457200"/>
+          <p:cNvPr id="45" name="TblCell2_1"/>
+          <p:cNvSpPr/>
+          <p:nvPr/>
+        </p:nvSpPr>
+        <p:spPr>
+          <a:xfrm>
+            <a:off x="6480000" y="1920000"/>
+            <a:ext cx="370000" cy="380000"/>
           </a:xfrm>
           <a:prstGeom prst="rect">
             <a:avLst/>
@@ -10316,36 +11398,108 @@
               <a:buNone/>
             </a:pPr>
             <a:r>
-              <a:rPr lang="en-US" sz="1400" dirty="0">
-                <a:solidFill>
-                  <a:srgbClr val="1E2761"/>
-                </a:solidFill>
-                <a:latin typeface="Calibri" pitchFamily="34" charset="0"/>
-                <a:ea typeface="Calibri" pitchFamily="34" charset="-122"/>
-                <a:cs typeface="Calibri" pitchFamily="34" charset="-120"/>
-              </a:rPr>
-              <a:t>→</a:t>
-            </a:r>
-            <a:endParaRPr lang="en-US" sz="1400" dirty="0"/>
+              <a:rPr lang="it-IT" sz="1100" dirty="0">
+                <a:solidFill>
+                  <a:srgbClr val="333333"/>
+                </a:solidFill>
+                <a:latin typeface="Calibri" pitchFamily="34" charset="0"/>
+              </a:rPr>
+              <a:t>✓</a:t>
+            </a:r>
+            <a:endParaRPr lang="it-IT" sz="1100" dirty="0"/>
           </a:p>
         </p:txBody>
       </p:sp>
       <p:sp>
         <p:nvSpPr>
-          <p:cNvPr id="13" name="Shape 11"/>
-          <p:cNvSpPr/>
-          <p:nvPr/>
-        </p:nvSpPr>
-        <p:spPr>
-          <a:xfrm>
-            <a:off x="5029200" y="960120"/>
-            <a:ext cx="1097280" cy="457200"/>
+          <p:cNvPr id="46" name="TblCell2_2"/>
+          <p:cNvSpPr/>
+          <p:nvPr/>
+        </p:nvSpPr>
+        <p:spPr>
+          <a:xfrm>
+            <a:off x="6930000" y="1920000"/>
+            <a:ext cx="1020000" cy="380000"/>
+          </a:xfrm>
+          <a:prstGeom prst="rect">
+            <a:avLst/>
+          </a:prstGeom>
+          <a:noFill/>
+          <a:ln/>
+        </p:spPr>
+        <p:txBody>
+          <a:bodyPr wrap="square" rtlCol="0" anchor="ctr"/>
+          <a:lstStyle/>
+          <a:p>
+            <a:pPr algn="ctr" indent="0" marL="0">
+              <a:buNone/>
+            </a:pPr>
+            <a:r>
+              <a:rPr lang="it-IT" sz="1100" dirty="0">
+                <a:solidFill>
+                  <a:srgbClr val="333333"/>
+                </a:solidFill>
+                <a:latin typeface="Calibri" pitchFamily="34" charset="0"/>
+              </a:rPr>
+              <a:t>~0.250</a:t>
+            </a:r>
+            <a:endParaRPr lang="it-IT" sz="1100" dirty="0"/>
+          </a:p>
+        </p:txBody>
+      </p:sp>
+      <p:sp>
+        <p:nvSpPr>
+          <p:cNvPr id="47" name="TblCell2_3"/>
+          <p:cNvSpPr/>
+          <p:nvPr/>
+        </p:nvSpPr>
+        <p:spPr>
+          <a:xfrm>
+            <a:off x="8030000" y="1920000"/>
+            <a:ext cx="870000" cy="380000"/>
+          </a:xfrm>
+          <a:prstGeom prst="rect">
+            <a:avLst/>
+          </a:prstGeom>
+          <a:noFill/>
+          <a:ln/>
+        </p:spPr>
+        <p:txBody>
+          <a:bodyPr wrap="square" rtlCol="0" anchor="ctr"/>
+          <a:lstStyle/>
+          <a:p>
+            <a:pPr algn="ctr" indent="0" marL="0">
+              <a:buNone/>
+            </a:pPr>
+            <a:r>
+              <a:rPr lang="it-IT" sz="1100" dirty="0">
+                <a:solidFill>
+                  <a:srgbClr val="333333"/>
+                </a:solidFill>
+                <a:latin typeface="Calibri" pitchFamily="34" charset="0"/>
+              </a:rPr>
+              <a:t>~45</a:t>
+            </a:r>
+            <a:endParaRPr lang="it-IT" sz="1100" dirty="0"/>
+          </a:p>
+        </p:txBody>
+      </p:sp>
+      <p:sp>
+        <p:nvSpPr>
+          <p:cNvPr id="48" name="TblRowBg3"/>
+          <p:cNvSpPr/>
+          <p:nvPr/>
+        </p:nvSpPr>
+        <p:spPr>
+          <a:xfrm>
+            <a:off x="4300000" y="2300000"/>
+            <a:ext cx="4600000" cy="380000"/>
           </a:xfrm>
           <a:prstGeom prst="rect">
             <a:avLst/>
           </a:prstGeom>
           <a:solidFill>
-            <a:srgbClr val="1E2761"/>
+            <a:srgbClr val="F4F6FB"/>
           </a:solidFill>
           <a:ln w="12700">
             <a:solidFill>
@@ -10357,14 +11511,14 @@
       </p:sp>
       <p:sp>
         <p:nvSpPr>
-          <p:cNvPr id="14" name="Text 12"/>
-          <p:cNvSpPr/>
-          <p:nvPr/>
-        </p:nvSpPr>
-        <p:spPr>
-          <a:xfrm>
-            <a:off x="5029200" y="960120"/>
-            <a:ext cx="1097280" cy="457200"/>
+          <p:cNvPr id="49" name="TblCell3_0"/>
+          <p:cNvSpPr/>
+          <p:nvPr/>
+        </p:nvSpPr>
+        <p:spPr>
+          <a:xfrm>
+            <a:off x="4380000" y="2300000"/>
+            <a:ext cx="2020000" cy="380000"/>
           </a:xfrm>
           <a:prstGeom prst="rect">
             <a:avLst/>
@@ -10376,34 +11530,32 @@
           <a:bodyPr wrap="square" rtlCol="0" anchor="ctr"/>
           <a:lstStyle/>
           <a:p>
-            <a:pPr algn="ctr" indent="0" marL="0">
+            <a:pPr algn="l" indent="0" marL="0">
               <a:buNone/>
             </a:pPr>
             <a:r>
-              <a:rPr lang="en-US" sz="900" b="1" dirty="0">
-                <a:solidFill>
-                  <a:srgbClr val="FFFFFF"/>
-                </a:solidFill>
-                <a:latin typeface="Calibri" pitchFamily="34" charset="0"/>
-                <a:ea typeface="Calibri" pitchFamily="34" charset="-122"/>
-                <a:cs typeface="Calibri" pitchFamily="34" charset="-120"/>
-              </a:rPr>
-              <a:t>Global Mean Pool</a:t>
-            </a:r>
-            <a:endParaRPr lang="en-US" sz="900" dirty="0"/>
+              <a:rPr lang="it-IT" sz="1100" dirty="0">
+                <a:solidFill>
+                  <a:srgbClr val="888888"/>
+                </a:solidFill>
+                <a:latin typeface="Calibri" pitchFamily="34" charset="0"/>
+              </a:rPr>
+              <a:t>Chance level</a:t>
+            </a:r>
+            <a:endParaRPr lang="it-IT" sz="1100" dirty="0"/>
           </a:p>
         </p:txBody>
       </p:sp>
       <p:sp>
         <p:nvSpPr>
-          <p:cNvPr id="15" name="Text 13"/>
-          <p:cNvSpPr/>
-          <p:nvPr/>
-        </p:nvSpPr>
-        <p:spPr>
-          <a:xfrm>
-            <a:off x="5029200" y="1554480"/>
-            <a:ext cx="1097280" cy="320040"/>
+          <p:cNvPr id="50" name="TblCell3_1"/>
+          <p:cNvSpPr/>
+          <p:nvPr/>
+        </p:nvSpPr>
+        <p:spPr>
+          <a:xfrm>
+            <a:off x="6480000" y="2300000"/>
+            <a:ext cx="370000" cy="380000"/>
           </a:xfrm>
           <a:prstGeom prst="rect">
             <a:avLst/>
@@ -10419,55 +11571,28 @@
               <a:buNone/>
             </a:pPr>
             <a:r>
-              <a:rPr lang="en-US" sz="900" i="1" dirty="0">
-                <a:solidFill>
-                  <a:srgbClr val="1A1A2E"/>
-                </a:solidFill>
-                <a:latin typeface="Calibri" pitchFamily="34" charset="0"/>
-                <a:ea typeface="Calibri" pitchFamily="34" charset="-122"/>
-                <a:cs typeface="Calibri" pitchFamily="34" charset="-120"/>
-              </a:rPr>
-              <a:t>[Embedding h]</a:t>
-            </a:r>
-            <a:endParaRPr lang="en-US" sz="900" dirty="0"/>
+              <a:rPr lang="it-IT" sz="1100" dirty="0">
+                <a:solidFill>
+                  <a:srgbClr val="888888"/>
+                </a:solidFill>
+                <a:latin typeface="Calibri" pitchFamily="34" charset="0"/>
+              </a:rPr>
+              <a:t/>
+            </a:r>
+            <a:endParaRPr lang="it-IT" sz="1100" dirty="0"/>
           </a:p>
         </p:txBody>
       </p:sp>
       <p:sp>
         <p:nvSpPr>
-          <p:cNvPr id="16" name="Shape 14"/>
-          <p:cNvSpPr/>
-          <p:nvPr/>
-        </p:nvSpPr>
-        <p:spPr>
-          <a:xfrm>
-            <a:off x="3840480" y="2103120"/>
-            <a:ext cx="1645920" cy="502920"/>
-          </a:xfrm>
-          <a:prstGeom prst="rect">
-            <a:avLst/>
-          </a:prstGeom>
-          <a:solidFill>
-            <a:srgbClr val="028090"/>
-          </a:solidFill>
-          <a:ln w="12700">
-            <a:solidFill>
-              <a:srgbClr val="028090"/>
-            </a:solidFill>
-            <a:prstDash val="solid"/>
-          </a:ln>
-        </p:spPr>
-      </p:sp>
-      <p:sp>
-        <p:nvSpPr>
-          <p:cNvPr id="17" name="Text 15"/>
-          <p:cNvSpPr/>
-          <p:nvPr/>
-        </p:nvSpPr>
-        <p:spPr>
-          <a:xfrm>
-            <a:off x="3840480" y="2103120"/>
-            <a:ext cx="1645920" cy="502920"/>
+          <p:cNvPr id="51" name="TblCell3_2"/>
+          <p:cNvSpPr/>
+          <p:nvPr/>
+        </p:nvSpPr>
+        <p:spPr>
+          <a:xfrm>
+            <a:off x="6930000" y="2300000"/>
+            <a:ext cx="1020000" cy="380000"/>
           </a:xfrm>
           <a:prstGeom prst="rect">
             <a:avLst/>
@@ -10483,72 +11608,28 @@
               <a:buNone/>
             </a:pPr>
             <a:r>
-              <a:rPr lang="en-US" sz="900" dirty="0">
-                <a:solidFill>
-                  <a:srgbClr val="FFFFFF"/>
-                </a:solidFill>
-                <a:latin typeface="Calibri" pitchFamily="34" charset="0"/>
-                <a:ea typeface="Calibri" pitchFamily="34" charset="-122"/>
-                <a:cs typeface="Calibri" pitchFamily="34" charset="-120"/>
-              </a:rPr>
-              <a:t>Task Classifier</a:t>
-            </a:r>
-            <a:endParaRPr lang="en-US" sz="900" dirty="0"/>
-          </a:p>
-          <a:p>
-            <a:pPr algn="ctr" indent="0" marL="0">
-              <a:buNone/>
-            </a:pPr>
-            <a:r>
-              <a:rPr lang="en-US" sz="900" dirty="0">
-                <a:solidFill>
-                  <a:srgbClr val="FFFFFF"/>
-                </a:solidFill>
-                <a:latin typeface="Calibri" pitchFamily="34" charset="0"/>
-                <a:ea typeface="Calibri" pitchFamily="34" charset="-122"/>
-                <a:cs typeface="Calibri" pitchFamily="34" charset="-120"/>
-              </a:rPr>
-              <a:t>4 classi — L_task</a:t>
-            </a:r>
-            <a:endParaRPr lang="en-US" sz="900" dirty="0"/>
+              <a:rPr lang="it-IT" sz="1100" dirty="0">
+                <a:solidFill>
+                  <a:srgbClr val="888888"/>
+                </a:solidFill>
+                <a:latin typeface="Calibri" pitchFamily="34" charset="0"/>
+              </a:rPr>
+              <a:t>0.250</a:t>
+            </a:r>
+            <a:endParaRPr lang="it-IT" sz="1100" dirty="0"/>
           </a:p>
         </p:txBody>
       </p:sp>
       <p:sp>
         <p:nvSpPr>
-          <p:cNvPr id="18" name="Shape 16"/>
-          <p:cNvSpPr/>
-          <p:nvPr/>
-        </p:nvSpPr>
-        <p:spPr>
-          <a:xfrm>
-            <a:off x="5669280" y="2103120"/>
-            <a:ext cx="1645920" cy="502920"/>
-          </a:xfrm>
-          <a:prstGeom prst="rect">
-            <a:avLst/>
-          </a:prstGeom>
-          <a:solidFill>
-            <a:srgbClr val="C0392B"/>
-          </a:solidFill>
-          <a:ln w="12700">
-            <a:solidFill>
-              <a:srgbClr val="C0392B"/>
-            </a:solidFill>
-            <a:prstDash val="solid"/>
-          </a:ln>
-        </p:spPr>
-      </p:sp>
-      <p:sp>
-        <p:nvSpPr>
-          <p:cNvPr id="19" name="Text 17"/>
-          <p:cNvSpPr/>
-          <p:nvPr/>
-        </p:nvSpPr>
-        <p:spPr>
-          <a:xfrm>
-            <a:off x="5669280" y="2103120"/>
-            <a:ext cx="1645920" cy="502920"/>
+          <p:cNvPr id="52" name="TblCell3_3"/>
+          <p:cNvSpPr/>
+          <p:nvPr/>
+        </p:nvSpPr>
+        <p:spPr>
+          <a:xfrm>
+            <a:off x="8030000" y="2300000"/>
+            <a:ext cx="870000" cy="380000"/>
           </a:xfrm>
           <a:prstGeom prst="rect">
             <a:avLst/>
@@ -10564,1425 +11645,28 @@
               <a:buNone/>
             </a:pPr>
             <a:r>
-              <a:rPr lang="en-US" sz="900" dirty="0">
-                <a:solidFill>
-                  <a:srgbClr val="FFFFFF"/>
-                </a:solidFill>
-                <a:latin typeface="Calibri" pitchFamily="34" charset="0"/>
-                <a:ea typeface="Calibri" pitchFamily="34" charset="-122"/>
-                <a:cs typeface="Calibri" pitchFamily="34" charset="-120"/>
-              </a:rPr>
-              <a:t>GRL(α) → Subject Disc.</a:t>
-            </a:r>
-            <a:endParaRPr lang="en-US" sz="900" dirty="0"/>
-          </a:p>
-          <a:p>
-            <a:pPr algn="ctr" indent="0" marL="0">
-              <a:buNone/>
-            </a:pPr>
-            <a:r>
-              <a:rPr lang="en-US" sz="900" dirty="0">
-                <a:solidFill>
-                  <a:srgbClr val="FFFFFF"/>
-                </a:solidFill>
-                <a:latin typeface="Calibri" pitchFamily="34" charset="0"/>
-                <a:ea typeface="Calibri" pitchFamily="34" charset="-122"/>
-                <a:cs typeface="Calibri" pitchFamily="34" charset="-120"/>
-              </a:rPr>
-              <a:t>Forward: segnale invariato</a:t>
-            </a:r>
-            <a:endParaRPr lang="en-US" sz="900" dirty="0"/>
-          </a:p>
-          <a:p>
-            <a:pPr algn="ctr" indent="0" marL="0">
-              <a:buNone/>
-            </a:pPr>
-            <a:r>
-              <a:rPr lang="en-US" sz="900" dirty="0">
-                <a:solidFill>
-                  <a:srgbClr val="FFFFFF"/>
-                </a:solidFill>
-                <a:latin typeface="Calibri" pitchFamily="34" charset="0"/>
-                <a:ea typeface="Calibri" pitchFamily="34" charset="-122"/>
-                <a:cs typeface="Calibri" pitchFamily="34" charset="-120"/>
-              </a:rPr>
-              <a:t>Backward: grad × (−α)</a:t>
-            </a:r>
-            <a:endParaRPr lang="en-US" sz="900" dirty="0"/>
-          </a:p>
-          <a:p>
-            <a:pPr algn="ctr" indent="0" marL="0">
-              <a:buNone/>
-            </a:pPr>
-            <a:r>
-              <a:rPr lang="en-US" sz="900" dirty="0">
-                <a:solidFill>
-                  <a:srgbClr val="FFFFFF"/>
-                </a:solidFill>
-                <a:latin typeface="Calibri" pitchFamily="34" charset="0"/>
-                <a:ea typeface="Calibri" pitchFamily="34" charset="-122"/>
-                <a:cs typeface="Calibri" pitchFamily="34" charset="-120"/>
-              </a:rPr>
-              <a:t>→ encoder inganna il discriminatore</a:t>
-            </a:r>
-            <a:endParaRPr lang="en-US" sz="900" dirty="0"/>
-          </a:p>
-          <a:p>
-            <a:pPr algn="ctr" indent="0" marL="0">
-              <a:buNone/>
-            </a:pPr>
-            <a:r>
-              <a:rPr lang="en-US" sz="900" dirty="0">
-                <a:solidFill>
-                  <a:srgbClr val="FFFFFF"/>
-                </a:solidFill>
-                <a:latin typeface="Calibri" pitchFamily="34" charset="0"/>
-                <a:ea typeface="Calibri" pitchFamily="34" charset="-122"/>
-                <a:cs typeface="Calibri" pitchFamily="34" charset="-120"/>
-              </a:rPr>
-              <a:t>50 soggetti — L_subj</a:t>
-            </a:r>
-            <a:endParaRPr lang="en-US" sz="900" dirty="0"/>
+              <a:rPr lang="it-IT" sz="1100" dirty="0">
+                <a:solidFill>
+                  <a:srgbClr val="888888"/>
+                </a:solidFill>
+                <a:latin typeface="Calibri" pitchFamily="34" charset="0"/>
+              </a:rPr>
+              <a:t>—</a:t>
+            </a:r>
+            <a:endParaRPr lang="it-IT" sz="1100" dirty="0"/>
           </a:p>
         </p:txBody>
       </p:sp>
       <p:sp>
         <p:nvSpPr>
-          <p:cNvPr id="20" name="Shape 18"/>
-          <p:cNvSpPr/>
-          <p:nvPr/>
-        </p:nvSpPr>
-        <p:spPr>
-          <a:xfrm>
-            <a:off x="4206240" y="2880360"/>
-            <a:ext cx="2560320" cy="411480"/>
-          </a:xfrm>
-          <a:prstGeom prst="rect">
-            <a:avLst/>
-          </a:prstGeom>
-          <a:solidFill>
-            <a:srgbClr val="1E2761"/>
-          </a:solidFill>
-          <a:ln w="12700">
-            <a:solidFill>
-              <a:srgbClr val="CADCFC"/>
-            </a:solidFill>
-            <a:prstDash val="solid"/>
-          </a:ln>
-        </p:spPr>
-      </p:sp>
-      <p:sp>
-        <p:nvSpPr>
-          <p:cNvPr id="21" name="Text 19"/>
-          <p:cNvSpPr/>
-          <p:nvPr/>
-        </p:nvSpPr>
-        <p:spPr>
-          <a:xfrm>
-            <a:off x="4206240" y="2880360"/>
-            <a:ext cx="2560320" cy="411480"/>
-          </a:xfrm>
-          <a:prstGeom prst="rect">
-            <a:avLst/>
-          </a:prstGeom>
-          <a:noFill/>
-          <a:ln/>
-        </p:spPr>
-        <p:txBody>
-          <a:bodyPr wrap="square" rtlCol="0" anchor="ctr"/>
-          <a:lstStyle/>
-          <a:p>
-            <a:pPr algn="ctr" indent="0" marL="0">
-              <a:buNone/>
-            </a:pPr>
-            <a:r>
-              <a:rPr lang="en-US" sz="1100" b="1" dirty="0">
-                <a:solidFill>
-                  <a:srgbClr val="CADCFC"/>
-                </a:solidFill>
-                <a:latin typeface="Calibri" pitchFamily="34" charset="0"/>
-                <a:ea typeface="Calibri" pitchFamily="34" charset="-122"/>
-                <a:cs typeface="Calibri" pitchFamily="34" charset="-120"/>
-              </a:rPr>
-              <a:t>Loss totale = L_task + λ·L_subj (λ=0.5)</a:t>
-            </a:r>
-            <a:endParaRPr lang="en-US" sz="1100" dirty="0"/>
-          </a:p>
-          <a:p>
-            <a:pPr algn="ctr" indent="0" marL="0">
-              <a:buNone/>
-            </a:pPr>
-            <a:r>
-              <a:rPr lang="en-US" sz="1100" b="1" dirty="0">
-                <a:solidFill>
-                  <a:srgbClr val="CADCFC"/>
-                </a:solidFill>
-                <a:latin typeface="Calibri" pitchFamily="34" charset="0"/>
-                <a:ea typeface="Calibri" pitchFamily="34" charset="-122"/>
-                <a:cs typeface="Calibri" pitchFamily="34" charset="-120"/>
-              </a:rPr>
-              <a:t>α schedule: 0→1 durante il training</a:t>
-            </a:r>
-            <a:endParaRPr lang="en-US" sz="1100" dirty="0"/>
-          </a:p>
-        </p:txBody>
-      </p:sp>
-      <p:graphicFrame>
-        <p:nvGraphicFramePr>
-          <p:cNvPr id="8" name="Table 0"/>
-          <p:cNvGraphicFramePr>
-            <a:graphicFrameLocks noGrp="1"/>
-          </p:cNvGraphicFramePr>
-          <p:nvPr>
-            <p:extLst>
-              <p:ext uri="{D42A27DB-BD31-4B8C-83A1-F6EECF244321}">
-                <p14:modId xmlns:p14="http://schemas.microsoft.com/office/powerpoint/2010/main" val="1579011935"/>
-              </p:ext>
-            </p:extLst>
-          </p:nvPr>
-        </p:nvGraphicFramePr>
-        <p:xfrm>
-          <a:off x="365760" y="3474720"/>
-          <a:ext cx="8412480" cy="1417320"/>
-        </p:xfrm>
-        <a:graphic>
-          <a:graphicData uri="http://schemas.openxmlformats.org/drawingml/2006/table">
-            <a:tbl>
-              <a:tblPr/>
-              <a:tblGrid>
-                <a:gridCol w="2286000"/>
-                <a:gridCol w="914400"/>
-                <a:gridCol w="1645920"/>
-                <a:gridCol w="1280160"/>
-              </a:tblGrid>
-              <a:tr h="283464">
-                <a:tc>
-                  <a:txBody>
-                    <a:bodyPr/>
-                    <a:lstStyle/>
-                    <a:p>
-                      <a:pPr indent="0" marL="0">
-                        <a:buNone/>
-                      </a:pPr>
-                      <a:r>
-                        <a:rPr lang="en-US" sz="1000" b="1" dirty="0">
-                          <a:solidFill>
-                            <a:srgbClr val="FFFFFF"/>
-                          </a:solidFill>
-                        </a:rPr>
-                        <a:t>Modello</a:t>
-                      </a:r>
-                      <a:endParaRPr lang="en-US" sz="1000" dirty="0"/>
-                    </a:p>
-                  </a:txBody>
-                  <a:tcPr marL="91440" marR="91440" marT="45720" marB="45720">
-                    <a:lnL w="12700" cap="flat" cmpd="sng" algn="ctr">
-                      <a:solidFill>
-                        <a:srgbClr val="CADCFC"/>
-                      </a:solidFill>
-                      <a:prstDash val="solid"/>
-                      <a:round/>
-                      <a:headEnd type="none" w="med" len="med"/>
-                      <a:tailEnd type="none" w="med" len="med"/>
-                    </a:lnL>
-                    <a:lnR w="12700" cap="flat" cmpd="sng" algn="ctr">
-                      <a:solidFill>
-                        <a:srgbClr val="CADCFC"/>
-                      </a:solidFill>
-                      <a:prstDash val="solid"/>
-                      <a:round/>
-                      <a:headEnd type="none" w="med" len="med"/>
-                      <a:tailEnd type="none" w="med" len="med"/>
-                    </a:lnR>
-                    <a:lnT w="12700" cap="flat" cmpd="sng" algn="ctr">
-                      <a:solidFill>
-                        <a:srgbClr val="CADCFC"/>
-                      </a:solidFill>
-                      <a:prstDash val="solid"/>
-                      <a:round/>
-                      <a:headEnd type="none" w="med" len="med"/>
-                      <a:tailEnd type="none" w="med" len="med"/>
-                    </a:lnT>
-                    <a:lnB w="12700" cap="flat" cmpd="sng" algn="ctr">
-                      <a:solidFill>
-                        <a:srgbClr val="CADCFC"/>
-                      </a:solidFill>
-                      <a:prstDash val="solid"/>
-                      <a:round/>
-                      <a:headEnd type="none" w="med" len="med"/>
-                      <a:tailEnd type="none" w="med" len="med"/>
-                    </a:lnB>
-                    <a:solidFill>
-                      <a:srgbClr val="1E2761"/>
-                    </a:solidFill>
-                  </a:tcPr>
-                </a:tc>
-                <a:tc>
-                  <a:txBody>
-                    <a:bodyPr/>
-                    <a:lstStyle/>
-                    <a:p>
-                      <a:pPr indent="0" marL="0">
-                        <a:buNone/>
-                      </a:pPr>
-                      <a:r>
-                        <a:rPr lang="en-US" sz="1000" b="1" dirty="0">
-                          <a:solidFill>
-                            <a:srgbClr val="FFFFFF"/>
-                          </a:solidFill>
-                        </a:rPr>
-                        <a:t>ADV</a:t>
-                      </a:r>
-                      <a:endParaRPr lang="en-US" sz="1000" dirty="0"/>
-                    </a:p>
-                  </a:txBody>
-                  <a:tcPr marL="91440" marR="91440" marT="45720" marB="45720">
-                    <a:lnL w="12700" cap="flat" cmpd="sng" algn="ctr">
-                      <a:solidFill>
-                        <a:srgbClr val="CADCFC"/>
-                      </a:solidFill>
-                      <a:prstDash val="solid"/>
-                      <a:round/>
-                      <a:headEnd type="none" w="med" len="med"/>
-                      <a:tailEnd type="none" w="med" len="med"/>
-                    </a:lnL>
-                    <a:lnR w="12700" cap="flat" cmpd="sng" algn="ctr">
-                      <a:solidFill>
-                        <a:srgbClr val="CADCFC"/>
-                      </a:solidFill>
-                      <a:prstDash val="solid"/>
-                      <a:round/>
-                      <a:headEnd type="none" w="med" len="med"/>
-                      <a:tailEnd type="none" w="med" len="med"/>
-                    </a:lnR>
-                    <a:lnT w="12700" cap="flat" cmpd="sng" algn="ctr">
-                      <a:solidFill>
-                        <a:srgbClr val="CADCFC"/>
-                      </a:solidFill>
-                      <a:prstDash val="solid"/>
-                      <a:round/>
-                      <a:headEnd type="none" w="med" len="med"/>
-                      <a:tailEnd type="none" w="med" len="med"/>
-                    </a:lnT>
-                    <a:lnB w="12700" cap="flat" cmpd="sng" algn="ctr">
-                      <a:solidFill>
-                        <a:srgbClr val="CADCFC"/>
-                      </a:solidFill>
-                      <a:prstDash val="solid"/>
-                      <a:round/>
-                      <a:headEnd type="none" w="med" len="med"/>
-                      <a:tailEnd type="none" w="med" len="med"/>
-                    </a:lnB>
-                    <a:solidFill>
-                      <a:srgbClr val="1E2761"/>
-                    </a:solidFill>
-                  </a:tcPr>
-                </a:tc>
-                <a:tc>
-                  <a:txBody>
-                    <a:bodyPr/>
-                    <a:lstStyle/>
-                    <a:p>
-                      <a:pPr indent="0" marL="0">
-                        <a:buNone/>
-                      </a:pPr>
-                      <a:r>
-                        <a:rPr lang="en-US" sz="1000" b="1" dirty="0">
-                          <a:solidFill>
-                            <a:srgbClr val="FFFFFF"/>
-                          </a:solidFill>
-                        </a:rPr>
-                        <a:t>test_bacc</a:t>
-                      </a:r>
-                      <a:endParaRPr lang="en-US" sz="1000" dirty="0"/>
-                    </a:p>
-                  </a:txBody>
-                  <a:tcPr marL="91440" marR="91440" marT="45720" marB="45720">
-                    <a:lnL w="12700" cap="flat" cmpd="sng" algn="ctr">
-                      <a:solidFill>
-                        <a:srgbClr val="CADCFC"/>
-                      </a:solidFill>
-                      <a:prstDash val="solid"/>
-                      <a:round/>
-                      <a:headEnd type="none" w="med" len="med"/>
-                      <a:tailEnd type="none" w="med" len="med"/>
-                    </a:lnL>
-                    <a:lnR w="12700" cap="flat" cmpd="sng" algn="ctr">
-                      <a:solidFill>
-                        <a:srgbClr val="CADCFC"/>
-                      </a:solidFill>
-                      <a:prstDash val="solid"/>
-                      <a:round/>
-                      <a:headEnd type="none" w="med" len="med"/>
-                      <a:tailEnd type="none" w="med" len="med"/>
-                    </a:lnR>
-                    <a:lnT w="12700" cap="flat" cmpd="sng" algn="ctr">
-                      <a:solidFill>
-                        <a:srgbClr val="CADCFC"/>
-                      </a:solidFill>
-                      <a:prstDash val="solid"/>
-                      <a:round/>
-                      <a:headEnd type="none" w="med" len="med"/>
-                      <a:tailEnd type="none" w="med" len="med"/>
-                    </a:lnT>
-                    <a:lnB w="12700" cap="flat" cmpd="sng" algn="ctr">
-                      <a:solidFill>
-                        <a:srgbClr val="CADCFC"/>
-                      </a:solidFill>
-                      <a:prstDash val="solid"/>
-                      <a:round/>
-                      <a:headEnd type="none" w="med" len="med"/>
-                      <a:tailEnd type="none" w="med" len="med"/>
-                    </a:lnB>
-                    <a:solidFill>
-                      <a:srgbClr val="1E2761"/>
-                    </a:solidFill>
-                  </a:tcPr>
-                </a:tc>
-                <a:tc>
-                  <a:txBody>
-                    <a:bodyPr/>
-                    <a:lstStyle/>
-                    <a:p>
-                      <a:pPr indent="0" marL="0">
-                        <a:buNone/>
-                      </a:pPr>
-                      <a:r>
-                        <a:rPr lang="en-US" sz="1000" b="1" dirty="0">
-                          <a:solidFill>
-                            <a:srgbClr val="FFFFFF"/>
-                          </a:solidFill>
-                        </a:rPr>
-                        <a:t>epochs</a:t>
-                      </a:r>
-                      <a:endParaRPr lang="en-US" sz="1000" dirty="0"/>
-                    </a:p>
-                  </a:txBody>
-                  <a:tcPr marL="91440" marR="91440" marT="45720" marB="45720">
-                    <a:lnL w="12700" cap="flat" cmpd="sng" algn="ctr">
-                      <a:solidFill>
-                        <a:srgbClr val="CADCFC"/>
-                      </a:solidFill>
-                      <a:prstDash val="solid"/>
-                      <a:round/>
-                      <a:headEnd type="none" w="med" len="med"/>
-                      <a:tailEnd type="none" w="med" len="med"/>
-                    </a:lnL>
-                    <a:lnR w="12700" cap="flat" cmpd="sng" algn="ctr">
-                      <a:solidFill>
-                        <a:srgbClr val="CADCFC"/>
-                      </a:solidFill>
-                      <a:prstDash val="solid"/>
-                      <a:round/>
-                      <a:headEnd type="none" w="med" len="med"/>
-                      <a:tailEnd type="none" w="med" len="med"/>
-                    </a:lnR>
-                    <a:lnT w="12700" cap="flat" cmpd="sng" algn="ctr">
-                      <a:solidFill>
-                        <a:srgbClr val="CADCFC"/>
-                      </a:solidFill>
-                      <a:prstDash val="solid"/>
-                      <a:round/>
-                      <a:headEnd type="none" w="med" len="med"/>
-                      <a:tailEnd type="none" w="med" len="med"/>
-                    </a:lnT>
-                    <a:lnB w="12700" cap="flat" cmpd="sng" algn="ctr">
-                      <a:solidFill>
-                        <a:srgbClr val="CADCFC"/>
-                      </a:solidFill>
-                      <a:prstDash val="solid"/>
-                      <a:round/>
-                      <a:headEnd type="none" w="med" len="med"/>
-                      <a:tailEnd type="none" w="med" len="med"/>
-                    </a:lnB>
-                    <a:solidFill>
-                      <a:srgbClr val="1E2761"/>
-                    </a:solidFill>
-                  </a:tcPr>
-                </a:tc>
-              </a:tr>
-              <a:tr h="283464">
-                <a:tc>
-                  <a:txBody>
-                    <a:bodyPr/>
-                    <a:lstStyle/>
-                    <a:p>
-                      <a:pPr indent="0" marL="0">
-                        <a:buNone/>
-                      </a:pPr>
-                      <a:r>
-                        <a:rPr lang="en-US" sz="1200" dirty="0">
-                          <a:solidFill>
-                            <a:srgbClr val="000000"/>
-                          </a:solidFill>
-                        </a:rPr>
-                        <a:t>GAT_2L</a:t>
-                      </a:r>
-                      <a:endParaRPr lang="en-US" sz="1200" dirty="0"/>
-                    </a:p>
-                  </a:txBody>
-                  <a:tcPr marL="91440" marR="91440" marT="45720" marB="45720">
-                    <a:lnL w="12700" cap="flat" cmpd="sng" algn="ctr">
-                      <a:solidFill>
-                        <a:srgbClr val="CADCFC"/>
-                      </a:solidFill>
-                      <a:prstDash val="solid"/>
-                      <a:round/>
-                      <a:headEnd type="none" w="med" len="med"/>
-                      <a:tailEnd type="none" w="med" len="med"/>
-                    </a:lnL>
-                    <a:lnR w="12700" cap="flat" cmpd="sng" algn="ctr">
-                      <a:solidFill>
-                        <a:srgbClr val="CADCFC"/>
-                      </a:solidFill>
-                      <a:prstDash val="solid"/>
-                      <a:round/>
-                      <a:headEnd type="none" w="med" len="med"/>
-                      <a:tailEnd type="none" w="med" len="med"/>
-                    </a:lnR>
-                    <a:lnT w="12700" cap="flat" cmpd="sng" algn="ctr">
-                      <a:solidFill>
-                        <a:srgbClr val="CADCFC"/>
-                      </a:solidFill>
-                      <a:prstDash val="solid"/>
-                      <a:round/>
-                      <a:headEnd type="none" w="med" len="med"/>
-                      <a:tailEnd type="none" w="med" len="med"/>
-                    </a:lnT>
-                    <a:lnB w="12700" cap="flat" cmpd="sng" algn="ctr">
-                      <a:solidFill>
-                        <a:srgbClr val="CADCFC"/>
-                      </a:solidFill>
-                      <a:prstDash val="solid"/>
-                      <a:round/>
-                      <a:headEnd type="none" w="med" len="med"/>
-                      <a:tailEnd type="none" w="med" len="med"/>
-                    </a:lnB>
-                    <a:solidFill>
-                      <a:srgbClr val="FFFFFF"/>
-                    </a:solidFill>
-                  </a:tcPr>
-                </a:tc>
-                <a:tc>
-                  <a:txBody>
-                    <a:bodyPr/>
-                    <a:lstStyle/>
-                    <a:p>
-                      <a:pPr indent="0" marL="0">
-                        <a:buNone/>
-                      </a:pPr>
-                      <a:r>
-                        <a:rPr lang="en-US" sz="1200" dirty="0">
-                          <a:solidFill>
-                            <a:srgbClr val="000000"/>
-                          </a:solidFill>
-                        </a:rPr>
-                        <a:t>✗</a:t>
-                      </a:r>
-                      <a:endParaRPr lang="en-US" sz="1200" dirty="0"/>
-                    </a:p>
-                  </a:txBody>
-                  <a:tcPr marL="91440" marR="91440" marT="45720" marB="45720">
-                    <a:lnL w="12700" cap="flat" cmpd="sng" algn="ctr">
-                      <a:solidFill>
-                        <a:srgbClr val="CADCFC"/>
-                      </a:solidFill>
-                      <a:prstDash val="solid"/>
-                      <a:round/>
-                      <a:headEnd type="none" w="med" len="med"/>
-                      <a:tailEnd type="none" w="med" len="med"/>
-                    </a:lnL>
-                    <a:lnR w="12700" cap="flat" cmpd="sng" algn="ctr">
-                      <a:solidFill>
-                        <a:srgbClr val="CADCFC"/>
-                      </a:solidFill>
-                      <a:prstDash val="solid"/>
-                      <a:round/>
-                      <a:headEnd type="none" w="med" len="med"/>
-                      <a:tailEnd type="none" w="med" len="med"/>
-                    </a:lnR>
-                    <a:lnT w="12700" cap="flat" cmpd="sng" algn="ctr">
-                      <a:solidFill>
-                        <a:srgbClr val="CADCFC"/>
-                      </a:solidFill>
-                      <a:prstDash val="solid"/>
-                      <a:round/>
-                      <a:headEnd type="none" w="med" len="med"/>
-                      <a:tailEnd type="none" w="med" len="med"/>
-                    </a:lnT>
-                    <a:lnB w="12700" cap="flat" cmpd="sng" algn="ctr">
-                      <a:solidFill>
-                        <a:srgbClr val="CADCFC"/>
-                      </a:solidFill>
-                      <a:prstDash val="solid"/>
-                      <a:round/>
-                      <a:headEnd type="none" w="med" len="med"/>
-                      <a:tailEnd type="none" w="med" len="med"/>
-                    </a:lnB>
-                    <a:solidFill>
-                      <a:srgbClr val="FFFFFF"/>
-                    </a:solidFill>
-                  </a:tcPr>
-                </a:tc>
-                <a:tc>
-                  <a:txBody>
-                    <a:bodyPr/>
-                    <a:lstStyle/>
-                    <a:p>
-                      <a:pPr indent="0" marL="0">
-                        <a:buNone/>
-                      </a:pPr>
-                      <a:r>
-                        <a:rPr lang="en-US" sz="1200" dirty="0">
-                          <a:solidFill>
-                            <a:srgbClr val="000000"/>
-                          </a:solidFill>
-                        </a:rPr>
-                        <a:t>0.253</a:t>
-                      </a:r>
-                      <a:endParaRPr lang="en-US" sz="1200" dirty="0"/>
-                    </a:p>
-                  </a:txBody>
-                  <a:tcPr marL="91440" marR="91440" marT="45720" marB="45720">
-                    <a:lnL w="12700" cap="flat" cmpd="sng" algn="ctr">
-                      <a:solidFill>
-                        <a:srgbClr val="CADCFC"/>
-                      </a:solidFill>
-                      <a:prstDash val="solid"/>
-                      <a:round/>
-                      <a:headEnd type="none" w="med" len="med"/>
-                      <a:tailEnd type="none" w="med" len="med"/>
-                    </a:lnL>
-                    <a:lnR w="12700" cap="flat" cmpd="sng" algn="ctr">
-                      <a:solidFill>
-                        <a:srgbClr val="CADCFC"/>
-                      </a:solidFill>
-                      <a:prstDash val="solid"/>
-                      <a:round/>
-                      <a:headEnd type="none" w="med" len="med"/>
-                      <a:tailEnd type="none" w="med" len="med"/>
-                    </a:lnR>
-                    <a:lnT w="12700" cap="flat" cmpd="sng" algn="ctr">
-                      <a:solidFill>
-                        <a:srgbClr val="CADCFC"/>
-                      </a:solidFill>
-                      <a:prstDash val="solid"/>
-                      <a:round/>
-                      <a:headEnd type="none" w="med" len="med"/>
-                      <a:tailEnd type="none" w="med" len="med"/>
-                    </a:lnT>
-                    <a:lnB w="12700" cap="flat" cmpd="sng" algn="ctr">
-                      <a:solidFill>
-                        <a:srgbClr val="CADCFC"/>
-                      </a:solidFill>
-                      <a:prstDash val="solid"/>
-                      <a:round/>
-                      <a:headEnd type="none" w="med" len="med"/>
-                      <a:tailEnd type="none" w="med" len="med"/>
-                    </a:lnB>
-                    <a:solidFill>
-                      <a:srgbClr val="FFFFFF"/>
-                    </a:solidFill>
-                  </a:tcPr>
-                </a:tc>
-                <a:tc>
-                  <a:txBody>
-                    <a:bodyPr/>
-                    <a:lstStyle/>
-                    <a:p>
-                      <a:pPr indent="0" marL="0">
-                        <a:buNone/>
-                      </a:pPr>
-                      <a:r>
-                        <a:rPr lang="en-US" sz="1200" dirty="0">
-                          <a:solidFill>
-                            <a:srgbClr val="000000"/>
-                          </a:solidFill>
-                        </a:rPr>
-                        <a:t>25</a:t>
-                      </a:r>
-                      <a:endParaRPr lang="en-US" sz="1200" dirty="0"/>
-                    </a:p>
-                  </a:txBody>
-                  <a:tcPr marL="91440" marR="91440" marT="45720" marB="45720">
-                    <a:lnL w="12700" cap="flat" cmpd="sng" algn="ctr">
-                      <a:solidFill>
-                        <a:srgbClr val="CADCFC"/>
-                      </a:solidFill>
-                      <a:prstDash val="solid"/>
-                      <a:round/>
-                      <a:headEnd type="none" w="med" len="med"/>
-                      <a:tailEnd type="none" w="med" len="med"/>
-                    </a:lnL>
-                    <a:lnR w="12700" cap="flat" cmpd="sng" algn="ctr">
-                      <a:solidFill>
-                        <a:srgbClr val="CADCFC"/>
-                      </a:solidFill>
-                      <a:prstDash val="solid"/>
-                      <a:round/>
-                      <a:headEnd type="none" w="med" len="med"/>
-                      <a:tailEnd type="none" w="med" len="med"/>
-                    </a:lnR>
-                    <a:lnT w="12700" cap="flat" cmpd="sng" algn="ctr">
-                      <a:solidFill>
-                        <a:srgbClr val="CADCFC"/>
-                      </a:solidFill>
-                      <a:prstDash val="solid"/>
-                      <a:round/>
-                      <a:headEnd type="none" w="med" len="med"/>
-                      <a:tailEnd type="none" w="med" len="med"/>
-                    </a:lnT>
-                    <a:lnB w="12700" cap="flat" cmpd="sng" algn="ctr">
-                      <a:solidFill>
-                        <a:srgbClr val="CADCFC"/>
-                      </a:solidFill>
-                      <a:prstDash val="solid"/>
-                      <a:round/>
-                      <a:headEnd type="none" w="med" len="med"/>
-                      <a:tailEnd type="none" w="med" len="med"/>
-                    </a:lnB>
-                    <a:solidFill>
-                      <a:srgbClr val="FFFFFF"/>
-                    </a:solidFill>
-                  </a:tcPr>
-                </a:tc>
-              </a:tr>
-              <a:tr h="283464">
-                <a:tc>
-                  <a:txBody>
-                    <a:bodyPr/>
-                    <a:lstStyle/>
-                    <a:p>
-                      <a:pPr indent="0" marL="0">
-                        <a:buNone/>
-                      </a:pPr>
-                      <a:r>
-                        <a:rPr lang="en-US" sz="1000" b="1" dirty="0">
-                          <a:solidFill>
-                            <a:srgbClr val="000000"/>
-                          </a:solidFill>
-                        </a:rPr>
-                        <a:t>GAT_2L_ADV</a:t>
-                      </a:r>
-                      <a:endParaRPr lang="en-US" sz="1000" dirty="0"/>
-                    </a:p>
-                  </a:txBody>
-                  <a:tcPr marL="91440" marR="91440" marT="45720" marB="45720">
-                    <a:lnL w="12700" cap="flat" cmpd="sng" algn="ctr">
-                      <a:solidFill>
-                        <a:srgbClr val="CADCFC"/>
-                      </a:solidFill>
-                      <a:prstDash val="solid"/>
-                      <a:round/>
-                      <a:headEnd type="none" w="med" len="med"/>
-                      <a:tailEnd type="none" w="med" len="med"/>
-                    </a:lnL>
-                    <a:lnR w="12700" cap="flat" cmpd="sng" algn="ctr">
-                      <a:solidFill>
-                        <a:srgbClr val="CADCFC"/>
-                      </a:solidFill>
-                      <a:prstDash val="solid"/>
-                      <a:round/>
-                      <a:headEnd type="none" w="med" len="med"/>
-                      <a:tailEnd type="none" w="med" len="med"/>
-                    </a:lnR>
-                    <a:lnT w="12700" cap="flat" cmpd="sng" algn="ctr">
-                      <a:solidFill>
-                        <a:srgbClr val="CADCFC"/>
-                      </a:solidFill>
-                      <a:prstDash val="solid"/>
-                      <a:round/>
-                      <a:headEnd type="none" w="med" len="med"/>
-                      <a:tailEnd type="none" w="med" len="med"/>
-                    </a:lnT>
-                    <a:lnB w="12700" cap="flat" cmpd="sng" algn="ctr">
-                      <a:solidFill>
-                        <a:srgbClr val="CADCFC"/>
-                      </a:solidFill>
-                      <a:prstDash val="solid"/>
-                      <a:round/>
-                      <a:headEnd type="none" w="med" len="med"/>
-                      <a:tailEnd type="none" w="med" len="med"/>
-                    </a:lnB>
-                    <a:solidFill>
-                      <a:srgbClr val="FFFFFF"/>
-                    </a:solidFill>
-                  </a:tcPr>
-                </a:tc>
-                <a:tc>
-                  <a:txBody>
-                    <a:bodyPr/>
-                    <a:lstStyle/>
-                    <a:p>
-                      <a:pPr indent="0" marL="0">
-                        <a:buNone/>
-                      </a:pPr>
-                      <a:r>
-                        <a:rPr lang="en-US" sz="1000" b="1" dirty="0">
-                          <a:solidFill>
-                            <a:srgbClr val="16A085"/>
-                          </a:solidFill>
-                        </a:rPr>
-                        <a:t>✓</a:t>
-                      </a:r>
-                      <a:endParaRPr lang="en-US" sz="1000" dirty="0"/>
-                    </a:p>
-                  </a:txBody>
-                  <a:tcPr marL="91440" marR="91440" marT="45720" marB="45720">
-                    <a:lnL w="12700" cap="flat" cmpd="sng" algn="ctr">
-                      <a:solidFill>
-                        <a:srgbClr val="CADCFC"/>
-                      </a:solidFill>
-                      <a:prstDash val="solid"/>
-                      <a:round/>
-                      <a:headEnd type="none" w="med" len="med"/>
-                      <a:tailEnd type="none" w="med" len="med"/>
-                    </a:lnL>
-                    <a:lnR w="12700" cap="flat" cmpd="sng" algn="ctr">
-                      <a:solidFill>
-                        <a:srgbClr val="CADCFC"/>
-                      </a:solidFill>
-                      <a:prstDash val="solid"/>
-                      <a:round/>
-                      <a:headEnd type="none" w="med" len="med"/>
-                      <a:tailEnd type="none" w="med" len="med"/>
-                    </a:lnR>
-                    <a:lnT w="12700" cap="flat" cmpd="sng" algn="ctr">
-                      <a:solidFill>
-                        <a:srgbClr val="CADCFC"/>
-                      </a:solidFill>
-                      <a:prstDash val="solid"/>
-                      <a:round/>
-                      <a:headEnd type="none" w="med" len="med"/>
-                      <a:tailEnd type="none" w="med" len="med"/>
-                    </a:lnT>
-                    <a:lnB w="12700" cap="flat" cmpd="sng" algn="ctr">
-                      <a:solidFill>
-                        <a:srgbClr val="CADCFC"/>
-                      </a:solidFill>
-                      <a:prstDash val="solid"/>
-                      <a:round/>
-                      <a:headEnd type="none" w="med" len="med"/>
-                      <a:tailEnd type="none" w="med" len="med"/>
-                    </a:lnB>
-                    <a:solidFill>
-                      <a:srgbClr val="FFFFFF"/>
-                    </a:solidFill>
-                  </a:tcPr>
-                </a:tc>
-                <a:tc>
-                  <a:txBody>
-                    <a:bodyPr/>
-                    <a:lstStyle/>
-                    <a:p>
-                      <a:pPr indent="0" marL="0">
-                        <a:buNone/>
-                      </a:pPr>
-                      <a:r>
-                        <a:rPr lang="en-US" sz="1000" b="1" dirty="0">
-                          <a:solidFill>
-                            <a:srgbClr val="16A085"/>
-                          </a:solidFill>
-                        </a:rPr>
-                        <a:t>0.254</a:t>
-                      </a:r>
-                      <a:endParaRPr lang="en-US" sz="1000" dirty="0"/>
-                    </a:p>
-                  </a:txBody>
-                  <a:tcPr marL="91440" marR="91440" marT="45720" marB="45720">
-                    <a:lnL w="12700" cap="flat" cmpd="sng" algn="ctr">
-                      <a:solidFill>
-                        <a:srgbClr val="CADCFC"/>
-                      </a:solidFill>
-                      <a:prstDash val="solid"/>
-                      <a:round/>
-                      <a:headEnd type="none" w="med" len="med"/>
-                      <a:tailEnd type="none" w="med" len="med"/>
-                    </a:lnL>
-                    <a:lnR w="12700" cap="flat" cmpd="sng" algn="ctr">
-                      <a:solidFill>
-                        <a:srgbClr val="CADCFC"/>
-                      </a:solidFill>
-                      <a:prstDash val="solid"/>
-                      <a:round/>
-                      <a:headEnd type="none" w="med" len="med"/>
-                      <a:tailEnd type="none" w="med" len="med"/>
-                    </a:lnR>
-                    <a:lnT w="12700" cap="flat" cmpd="sng" algn="ctr">
-                      <a:solidFill>
-                        <a:srgbClr val="CADCFC"/>
-                      </a:solidFill>
-                      <a:prstDash val="solid"/>
-                      <a:round/>
-                      <a:headEnd type="none" w="med" len="med"/>
-                      <a:tailEnd type="none" w="med" len="med"/>
-                    </a:lnT>
-                    <a:lnB w="12700" cap="flat" cmpd="sng" algn="ctr">
-                      <a:solidFill>
-                        <a:srgbClr val="CADCFC"/>
-                      </a:solidFill>
-                      <a:prstDash val="solid"/>
-                      <a:round/>
-                      <a:headEnd type="none" w="med" len="med"/>
-                      <a:tailEnd type="none" w="med" len="med"/>
-                    </a:lnB>
-                    <a:solidFill>
-                      <a:srgbClr val="FFFFFF"/>
-                    </a:solidFill>
-                  </a:tcPr>
-                </a:tc>
-                <a:tc>
-                  <a:txBody>
-                    <a:bodyPr/>
-                    <a:lstStyle/>
-                    <a:p>
-                      <a:pPr indent="0" marL="0">
-                        <a:buNone/>
-                      </a:pPr>
-                      <a:r>
-                        <a:rPr lang="en-US" sz="1000" dirty="0">
-                          <a:solidFill>
-                            <a:srgbClr val="000000"/>
-                          </a:solidFill>
-                        </a:rPr>
-                        <a:t>45</a:t>
-                      </a:r>
-                      <a:endParaRPr lang="en-US" sz="1000" dirty="0"/>
-                    </a:p>
-                  </a:txBody>
-                  <a:tcPr marL="91440" marR="91440" marT="45720" marB="45720">
-                    <a:lnL w="12700" cap="flat" cmpd="sng" algn="ctr">
-                      <a:solidFill>
-                        <a:srgbClr val="CADCFC"/>
-                      </a:solidFill>
-                      <a:prstDash val="solid"/>
-                      <a:round/>
-                      <a:headEnd type="none" w="med" len="med"/>
-                      <a:tailEnd type="none" w="med" len="med"/>
-                    </a:lnL>
-                    <a:lnR w="12700" cap="flat" cmpd="sng" algn="ctr">
-                      <a:solidFill>
-                        <a:srgbClr val="CADCFC"/>
-                      </a:solidFill>
-                      <a:prstDash val="solid"/>
-                      <a:round/>
-                      <a:headEnd type="none" w="med" len="med"/>
-                      <a:tailEnd type="none" w="med" len="med"/>
-                    </a:lnR>
-                    <a:lnT w="12700" cap="flat" cmpd="sng" algn="ctr">
-                      <a:solidFill>
-                        <a:srgbClr val="CADCFC"/>
-                      </a:solidFill>
-                      <a:prstDash val="solid"/>
-                      <a:round/>
-                      <a:headEnd type="none" w="med" len="med"/>
-                      <a:tailEnd type="none" w="med" len="med"/>
-                    </a:lnT>
-                    <a:lnB w="12700" cap="flat" cmpd="sng" algn="ctr">
-                      <a:solidFill>
-                        <a:srgbClr val="CADCFC"/>
-                      </a:solidFill>
-                      <a:prstDash val="solid"/>
-                      <a:round/>
-                      <a:headEnd type="none" w="med" len="med"/>
-                      <a:tailEnd type="none" w="med" len="med"/>
-                    </a:lnB>
-                    <a:solidFill>
-                      <a:srgbClr val="FFFFFF"/>
-                    </a:solidFill>
-                  </a:tcPr>
-                </a:tc>
-              </a:tr>
-              <a:tr h="283464">
-                <a:tc>
-                  <a:txBody>
-                    <a:bodyPr/>
-                    <a:lstStyle/>
-                    <a:p>
-                      <a:pPr indent="0" marL="0">
-                        <a:buNone/>
-                      </a:pPr>
-                      <a:r>
-                        <a:rPr lang="en-US" sz="1200" dirty="0">
-                          <a:solidFill>
-                            <a:srgbClr val="000000"/>
-                          </a:solidFill>
-                        </a:rPr>
-                        <a:t>GAT_3L_ADV</a:t>
-                      </a:r>
-                      <a:endParaRPr lang="en-US" sz="1200" dirty="0"/>
-                    </a:p>
-                  </a:txBody>
-                  <a:tcPr marL="91440" marR="91440" marT="45720" marB="45720">
-                    <a:lnL w="12700" cap="flat" cmpd="sng" algn="ctr">
-                      <a:solidFill>
-                        <a:srgbClr val="CADCFC"/>
-                      </a:solidFill>
-                      <a:prstDash val="solid"/>
-                      <a:round/>
-                      <a:headEnd type="none" w="med" len="med"/>
-                      <a:tailEnd type="none" w="med" len="med"/>
-                    </a:lnL>
-                    <a:lnR w="12700" cap="flat" cmpd="sng" algn="ctr">
-                      <a:solidFill>
-                        <a:srgbClr val="CADCFC"/>
-                      </a:solidFill>
-                      <a:prstDash val="solid"/>
-                      <a:round/>
-                      <a:headEnd type="none" w="med" len="med"/>
-                      <a:tailEnd type="none" w="med" len="med"/>
-                    </a:lnR>
-                    <a:lnT w="12700" cap="flat" cmpd="sng" algn="ctr">
-                      <a:solidFill>
-                        <a:srgbClr val="CADCFC"/>
-                      </a:solidFill>
-                      <a:prstDash val="solid"/>
-                      <a:round/>
-                      <a:headEnd type="none" w="med" len="med"/>
-                      <a:tailEnd type="none" w="med" len="med"/>
-                    </a:lnT>
-                    <a:lnB w="12700" cap="flat" cmpd="sng" algn="ctr">
-                      <a:solidFill>
-                        <a:srgbClr val="CADCFC"/>
-                      </a:solidFill>
-                      <a:prstDash val="solid"/>
-                      <a:round/>
-                      <a:headEnd type="none" w="med" len="med"/>
-                      <a:tailEnd type="none" w="med" len="med"/>
-                    </a:lnB>
-                    <a:solidFill>
-                      <a:srgbClr val="FFFFFF"/>
-                    </a:solidFill>
-                  </a:tcPr>
-                </a:tc>
-                <a:tc>
-                  <a:txBody>
-                    <a:bodyPr/>
-                    <a:lstStyle/>
-                    <a:p>
-                      <a:pPr indent="0" marL="0">
-                        <a:buNone/>
-                      </a:pPr>
-                      <a:r>
-                        <a:rPr lang="en-US" sz="1200" dirty="0">
-                          <a:solidFill>
-                            <a:srgbClr val="000000"/>
-                          </a:solidFill>
-                        </a:rPr>
-                        <a:t>✓</a:t>
-                      </a:r>
-                      <a:endParaRPr lang="en-US" sz="1200" dirty="0"/>
-                    </a:p>
-                  </a:txBody>
-                  <a:tcPr marL="91440" marR="91440" marT="45720" marB="45720">
-                    <a:lnL w="12700" cap="flat" cmpd="sng" algn="ctr">
-                      <a:solidFill>
-                        <a:srgbClr val="CADCFC"/>
-                      </a:solidFill>
-                      <a:prstDash val="solid"/>
-                      <a:round/>
-                      <a:headEnd type="none" w="med" len="med"/>
-                      <a:tailEnd type="none" w="med" len="med"/>
-                    </a:lnL>
-                    <a:lnR w="12700" cap="flat" cmpd="sng" algn="ctr">
-                      <a:solidFill>
-                        <a:srgbClr val="CADCFC"/>
-                      </a:solidFill>
-                      <a:prstDash val="solid"/>
-                      <a:round/>
-                      <a:headEnd type="none" w="med" len="med"/>
-                      <a:tailEnd type="none" w="med" len="med"/>
-                    </a:lnR>
-                    <a:lnT w="12700" cap="flat" cmpd="sng" algn="ctr">
-                      <a:solidFill>
-                        <a:srgbClr val="CADCFC"/>
-                      </a:solidFill>
-                      <a:prstDash val="solid"/>
-                      <a:round/>
-                      <a:headEnd type="none" w="med" len="med"/>
-                      <a:tailEnd type="none" w="med" len="med"/>
-                    </a:lnT>
-                    <a:lnB w="12700" cap="flat" cmpd="sng" algn="ctr">
-                      <a:solidFill>
-                        <a:srgbClr val="CADCFC"/>
-                      </a:solidFill>
-                      <a:prstDash val="solid"/>
-                      <a:round/>
-                      <a:headEnd type="none" w="med" len="med"/>
-                      <a:tailEnd type="none" w="med" len="med"/>
-                    </a:lnB>
-                    <a:solidFill>
-                      <a:srgbClr val="FFFFFF"/>
-                    </a:solidFill>
-                  </a:tcPr>
-                </a:tc>
-                <a:tc>
-                  <a:txBody>
-                    <a:bodyPr/>
-                    <a:lstStyle/>
-                    <a:p>
-                      <a:pPr indent="0" marL="0">
-                        <a:buNone/>
-                      </a:pPr>
-                      <a:r>
-                        <a:rPr lang="en-US" sz="1200" dirty="0">
-                          <a:solidFill>
-                            <a:srgbClr val="000000"/>
-                          </a:solidFill>
-                        </a:rPr>
-                        <a:t>~0.250</a:t>
-                      </a:r>
-                      <a:endParaRPr lang="en-US" sz="1200" dirty="0"/>
-                    </a:p>
-                  </a:txBody>
-                  <a:tcPr marL="91440" marR="91440" marT="45720" marB="45720">
-                    <a:lnL w="12700" cap="flat" cmpd="sng" algn="ctr">
-                      <a:solidFill>
-                        <a:srgbClr val="CADCFC"/>
-                      </a:solidFill>
-                      <a:prstDash val="solid"/>
-                      <a:round/>
-                      <a:headEnd type="none" w="med" len="med"/>
-                      <a:tailEnd type="none" w="med" len="med"/>
-                    </a:lnL>
-                    <a:lnR w="12700" cap="flat" cmpd="sng" algn="ctr">
-                      <a:solidFill>
-                        <a:srgbClr val="CADCFC"/>
-                      </a:solidFill>
-                      <a:prstDash val="solid"/>
-                      <a:round/>
-                      <a:headEnd type="none" w="med" len="med"/>
-                      <a:tailEnd type="none" w="med" len="med"/>
-                    </a:lnR>
-                    <a:lnT w="12700" cap="flat" cmpd="sng" algn="ctr">
-                      <a:solidFill>
-                        <a:srgbClr val="CADCFC"/>
-                      </a:solidFill>
-                      <a:prstDash val="solid"/>
-                      <a:round/>
-                      <a:headEnd type="none" w="med" len="med"/>
-                      <a:tailEnd type="none" w="med" len="med"/>
-                    </a:lnT>
-                    <a:lnB w="12700" cap="flat" cmpd="sng" algn="ctr">
-                      <a:solidFill>
-                        <a:srgbClr val="CADCFC"/>
-                      </a:solidFill>
-                      <a:prstDash val="solid"/>
-                      <a:round/>
-                      <a:headEnd type="none" w="med" len="med"/>
-                      <a:tailEnd type="none" w="med" len="med"/>
-                    </a:lnB>
-                    <a:solidFill>
-                      <a:srgbClr val="FFFFFF"/>
-                    </a:solidFill>
-                  </a:tcPr>
-                </a:tc>
-                <a:tc>
-                  <a:txBody>
-                    <a:bodyPr/>
-                    <a:lstStyle/>
-                    <a:p>
-                      <a:pPr indent="0" marL="0">
-                        <a:buNone/>
-                      </a:pPr>
-                      <a:r>
-                        <a:rPr lang="en-US" sz="1200" dirty="0">
-                          <a:solidFill>
-                            <a:srgbClr val="000000"/>
-                          </a:solidFill>
-                        </a:rPr>
-                        <a:t>40+</a:t>
-                      </a:r>
-                      <a:endParaRPr lang="en-US" sz="1200" dirty="0"/>
-                    </a:p>
-                  </a:txBody>
-                  <a:tcPr marL="91440" marR="91440" marT="45720" marB="45720">
-                    <a:lnL w="12700" cap="flat" cmpd="sng" algn="ctr">
-                      <a:solidFill>
-                        <a:srgbClr val="CADCFC"/>
-                      </a:solidFill>
-                      <a:prstDash val="solid"/>
-                      <a:round/>
-                      <a:headEnd type="none" w="med" len="med"/>
-                      <a:tailEnd type="none" w="med" len="med"/>
-                    </a:lnL>
-                    <a:lnR w="12700" cap="flat" cmpd="sng" algn="ctr">
-                      <a:solidFill>
-                        <a:srgbClr val="CADCFC"/>
-                      </a:solidFill>
-                      <a:prstDash val="solid"/>
-                      <a:round/>
-                      <a:headEnd type="none" w="med" len="med"/>
-                      <a:tailEnd type="none" w="med" len="med"/>
-                    </a:lnR>
-                    <a:lnT w="12700" cap="flat" cmpd="sng" algn="ctr">
-                      <a:solidFill>
-                        <a:srgbClr val="CADCFC"/>
-                      </a:solidFill>
-                      <a:prstDash val="solid"/>
-                      <a:round/>
-                      <a:headEnd type="none" w="med" len="med"/>
-                      <a:tailEnd type="none" w="med" len="med"/>
-                    </a:lnT>
-                    <a:lnB w="12700" cap="flat" cmpd="sng" algn="ctr">
-                      <a:solidFill>
-                        <a:srgbClr val="CADCFC"/>
-                      </a:solidFill>
-                      <a:prstDash val="solid"/>
-                      <a:round/>
-                      <a:headEnd type="none" w="med" len="med"/>
-                      <a:tailEnd type="none" w="med" len="med"/>
-                    </a:lnB>
-                    <a:solidFill>
-                      <a:srgbClr val="FFFFFF"/>
-                    </a:solidFill>
-                  </a:tcPr>
-                </a:tc>
-              </a:tr>
-              <a:tr h="283464">
-                <a:tc>
-                  <a:txBody>
-                    <a:bodyPr/>
-                    <a:lstStyle/>
-                    <a:p>
-                      <a:pPr indent="0" marL="0">
-                        <a:buNone/>
-                      </a:pPr>
-                      <a:r>
-                        <a:rPr lang="en-US" sz="1000" i="1" dirty="0">
-                          <a:solidFill>
-                            <a:srgbClr val="888888"/>
-                          </a:solidFill>
-                        </a:rPr>
-                        <a:t>Chance</a:t>
-                      </a:r>
-                      <a:endParaRPr lang="en-US" sz="1000" dirty="0"/>
-                    </a:p>
-                  </a:txBody>
-                  <a:tcPr marL="91440" marR="91440" marT="45720" marB="45720">
-                    <a:lnL w="12700" cap="flat" cmpd="sng" algn="ctr">
-                      <a:solidFill>
-                        <a:srgbClr val="CADCFC"/>
-                      </a:solidFill>
-                      <a:prstDash val="solid"/>
-                      <a:round/>
-                      <a:headEnd type="none" w="med" len="med"/>
-                      <a:tailEnd type="none" w="med" len="med"/>
-                    </a:lnL>
-                    <a:lnR w="12700" cap="flat" cmpd="sng" algn="ctr">
-                      <a:solidFill>
-                        <a:srgbClr val="CADCFC"/>
-                      </a:solidFill>
-                      <a:prstDash val="solid"/>
-                      <a:round/>
-                      <a:headEnd type="none" w="med" len="med"/>
-                      <a:tailEnd type="none" w="med" len="med"/>
-                    </a:lnR>
-                    <a:lnT w="12700" cap="flat" cmpd="sng" algn="ctr">
-                      <a:solidFill>
-                        <a:srgbClr val="CADCFC"/>
-                      </a:solidFill>
-                      <a:prstDash val="solid"/>
-                      <a:round/>
-                      <a:headEnd type="none" w="med" len="med"/>
-                      <a:tailEnd type="none" w="med" len="med"/>
-                    </a:lnT>
-                    <a:lnB w="12700" cap="flat" cmpd="sng" algn="ctr">
-                      <a:solidFill>
-                        <a:srgbClr val="CADCFC"/>
-                      </a:solidFill>
-                      <a:prstDash val="solid"/>
-                      <a:round/>
-                      <a:headEnd type="none" w="med" len="med"/>
-                      <a:tailEnd type="none" w="med" len="med"/>
-                    </a:lnB>
-                    <a:solidFill>
-                      <a:srgbClr val="FFFFFF"/>
-                    </a:solidFill>
-                  </a:tcPr>
-                </a:tc>
-                <a:tc>
-                  <a:txBody>
-                    <a:bodyPr/>
-                    <a:lstStyle/>
-                    <a:p>
-                      <a:pPr indent="0" marL="0">
-                        <a:buNone/>
-                      </a:pPr>
-                      <a:endParaRPr lang="en-US" sz="1200" dirty="0"/>
-                    </a:p>
-                  </a:txBody>
-                  <a:tcPr marL="91440" marR="91440" marT="45720" marB="45720">
-                    <a:lnL w="12700" cap="flat" cmpd="sng" algn="ctr">
-                      <a:solidFill>
-                        <a:srgbClr val="CADCFC"/>
-                      </a:solidFill>
-                      <a:prstDash val="solid"/>
-                      <a:round/>
-                      <a:headEnd type="none" w="med" len="med"/>
-                      <a:tailEnd type="none" w="med" len="med"/>
-                    </a:lnL>
-                    <a:lnR w="12700" cap="flat" cmpd="sng" algn="ctr">
-                      <a:solidFill>
-                        <a:srgbClr val="CADCFC"/>
-                      </a:solidFill>
-                      <a:prstDash val="solid"/>
-                      <a:round/>
-                      <a:headEnd type="none" w="med" len="med"/>
-                      <a:tailEnd type="none" w="med" len="med"/>
-                    </a:lnR>
-                    <a:lnT w="12700" cap="flat" cmpd="sng" algn="ctr">
-                      <a:solidFill>
-                        <a:srgbClr val="CADCFC"/>
-                      </a:solidFill>
-                      <a:prstDash val="solid"/>
-                      <a:round/>
-                      <a:headEnd type="none" w="med" len="med"/>
-                      <a:tailEnd type="none" w="med" len="med"/>
-                    </a:lnT>
-                    <a:lnB w="12700" cap="flat" cmpd="sng" algn="ctr">
-                      <a:solidFill>
-                        <a:srgbClr val="CADCFC"/>
-                      </a:solidFill>
-                      <a:prstDash val="solid"/>
-                      <a:round/>
-                      <a:headEnd type="none" w="med" len="med"/>
-                      <a:tailEnd type="none" w="med" len="med"/>
-                    </a:lnB>
-                    <a:solidFill>
-                      <a:srgbClr val="FFFFFF"/>
-                    </a:solidFill>
-                  </a:tcPr>
-                </a:tc>
-                <a:tc>
-                  <a:txBody>
-                    <a:bodyPr/>
-                    <a:lstStyle/>
-                    <a:p>
-                      <a:pPr indent="0" marL="0">
-                        <a:buNone/>
-                      </a:pPr>
-                      <a:r>
-                        <a:rPr lang="en-US" sz="1000" i="1" dirty="0">
-                          <a:solidFill>
-                            <a:srgbClr val="888888"/>
-                          </a:solidFill>
-                        </a:rPr>
-                        <a:t>0.250</a:t>
-                      </a:r>
-                      <a:endParaRPr lang="en-US" sz="1000" dirty="0"/>
-                    </a:p>
-                  </a:txBody>
-                  <a:tcPr marL="91440" marR="91440" marT="45720" marB="45720">
-                    <a:lnL w="12700" cap="flat" cmpd="sng" algn="ctr">
-                      <a:solidFill>
-                        <a:srgbClr val="CADCFC"/>
-                      </a:solidFill>
-                      <a:prstDash val="solid"/>
-                      <a:round/>
-                      <a:headEnd type="none" w="med" len="med"/>
-                      <a:tailEnd type="none" w="med" len="med"/>
-                    </a:lnL>
-                    <a:lnR w="12700" cap="flat" cmpd="sng" algn="ctr">
-                      <a:solidFill>
-                        <a:srgbClr val="CADCFC"/>
-                      </a:solidFill>
-                      <a:prstDash val="solid"/>
-                      <a:round/>
-                      <a:headEnd type="none" w="med" len="med"/>
-                      <a:tailEnd type="none" w="med" len="med"/>
-                    </a:lnR>
-                    <a:lnT w="12700" cap="flat" cmpd="sng" algn="ctr">
-                      <a:solidFill>
-                        <a:srgbClr val="CADCFC"/>
-                      </a:solidFill>
-                      <a:prstDash val="solid"/>
-                      <a:round/>
-                      <a:headEnd type="none" w="med" len="med"/>
-                      <a:tailEnd type="none" w="med" len="med"/>
-                    </a:lnT>
-                    <a:lnB w="12700" cap="flat" cmpd="sng" algn="ctr">
-                      <a:solidFill>
-                        <a:srgbClr val="CADCFC"/>
-                      </a:solidFill>
-                      <a:prstDash val="solid"/>
-                      <a:round/>
-                      <a:headEnd type="none" w="med" len="med"/>
-                      <a:tailEnd type="none" w="med" len="med"/>
-                    </a:lnB>
-                    <a:solidFill>
-                      <a:srgbClr val="FFFFFF"/>
-                    </a:solidFill>
-                  </a:tcPr>
-                </a:tc>
-                <a:tc>
-                  <a:txBody>
-                    <a:bodyPr/>
-                    <a:lstStyle/>
-                    <a:p>
-                      <a:pPr indent="0" marL="0">
-                        <a:buNone/>
-                      </a:pPr>
-                      <a:endParaRPr lang="en-US" sz="1200" dirty="0"/>
-                    </a:p>
-                  </a:txBody>
-                  <a:tcPr marL="91440" marR="91440" marT="45720" marB="45720">
-                    <a:lnL w="12700" cap="flat" cmpd="sng" algn="ctr">
-                      <a:solidFill>
-                        <a:srgbClr val="CADCFC"/>
-                      </a:solidFill>
-                      <a:prstDash val="solid"/>
-                      <a:round/>
-                      <a:headEnd type="none" w="med" len="med"/>
-                      <a:tailEnd type="none" w="med" len="med"/>
-                    </a:lnL>
-                    <a:lnR w="12700" cap="flat" cmpd="sng" algn="ctr">
-                      <a:solidFill>
-                        <a:srgbClr val="CADCFC"/>
-                      </a:solidFill>
-                      <a:prstDash val="solid"/>
-                      <a:round/>
-                      <a:headEnd type="none" w="med" len="med"/>
-                      <a:tailEnd type="none" w="med" len="med"/>
-                    </a:lnR>
-                    <a:lnT w="12700" cap="flat" cmpd="sng" algn="ctr">
-                      <a:solidFill>
-                        <a:srgbClr val="CADCFC"/>
-                      </a:solidFill>
-                      <a:prstDash val="solid"/>
-                      <a:round/>
-                      <a:headEnd type="none" w="med" len="med"/>
-                      <a:tailEnd type="none" w="med" len="med"/>
-                    </a:lnT>
-                    <a:lnB w="12700" cap="flat" cmpd="sng" algn="ctr">
-                      <a:solidFill>
-                        <a:srgbClr val="CADCFC"/>
-                      </a:solidFill>
-                      <a:prstDash val="solid"/>
-                      <a:round/>
-                      <a:headEnd type="none" w="med" len="med"/>
-                      <a:tailEnd type="none" w="med" len="med"/>
-                    </a:lnB>
-                    <a:solidFill>
-                      <a:srgbClr val="FFFFFF"/>
-                    </a:solidFill>
-                  </a:tcPr>
-                </a:tc>
-              </a:tr>
-            </a:tbl>
-          </a:graphicData>
-        </a:graphic>
-      </p:graphicFrame>
-      <p:sp>
-        <p:nvSpPr>
-          <p:cNvPr id="23" name="Shape 20"/>
-          <p:cNvSpPr/>
-          <p:nvPr/>
-        </p:nvSpPr>
-        <p:spPr>
-          <a:xfrm>
-            <a:off x="365760" y="4709160"/>
-            <a:ext cx="8412480" cy="320040"/>
+          <p:cNvPr id="53" name="BgWarn"/>
+          <p:cNvSpPr/>
+          <p:nvPr/>
+        </p:nvSpPr>
+        <p:spPr>
+          <a:xfrm>
+            <a:off x="4300000" y="2800000"/>
+            <a:ext cx="4600000" cy="480000"/>
           </a:xfrm>
           <a:prstGeom prst="rect">
             <a:avLst/>
@@ -11990,7 +11674,7 @@
           <a:solidFill>
             <a:srgbClr val="FFF3CD"/>
           </a:solidFill>
-          <a:ln w="12700">
+          <a:ln w="25400">
             <a:solidFill>
               <a:srgbClr val="F0AD4E"/>
             </a:solidFill>
@@ -12000,14 +11684,14 @@
       </p:sp>
       <p:sp>
         <p:nvSpPr>
-          <p:cNvPr id="24" name="Text 21"/>
-          <p:cNvSpPr/>
-          <p:nvPr/>
-        </p:nvSpPr>
-        <p:spPr>
-          <a:xfrm>
-            <a:off x="457200" y="4709160"/>
-            <a:ext cx="8229600" cy="320040"/>
+          <p:cNvPr id="54" name="TxtWarn"/>
+          <p:cNvSpPr/>
+          <p:nvPr/>
+        </p:nvSpPr>
+        <p:spPr>
+          <a:xfrm>
+            <a:off x="4420000" y="2860000"/>
+            <a:ext cx="4360000" cy="360000"/>
           </a:xfrm>
           <a:prstGeom prst="rect">
             <a:avLst/>
@@ -12016,41 +11700,114 @@
           <a:ln/>
         </p:spPr>
         <p:txBody>
-          <a:bodyPr wrap="square" rtlCol="0" anchor="ctr"/>
+          <a:bodyPr wrap="square" rtlCol="0" anchor="t"/>
           <a:lstStyle/>
           <a:p>
-            <a:pPr indent="0" marL="0">
+            <a:pPr algn="l" indent="0" marL="0">
               <a:buNone/>
             </a:pPr>
             <a:r>
-              <a:rPr lang="en-US" sz="1100" dirty="0">
-                <a:solidFill>
-                  <a:srgbClr val="8A6D3B"/>
-                </a:solidFill>
-                <a:latin typeface="Calibri" pitchFamily="34" charset="0"/>
-                <a:ea typeface="Calibri" pitchFamily="34" charset="-122"/>
-                <a:cs typeface="Calibri" pitchFamily="34" charset="-120"/>
-              </a:rPr>
-              <a:t>⚠ train_acc max 0.32 — underfitting semantico (nessun gap train/val)</a:t>
-            </a:r>
-            <a:endParaRPr lang="en-US" sz="1100" dirty="0"/>
-          </a:p>
-          <a:p>
-            <a:pPr indent="0" marL="0">
+              <a:rPr lang="it-IT" sz="1100" b="1" dirty="0">
+                <a:solidFill>
+                  <a:srgbClr val="856404"/>
+                </a:solidFill>
+                <a:latin typeface="Calibri" pitchFamily="34" charset="0"/>
+              </a:rPr>
+              <a:t>⚠  Diagnosi: underfitting semantico</a:t>
+            </a:r>
+            <a:endParaRPr lang="it-IT" sz="1100" dirty="0"/>
+          </a:p>
+          <a:p>
+            <a:pPr algn="l" indent="0" marL="0">
               <a:buNone/>
             </a:pPr>
             <a:r>
-              <a:rPr lang="en-US" sz="1100" dirty="0">
-                <a:solidFill>
-                  <a:srgbClr val="8A6D3B"/>
-                </a:solidFill>
-                <a:latin typeface="Calibri" pitchFamily="34" charset="0"/>
-                <a:ea typeface="Calibri" pitchFamily="34" charset="-122"/>
-                <a:cs typeface="Calibri" pitchFamily="34" charset="-120"/>
-              </a:rPr>
-              <a:t>v1: patience=15 → alpha≈0.38, GRL non efficace | v2: patience=40 → alpha→1.0, stesso risultato</a:t>
-            </a:r>
-            <a:endParaRPr lang="en-US" sz="1100" dirty="0"/>
+              <a:rPr lang="it-IT" sz="1050" dirty="0">
+                <a:solidFill>
+                  <a:srgbClr val="856404"/>
+                </a:solidFill>
+                <a:latin typeface="Calibri" pitchFamily="34" charset="0"/>
+              </a:rPr>
+              <a:t>train_acc max 0.32 — nessun gap train/val (il modello non fitta il training set)</a:t>
+            </a:r>
+            <a:endParaRPr lang="it-IT" sz="1050" dirty="0"/>
+          </a:p>
+        </p:txBody>
+      </p:sp>
+      <p:sp>
+        <p:nvSpPr>
+          <p:cNvPr id="55" name="BgV1V2"/>
+          <p:cNvSpPr/>
+          <p:nvPr/>
+        </p:nvSpPr>
+        <p:spPr>
+          <a:xfrm>
+            <a:off x="4300000" y="3400000"/>
+            <a:ext cx="4600000" cy="520000"/>
+          </a:xfrm>
+          <a:prstGeom prst="rect">
+            <a:avLst/>
+          </a:prstGeom>
+          <a:solidFill>
+            <a:srgbClr val="F8D7DA"/>
+          </a:solidFill>
+          <a:ln w="25400">
+            <a:solidFill>
+              <a:srgbClr val="E74C3C"/>
+            </a:solidFill>
+            <a:prstDash val="solid"/>
+          </a:ln>
+        </p:spPr>
+      </p:sp>
+      <p:sp>
+        <p:nvSpPr>
+          <p:cNvPr id="56" name="TxtV1V2"/>
+          <p:cNvSpPr/>
+          <p:nvPr/>
+        </p:nvSpPr>
+        <p:spPr>
+          <a:xfrm>
+            <a:off x="4420000" y="3460000"/>
+            <a:ext cx="4360000" cy="400000"/>
+          </a:xfrm>
+          <a:prstGeom prst="rect">
+            <a:avLst/>
+          </a:prstGeom>
+          <a:noFill/>
+          <a:ln/>
+        </p:spPr>
+        <p:txBody>
+          <a:bodyPr wrap="square" rtlCol="0" anchor="t"/>
+          <a:lstStyle/>
+          <a:p>
+            <a:pPr algn="l" indent="0" marL="0">
+              <a:buNone/>
+            </a:pPr>
+            <a:r>
+              <a:rPr lang="it-IT" sz="1050" dirty="0">
+                <a:solidFill>
+                  <a:srgbClr val="721C24"/>
+                </a:solidFill>
+                <a:latin typeface="Calibri" pitchFamily="34" charset="0"/>
+              </a:rPr>
+              <a:t>v1: patience=15 → α≈0.38, GRL non efficace (stop troppo presto)</a:t>
+            </a:r>
+            <a:endParaRPr lang="it-IT" sz="1050" dirty="0"/>
+          </a:p>
+          <a:p>
+            <a:pPr algn="l" indent="0" marL="0">
+              <a:buNone/>
+            </a:pPr>
+            <a:r>
+              <a:rPr lang="it-IT" sz="1050" dirty="0">
+                <a:solidFill>
+                  <a:srgbClr val="721C24"/>
+                </a:solidFill>
+                <a:latin typeface="Calibri" pitchFamily="34" charset="0"/>
+              </a:rPr>
+              <a:t>v2: patience=40, λ=0.5 → α→1.0, stesso risultato — segnale semantico ε²=0.03 insufficiente</a:t>
+            </a:r>
+            <a:endParaRPr lang="it-IT" sz="1050" dirty="0"/>
           </a:p>
         </p:txBody>
       </p:sp>

</xml_diff>

<commit_message>
docs: aggiungi slide concr4 (slide 5) — clustering semantico e gestione sbilanciamento
- Nuova slide inserita dopo Pipeline (slide 4), prima di Progressione (slide 6)
- Tabella 4 classi con distribuzione reale: ASTRATTO 67/110 (~40%),
  AZIONE 17 (~25%), STATO 11 (~19%), CONCRETO 15 (~16%)
- Esempi di parole per ogni classe dal dataset reale
- 4 ragioni per cui e un buon schema: validita psycolinguistica (Brysbaert 2014),
  correlati neurali distinti, stabilita cross-subject, confronto vs 110 classi
- Spiegazione gestione sbilanciamento: class weights + Balanced Accuracy
- Note relatore con risposta alla domanda "perche ASTRATTO ha piu parole?"

Co-Authored-By: Claude Sonnet 4.6 <noreply@anthropic.com>
</commit_message>
<xml_diff>
--- a/docs/presentation_stato_lavori_apr2026.pptx
+++ b/docs/presentation_stato_lavori_apr2026.pptx
@@ -4,11 +4,15 @@
   <p:sldMasterIdLst>
     <p:sldMasterId id="2147483648" r:id="rId1"/>
   </p:sldMasterIdLst>
+  <p:notesMasterIdLst>
+    <p:notesMasterId r:id="rId15"/>
+  </p:notesMasterIdLst>
   <p:sldIdLst>
     <p:sldId id="256" r:id="rId2"/>
     <p:sldId id="257" r:id="rId3"/>
     <p:sldId id="258" r:id="rId4"/>
     <p:sldId id="259" r:id="rId5"/>
+    <p:sldId id="269" r:id="rId20"/>
     <p:sldId id="260" r:id="rId6"/>
     <p:sldId id="261" r:id="rId7"/>
     <p:sldId id="262" r:id="rId8"/>
@@ -19,9 +23,6 @@
     <p:sldId id="267" r:id="rId13"/>
     <p:sldId id="268" r:id="rId14"/>
   </p:sldIdLst>
-  <p:notesMasterIdLst>
-    <p:notesMasterId r:id="rId15"/>
-  </p:notesMasterIdLst>
   <p:sldSz cx="9144000" cy="5143500"/>
   <p:notesSz cx="5143500" cy="9144000"/>
   <p:defaultTextStyle>
@@ -1013,6 +1014,101 @@
         <p14:creationId xmlns:p14="http://schemas.microsoft.com/office/powerpoint/2010/main" val="1024086991"/>
       </p:ext>
     </p:extLst>
+  </p:cSld>
+  <p:clrMapOvr>
+    <a:masterClrMapping/>
+  </p:clrMapOvr>
+</p:notes>
+</file>
+
+<file path=ppt/notesSlides/notesSlide14.xml><?xml version="1.0" encoding="utf-8"?>
+<p:notes xmlns:a="http://schemas.openxmlformats.org/drawingml/2006/main" xmlns:r="http://schemas.openxmlformats.org/officeDocument/2006/relationships" xmlns:p="http://schemas.openxmlformats.org/presentationml/2006/main">
+  <p:cSld>
+    <p:spTree>
+      <p:nvGrpSpPr>
+        <p:cNvPr id="1" name=""/>
+        <p:cNvGrpSpPr/>
+        <p:nvPr/>
+      </p:nvGrpSpPr>
+      <p:grpSpPr>
+        <a:xfrm>
+          <a:off x="0" y="0"/>
+          <a:ext cx="0" cy="0"/>
+          <a:chOff x="0" y="0"/>
+          <a:chExt cx="0" cy="0"/>
+        </a:xfrm>
+      </p:grpSpPr>
+      <p:sp>
+        <p:nvSpPr>
+          <p:cNvPr id="2" name="Slide Image Placeholder 1"/>
+          <p:cNvSpPr>
+            <a:spLocks noGrp="1" noRot="1" noChangeAspect="1"/>
+          </p:cNvSpPr>
+          <p:nvPr>
+            <p:ph type="sldImg"/>
+          </p:nvPr>
+        </p:nvSpPr>
+        <p:spPr/>
+      </p:sp>
+      <p:sp>
+        <p:nvSpPr>
+          <p:cNvPr id="3" name="Notes Placeholder 2"/>
+          <p:cNvSpPr>
+            <a:spLocks noGrp="1"/>
+          </p:cNvSpPr>
+          <p:nvPr>
+            <p:ph type="body" idx="1"/>
+          </p:nvPr>
+        </p:nvSpPr>
+        <p:spPr/>
+        <p:txBody>
+          <a:bodyPr/>
+          <a:lstStyle/>
+          <a:p>
+            <a:r>
+              <a:rPr lang="it-IT" dirty="0"/>
+              <a:t>Il concr4 e lo schema di clustering usato in tutti gli esperimenti da EEG_05 in poi. Le 110 parole sono raggruppate in 4 classi basate sui Brysbaert concreteness norms (2014), un dataset psycolinguistico validato su migliaia di parlanti nativi.</a:t>
+            </a:r>
+            <a:endParaRPr lang="it-IT" dirty="0"/>
+          </a:p>
+          <a:p>
+            <a:r>
+              <a:rPr lang="it-IT" dirty="0"/>
+              <a:t>ASTRATTO (67 parole, ~40% trial): parole funzionali, pronomi, avverbi, verbi modali — tutto cio che ha bassa concretezza percettiva.</a:t>
+            </a:r>
+            <a:endParaRPr lang="it-IT" dirty="0"/>
+          </a:p>
+          <a:p>
+            <a:r>
+              <a:rPr lang="it-IT" dirty="0"/>
+              <a:t>AZIONE (17 parole, ~25%): verbi di movimento e azione fisica — andare, arrivare, aprire. STATO (11 parole, ~19%): stati emotivi e mentali — ansia, gioia, dolore. CONCRETO (15 parole, ~16%): oggetti fisici percepibili — acqua, computer, macchina.</a:t>
+            </a:r>
+            <a:endParaRPr lang="it-IT" dirty="0"/>
+          </a:p>
+          <a:p>
+            <a:r>
+              <a:rPr lang="it-IT" dirty="0"/>
+              <a:t>Domanda probabile: perche ASTRATTO ha cosi tante parole? Risposta: riflette la distribuzione reale del lessico italiano — ci sono oggettivamente piu parole astratte che concrete. Non e un problema di design, e una proprieta della lingua.</a:t>
+            </a:r>
+            <a:endParaRPr lang="it-IT" dirty="0"/>
+          </a:p>
+          <a:p>
+            <a:r>
+              <a:rPr lang="it-IT" dirty="0"/>
+              <a:t>Lo sbilanciamento e gestito a due livelli: (1) training: class weights inverso alla frequenza evitano il class collapse; (2) evaluation: Balanced Accuracy calcola la media delle accuracy per classe, quindi 25% rimane il chance level anche con distribuzioni asimmetriche.</a:t>
+            </a:r>
+            <a:endParaRPr lang="it-IT" dirty="0"/>
+          </a:p>
+          <a:p>
+            <a:r>
+              <a:rPr lang="it-IT" dirty="0"/>
+              <a:t>Perche non Ward? L'analisi EEG_00 ha mostrato ARI cross-soggetto ~0 per il Ward clustering data-driven: i cluster cambiano completamente da soggetto a soggetto. concr4 e deterministico, stabile, e motivato da letteratura psycolinguistica consolidata.</a:t>
+            </a:r>
+            <a:endParaRPr lang="it-IT" dirty="0"/>
+          </a:p>
+        </p:txBody>
+      </p:sp>
+    </p:spTree>
   </p:cSld>
   <p:clrMapOvr>
     <a:masterClrMapping/>
@@ -4923,6 +5019,1762 @@
 </p:sld>
 </file>
 
+<file path=ppt/slides/slide14.xml><?xml version="1.0" encoding="utf-8"?>
+<p:sld xmlns:a="http://schemas.openxmlformats.org/drawingml/2006/main" xmlns:r="http://schemas.openxmlformats.org/officeDocument/2006/relationships" xmlns:p="http://schemas.openxmlformats.org/presentationml/2006/main">
+  <p:cSld name="Slide concr4">
+    <p:bg>
+      <p:bgPr>
+        <a:solidFill>
+          <a:srgbClr val="F4F6FB"/>
+        </a:solidFill>
+      </p:bgPr>
+    </p:bg>
+    <p:spTree>
+      <p:nvGrpSpPr>
+        <p:cNvPr id="1" name=""/>
+        <p:cNvGrpSpPr/>
+        <p:nvPr/>
+      </p:nvGrpSpPr>
+      <p:grpSpPr>
+        <a:xfrm>
+          <a:off x="0" y="0"/>
+          <a:ext cx="0" cy="0"/>
+          <a:chOff x="0" y="0"/>
+          <a:chExt cx="0" cy="0"/>
+        </a:xfrm>
+      </p:grpSpPr>
+      <p:sp>
+        <p:nvSpPr>
+          <p:cNvPr id="2" name="TitleBg"/>
+          <p:cNvSpPr/>
+          <p:nvPr/>
+        </p:nvSpPr>
+        <p:spPr>
+          <a:xfrm>
+            <a:off x="0" y="0"/>
+            <a:ext cx="9144000" cy="685800"/>
+          </a:xfrm>
+          <a:prstGeom prst="rect">
+            <a:avLst/>
+          </a:prstGeom>
+          <a:solidFill>
+            <a:srgbClr val="1E2761"/>
+          </a:solidFill>
+          <a:ln w="25400">
+            <a:solidFill>
+              <a:srgbClr val="1E2761"/>
+            </a:solidFill>
+            <a:prstDash val="solid"/>
+          </a:ln>
+        </p:spPr>
+      </p:sp>
+      <p:sp>
+        <p:nvSpPr>
+          <p:cNvPr id="3" name="TitleTxt"/>
+          <p:cNvSpPr/>
+          <p:nvPr/>
+        </p:nvSpPr>
+        <p:spPr>
+          <a:xfrm>
+            <a:off x="457200" y="0"/>
+            <a:ext cx="8686800" cy="685800"/>
+          </a:xfrm>
+          <a:prstGeom prst="rect">
+            <a:avLst/>
+          </a:prstGeom>
+          <a:noFill/>
+          <a:ln/>
+        </p:spPr>
+        <p:txBody>
+          <a:bodyPr wrap="square" rtlCol="0" anchor="ctr"/>
+          <a:lstStyle/>
+          <a:p>
+            <a:pPr algn="l" indent="0" marL="0">
+              <a:buNone/>
+            </a:pPr>
+            <a:r>
+              <a:rPr lang="it-IT" sz="2200" b="1" dirty="0">
+                <a:solidFill>
+                  <a:srgbClr val="FFFFFF"/>
+                </a:solidFill>
+                <a:latin typeface="Calibri" pitchFamily="34" charset="0"/>
+              </a:rPr>
+              <a:t>Schema concr4 — Clustering Semantico delle 110 Parole</a:t>
+            </a:r>
+            <a:endParaRPr lang="it-IT" sz="2200" dirty="0"/>
+          </a:p>
+        </p:txBody>
+      </p:sp>
+      <p:sp>
+        <p:nvSpPr>
+          <p:cNvPr id="4" name="LHdrBg"/>
+          <p:cNvSpPr/>
+          <p:nvPr/>
+        </p:nvSpPr>
+        <p:spPr>
+          <a:xfrm>
+            <a:off x="320000" y="845800"/>
+            <a:ext cx="4600000" cy="300000"/>
+          </a:xfrm>
+          <a:prstGeom prst="rect">
+            <a:avLst/>
+          </a:prstGeom>
+          <a:solidFill>
+            <a:srgbClr val="1E2761"/>
+          </a:solidFill>
+          <a:ln w="25400">
+            <a:solidFill>
+              <a:srgbClr val="1E2761"/>
+            </a:solidFill>
+            <a:prstDash val="solid"/>
+          </a:ln>
+        </p:spPr>
+      </p:sp>
+      <p:sp>
+        <p:nvSpPr>
+          <p:cNvPr id="5" name="LHdrTxt"/>
+          <p:cNvSpPr/>
+          <p:nvPr/>
+        </p:nvSpPr>
+        <p:spPr>
+          <a:xfrm>
+            <a:off x="320000" y="845800"/>
+            <a:ext cx="4600000" cy="300000"/>
+          </a:xfrm>
+          <a:prstGeom prst="rect">
+            <a:avLst/>
+          </a:prstGeom>
+          <a:noFill/>
+          <a:ln/>
+        </p:spPr>
+        <p:txBody>
+          <a:bodyPr wrap="square" rtlCol="0" anchor="ctr"/>
+          <a:lstStyle/>
+          <a:p>
+            <a:pPr algn="ctr" indent="0" marL="0">
+              <a:buNone/>
+            </a:pPr>
+            <a:r>
+              <a:rPr lang="it-IT" sz="1200" b="1" dirty="0">
+                <a:solidFill>
+                  <a:srgbClr val="CADCFC"/>
+                </a:solidFill>
+                <a:latin typeface="Calibri" pitchFamily="34" charset="0"/>
+              </a:rPr>
+              <a:t>Distribuzione delle 110 parole in 4 classi</a:t>
+            </a:r>
+            <a:endParaRPr lang="it-IT" sz="1200" dirty="0"/>
+          </a:p>
+        </p:txBody>
+      </p:sp>
+      <p:sp>
+        <p:nvSpPr>
+          <p:cNvPr id="6" name="TblColHdrBg"/>
+          <p:cNvSpPr/>
+          <p:nvPr/>
+        </p:nvSpPr>
+        <p:spPr>
+          <a:xfrm>
+            <a:off x="320000" y="1145800"/>
+            <a:ext cx="4600000" cy="280000"/>
+          </a:xfrm>
+          <a:prstGeom prst="rect">
+            <a:avLst/>
+          </a:prstGeom>
+          <a:solidFill>
+            <a:srgbClr val="2C3E7A"/>
+          </a:solidFill>
+          <a:ln w="25400">
+            <a:solidFill>
+              <a:srgbClr val="2C3E7A"/>
+            </a:solidFill>
+            <a:prstDash val="solid"/>
+          </a:ln>
+        </p:spPr>
+      </p:sp>
+      <p:sp>
+        <p:nvSpPr>
+          <p:cNvPr id="8" name="THdr0"/>
+          <p:cNvSpPr/>
+          <p:nvPr/>
+        </p:nvSpPr>
+        <p:spPr>
+          <a:xfrm>
+            <a:off x="380000" y="1145800"/>
+            <a:ext cx="1740000" cy="280000"/>
+          </a:xfrm>
+          <a:prstGeom prst="rect">
+            <a:avLst/>
+          </a:prstGeom>
+          <a:noFill/>
+          <a:ln/>
+        </p:spPr>
+        <p:txBody>
+          <a:bodyPr wrap="square" rtlCol="0" anchor="ctr"/>
+          <a:lstStyle/>
+          <a:p>
+            <a:pPr algn="l" indent="0" marL="0">
+              <a:buNone/>
+            </a:pPr>
+            <a:r>
+              <a:rPr lang="it-IT" sz="1000" b="1" dirty="0">
+                <a:solidFill>
+                  <a:srgbClr val="FFFFFF"/>
+                </a:solidFill>
+                <a:latin typeface="Calibri" pitchFamily="34" charset="0"/>
+              </a:rPr>
+              <a:t>Classe</a:t>
+            </a:r>
+            <a:endParaRPr lang="it-IT" sz="1000" dirty="0"/>
+          </a:p>
+        </p:txBody>
+      </p:sp>
+      <p:sp>
+        <p:nvSpPr>
+          <p:cNvPr id="9" name="THdr1"/>
+          <p:cNvSpPr/>
+          <p:nvPr/>
+        </p:nvSpPr>
+        <p:spPr>
+          <a:xfrm>
+            <a:off x="2180000" y="1145800"/>
+            <a:ext cx="390000" cy="280000"/>
+          </a:xfrm>
+          <a:prstGeom prst="rect">
+            <a:avLst/>
+          </a:prstGeom>
+          <a:noFill/>
+          <a:ln/>
+        </p:spPr>
+        <p:txBody>
+          <a:bodyPr wrap="square" rtlCol="0" anchor="ctr"/>
+          <a:lstStyle/>
+          <a:p>
+            <a:pPr algn="ctr" indent="0" marL="0">
+              <a:buNone/>
+            </a:pPr>
+            <a:r>
+              <a:rPr lang="it-IT" sz="1000" b="1" dirty="0">
+                <a:solidFill>
+                  <a:srgbClr val="FFFFFF"/>
+                </a:solidFill>
+                <a:latin typeface="Calibri" pitchFamily="34" charset="0"/>
+              </a:rPr>
+              <a:t>N parole</a:t>
+            </a:r>
+            <a:endParaRPr lang="it-IT" sz="1000" dirty="0"/>
+          </a:p>
+        </p:txBody>
+      </p:sp>
+      <p:sp>
+        <p:nvSpPr>
+          <p:cNvPr id="10" name="THdr2"/>
+          <p:cNvSpPr/>
+          <p:nvPr/>
+        </p:nvSpPr>
+        <p:spPr>
+          <a:xfrm>
+            <a:off x="2630000" y="1145800"/>
+            <a:ext cx="640000" cy="280000"/>
+          </a:xfrm>
+          <a:prstGeom prst="rect">
+            <a:avLst/>
+          </a:prstGeom>
+          <a:noFill/>
+          <a:ln/>
+        </p:spPr>
+        <p:txBody>
+          <a:bodyPr wrap="square" rtlCol="0" anchor="ctr"/>
+          <a:lstStyle/>
+          <a:p>
+            <a:pPr algn="ctr" indent="0" marL="0">
+              <a:buNone/>
+            </a:pPr>
+            <a:r>
+              <a:rPr lang="it-IT" sz="1000" b="1" dirty="0">
+                <a:solidFill>
+                  <a:srgbClr val="FFFFFF"/>
+                </a:solidFill>
+                <a:latin typeface="Calibri" pitchFamily="34" charset="0"/>
+              </a:rPr>
+              <a:t>% trial</a:t>
+            </a:r>
+            <a:endParaRPr lang="it-IT" sz="1000" dirty="0"/>
+          </a:p>
+        </p:txBody>
+      </p:sp>
+      <p:sp>
+        <p:nvSpPr>
+          <p:cNvPr id="11" name="THdr3"/>
+          <p:cNvSpPr/>
+          <p:nvPr/>
+        </p:nvSpPr>
+        <p:spPr>
+          <a:xfrm>
+            <a:off x="3330000" y="1145800"/>
+            <a:ext cx="1440000" cy="280000"/>
+          </a:xfrm>
+          <a:prstGeom prst="rect">
+            <a:avLst/>
+          </a:prstGeom>
+          <a:noFill/>
+          <a:ln/>
+        </p:spPr>
+        <p:txBody>
+          <a:bodyPr wrap="square" rtlCol="0" anchor="ctr"/>
+          <a:lstStyle/>
+          <a:p>
+            <a:pPr algn="ctr" indent="0" marL="0">
+              <a:buNone/>
+            </a:pPr>
+            <a:r>
+              <a:rPr lang="it-IT" sz="1000" b="1" dirty="0">
+                <a:solidFill>
+                  <a:srgbClr val="FFFFFF"/>
+                </a:solidFill>
+                <a:latin typeface="Calibri" pitchFamily="34" charset="0"/>
+              </a:rPr>
+              <a:t>Esempi (dal dataset)</a:t>
+            </a:r>
+            <a:endParaRPr lang="it-IT" sz="1000" dirty="0"/>
+          </a:p>
+        </p:txBody>
+      </p:sp>
+      <p:sp>
+        <p:nvSpPr>
+          <p:cNvPr id="12" name="RowBg0"/>
+          <p:cNvSpPr/>
+          <p:nvPr/>
+        </p:nvSpPr>
+        <p:spPr>
+          <a:xfrm>
+            <a:off x="320000" y="1425800"/>
+            <a:ext cx="4600000" cy="360000"/>
+          </a:xfrm>
+          <a:prstGeom prst="rect">
+            <a:avLst/>
+          </a:prstGeom>
+          <a:solidFill>
+            <a:srgbClr val="E8EDF8"/>
+          </a:solidFill>
+          <a:ln w="12700">
+            <a:solidFill>
+              <a:srgbClr val="CADCFC"/>
+            </a:solidFill>
+            <a:prstDash val="solid"/>
+          </a:ln>
+        </p:spPr>
+      </p:sp>
+      <p:sp>
+        <p:nvSpPr>
+          <p:cNvPr id="13" name="RowAccent0"/>
+          <p:cNvSpPr/>
+          <p:nvPr/>
+        </p:nvSpPr>
+        <p:spPr>
+          <a:xfrm>
+            <a:off x="320000" y="1425800"/>
+            <a:ext cx="30000" cy="360000"/>
+          </a:xfrm>
+          <a:prstGeom prst="rect">
+            <a:avLst/>
+          </a:prstGeom>
+          <a:solidFill>
+            <a:srgbClr val="1E2761"/>
+          </a:solidFill>
+          <a:ln w="25400">
+            <a:solidFill>
+              <a:srgbClr val="1E2761"/>
+            </a:solidFill>
+            <a:prstDash val="solid"/>
+          </a:ln>
+        </p:spPr>
+      </p:sp>
+      <p:sp>
+        <p:nvSpPr>
+          <p:cNvPr id="14" name="RC0_0"/>
+          <p:cNvSpPr/>
+          <p:nvPr/>
+        </p:nvSpPr>
+        <p:spPr>
+          <a:xfrm>
+            <a:off x="380000" y="1425800"/>
+            <a:ext cx="1740000" cy="360000"/>
+          </a:xfrm>
+          <a:prstGeom prst="rect">
+            <a:avLst/>
+          </a:prstGeom>
+          <a:noFill/>
+          <a:ln/>
+        </p:spPr>
+        <p:txBody>
+          <a:bodyPr wrap="square" rtlCol="0" anchor="ctr"/>
+          <a:lstStyle/>
+          <a:p>
+            <a:pPr algn="l" indent="0" marL="0">
+              <a:buNone/>
+            </a:pPr>
+            <a:r>
+              <a:rPr lang="it-IT" sz="1050" b="1" dirty="0">
+                <a:solidFill>
+                  <a:srgbClr val="1E2761"/>
+                </a:solidFill>
+                <a:latin typeface="Calibri" pitchFamily="34" charset="0"/>
+              </a:rPr>
+              <a:t>ASTRATTO</a:t>
+            </a:r>
+            <a:endParaRPr lang="it-IT" sz="1050" dirty="0"/>
+          </a:p>
+        </p:txBody>
+      </p:sp>
+      <p:sp>
+        <p:nvSpPr>
+          <p:cNvPr id="15" name="RC0_1"/>
+          <p:cNvSpPr/>
+          <p:nvPr/>
+        </p:nvSpPr>
+        <p:spPr>
+          <a:xfrm>
+            <a:off x="2180000" y="1425800"/>
+            <a:ext cx="390000" cy="360000"/>
+          </a:xfrm>
+          <a:prstGeom prst="rect">
+            <a:avLst/>
+          </a:prstGeom>
+          <a:noFill/>
+          <a:ln/>
+        </p:spPr>
+        <p:txBody>
+          <a:bodyPr wrap="square" rtlCol="0" anchor="ctr"/>
+          <a:lstStyle/>
+          <a:p>
+            <a:pPr algn="ctr" indent="0" marL="0">
+              <a:buNone/>
+            </a:pPr>
+            <a:r>
+              <a:rPr lang="it-IT" sz="1050" dirty="0">
+                <a:solidFill>
+                  <a:srgbClr val="333333"/>
+                </a:solidFill>
+                <a:latin typeface="Calibri" pitchFamily="34" charset="0"/>
+              </a:rPr>
+              <a:t>67</a:t>
+            </a:r>
+            <a:endParaRPr lang="it-IT" sz="1050" dirty="0"/>
+          </a:p>
+        </p:txBody>
+      </p:sp>
+      <p:sp>
+        <p:nvSpPr>
+          <p:cNvPr id="16" name="RC0_2"/>
+          <p:cNvSpPr/>
+          <p:nvPr/>
+        </p:nvSpPr>
+        <p:spPr>
+          <a:xfrm>
+            <a:off x="2630000" y="1425800"/>
+            <a:ext cx="640000" cy="360000"/>
+          </a:xfrm>
+          <a:prstGeom prst="rect">
+            <a:avLst/>
+          </a:prstGeom>
+          <a:noFill/>
+          <a:ln/>
+        </p:spPr>
+        <p:txBody>
+          <a:bodyPr wrap="square" rtlCol="0" anchor="ctr"/>
+          <a:lstStyle/>
+          <a:p>
+            <a:pPr algn="ctr" indent="0" marL="0">
+              <a:buNone/>
+            </a:pPr>
+            <a:r>
+              <a:rPr lang="it-IT" sz="1050" dirty="0">
+                <a:solidFill>
+                  <a:srgbClr val="333333"/>
+                </a:solidFill>
+                <a:latin typeface="Calibri" pitchFamily="34" charset="0"/>
+              </a:rPr>
+              <a:t>~40%</a:t>
+            </a:r>
+            <a:endParaRPr lang="it-IT" sz="1050" dirty="0"/>
+          </a:p>
+        </p:txBody>
+      </p:sp>
+      <p:sp>
+        <p:nvSpPr>
+          <p:cNvPr id="17" name="RC0_3"/>
+          <p:cNvSpPr/>
+          <p:nvPr/>
+        </p:nvSpPr>
+        <p:spPr>
+          <a:xfrm>
+            <a:off x="3330000" y="1425800"/>
+            <a:ext cx="1440000" cy="360000"/>
+          </a:xfrm>
+          <a:prstGeom prst="rect">
+            <a:avLst/>
+          </a:prstGeom>
+          <a:noFill/>
+          <a:ln/>
+        </p:spPr>
+        <p:txBody>
+          <a:bodyPr wrap="square" rtlCol="0" anchor="ctr"/>
+          <a:lstStyle/>
+          <a:p>
+            <a:pPr algn="ctr" indent="0" marL="0">
+              <a:buNone/>
+            </a:pPr>
+            <a:r>
+              <a:rPr lang="it-IT" sz="1000" dirty="0">
+                <a:solidFill>
+                  <a:srgbClr val="333333"/>
+                </a:solidFill>
+                <a:latin typeface="Calibri" pitchFamily="34" charset="0"/>
+              </a:rPr>
+              <a:t>amore, forse, sempre, volere...</a:t>
+            </a:r>
+            <a:endParaRPr lang="it-IT" sz="1000" dirty="0"/>
+          </a:p>
+        </p:txBody>
+      </p:sp>
+      <p:sp>
+        <p:nvSpPr>
+          <p:cNvPr id="18" name="RowBg1"/>
+          <p:cNvSpPr/>
+          <p:nvPr/>
+        </p:nvSpPr>
+        <p:spPr>
+          <a:xfrm>
+            <a:off x="320000" y="1785800"/>
+            <a:ext cx="4600000" cy="360000"/>
+          </a:xfrm>
+          <a:prstGeom prst="rect">
+            <a:avLst/>
+          </a:prstGeom>
+          <a:solidFill>
+            <a:srgbClr val="E8F5E9"/>
+          </a:solidFill>
+          <a:ln w="12700">
+            <a:solidFill>
+              <a:srgbClr val="CADCFC"/>
+            </a:solidFill>
+            <a:prstDash val="solid"/>
+          </a:ln>
+        </p:spPr>
+      </p:sp>
+      <p:sp>
+        <p:nvSpPr>
+          <p:cNvPr id="19" name="RowAccent1"/>
+          <p:cNvSpPr/>
+          <p:nvPr/>
+        </p:nvSpPr>
+        <p:spPr>
+          <a:xfrm>
+            <a:off x="320000" y="1785800"/>
+            <a:ext cx="30000" cy="360000"/>
+          </a:xfrm>
+          <a:prstGeom prst="rect">
+            <a:avLst/>
+          </a:prstGeom>
+          <a:solidFill>
+            <a:srgbClr val="1E7E34"/>
+          </a:solidFill>
+          <a:ln w="25400">
+            <a:solidFill>
+              <a:srgbClr val="1E7E34"/>
+            </a:solidFill>
+            <a:prstDash val="solid"/>
+          </a:ln>
+        </p:spPr>
+      </p:sp>
+      <p:sp>
+        <p:nvSpPr>
+          <p:cNvPr id="20" name="RC1_0"/>
+          <p:cNvSpPr/>
+          <p:nvPr/>
+        </p:nvSpPr>
+        <p:spPr>
+          <a:xfrm>
+            <a:off x="380000" y="1785800"/>
+            <a:ext cx="1740000" cy="360000"/>
+          </a:xfrm>
+          <a:prstGeom prst="rect">
+            <a:avLst/>
+          </a:prstGeom>
+          <a:noFill/>
+          <a:ln/>
+        </p:spPr>
+        <p:txBody>
+          <a:bodyPr wrap="square" rtlCol="0" anchor="ctr"/>
+          <a:lstStyle/>
+          <a:p>
+            <a:pPr algn="l" indent="0" marL="0">
+              <a:buNone/>
+            </a:pPr>
+            <a:r>
+              <a:rPr lang="it-IT" sz="1050" b="1" dirty="0">
+                <a:solidFill>
+                  <a:srgbClr val="1E7E34"/>
+                </a:solidFill>
+                <a:latin typeface="Calibri" pitchFamily="34" charset="0"/>
+              </a:rPr>
+              <a:t>AZIONE</a:t>
+            </a:r>
+            <a:endParaRPr lang="it-IT" sz="1050" dirty="0"/>
+          </a:p>
+        </p:txBody>
+      </p:sp>
+      <p:sp>
+        <p:nvSpPr>
+          <p:cNvPr id="21" name="RC1_1"/>
+          <p:cNvSpPr/>
+          <p:nvPr/>
+        </p:nvSpPr>
+        <p:spPr>
+          <a:xfrm>
+            <a:off x="2180000" y="1785800"/>
+            <a:ext cx="390000" cy="360000"/>
+          </a:xfrm>
+          <a:prstGeom prst="rect">
+            <a:avLst/>
+          </a:prstGeom>
+          <a:noFill/>
+          <a:ln/>
+        </p:spPr>
+        <p:txBody>
+          <a:bodyPr wrap="square" rtlCol="0" anchor="ctr"/>
+          <a:lstStyle/>
+          <a:p>
+            <a:pPr algn="ctr" indent="0" marL="0">
+              <a:buNone/>
+            </a:pPr>
+            <a:r>
+              <a:rPr lang="it-IT" sz="1050" dirty="0">
+                <a:solidFill>
+                  <a:srgbClr val="333333"/>
+                </a:solidFill>
+                <a:latin typeface="Calibri" pitchFamily="34" charset="0"/>
+              </a:rPr>
+              <a:t>17</a:t>
+            </a:r>
+            <a:endParaRPr lang="it-IT" sz="1050" dirty="0"/>
+          </a:p>
+        </p:txBody>
+      </p:sp>
+      <p:sp>
+        <p:nvSpPr>
+          <p:cNvPr id="22" name="RC1_2"/>
+          <p:cNvSpPr/>
+          <p:nvPr/>
+        </p:nvSpPr>
+        <p:spPr>
+          <a:xfrm>
+            <a:off x="2630000" y="1785800"/>
+            <a:ext cx="640000" cy="360000"/>
+          </a:xfrm>
+          <a:prstGeom prst="rect">
+            <a:avLst/>
+          </a:prstGeom>
+          <a:noFill/>
+          <a:ln/>
+        </p:spPr>
+        <p:txBody>
+          <a:bodyPr wrap="square" rtlCol="0" anchor="ctr"/>
+          <a:lstStyle/>
+          <a:p>
+            <a:pPr algn="ctr" indent="0" marL="0">
+              <a:buNone/>
+            </a:pPr>
+            <a:r>
+              <a:rPr lang="it-IT" sz="1050" dirty="0">
+                <a:solidFill>
+                  <a:srgbClr val="333333"/>
+                </a:solidFill>
+                <a:latin typeface="Calibri" pitchFamily="34" charset="0"/>
+              </a:rPr>
+              <a:t>~25%</a:t>
+            </a:r>
+            <a:endParaRPr lang="it-IT" sz="1050" dirty="0"/>
+          </a:p>
+        </p:txBody>
+      </p:sp>
+      <p:sp>
+        <p:nvSpPr>
+          <p:cNvPr id="23" name="RC1_3"/>
+          <p:cNvSpPr/>
+          <p:nvPr/>
+        </p:nvSpPr>
+        <p:spPr>
+          <a:xfrm>
+            <a:off x="3330000" y="1785800"/>
+            <a:ext cx="1440000" cy="360000"/>
+          </a:xfrm>
+          <a:prstGeom prst="rect">
+            <a:avLst/>
+          </a:prstGeom>
+          <a:noFill/>
+          <a:ln/>
+        </p:spPr>
+        <p:txBody>
+          <a:bodyPr wrap="square" rtlCol="0" anchor="ctr"/>
+          <a:lstStyle/>
+          <a:p>
+            <a:pPr algn="ctr" indent="0" marL="0">
+              <a:buNone/>
+            </a:pPr>
+            <a:r>
+              <a:rPr lang="it-IT" sz="1000" dirty="0">
+                <a:solidFill>
+                  <a:srgbClr val="333333"/>
+                </a:solidFill>
+                <a:latin typeface="Calibri" pitchFamily="34" charset="0"/>
+              </a:rPr>
+              <a:t>andare, arrivare, aprire, venire...</a:t>
+            </a:r>
+            <a:endParaRPr lang="it-IT" sz="1000" dirty="0"/>
+          </a:p>
+        </p:txBody>
+      </p:sp>
+      <p:sp>
+        <p:nvSpPr>
+          <p:cNvPr id="24" name="RowBg2"/>
+          <p:cNvSpPr/>
+          <p:nvPr/>
+        </p:nvSpPr>
+        <p:spPr>
+          <a:xfrm>
+            <a:off x="320000" y="2145800"/>
+            <a:ext cx="4600000" cy="360000"/>
+          </a:xfrm>
+          <a:prstGeom prst="rect">
+            <a:avLst/>
+          </a:prstGeom>
+          <a:solidFill>
+            <a:srgbClr val="FFF8E1"/>
+          </a:solidFill>
+          <a:ln w="12700">
+            <a:solidFill>
+              <a:srgbClr val="CADCFC"/>
+            </a:solidFill>
+            <a:prstDash val="solid"/>
+          </a:ln>
+        </p:spPr>
+      </p:sp>
+      <p:sp>
+        <p:nvSpPr>
+          <p:cNvPr id="25" name="RowAccent2"/>
+          <p:cNvSpPr/>
+          <p:nvPr/>
+        </p:nvSpPr>
+        <p:spPr>
+          <a:xfrm>
+            <a:off x="320000" y="2145800"/>
+            <a:ext cx="30000" cy="360000"/>
+          </a:xfrm>
+          <a:prstGeom prst="rect">
+            <a:avLst/>
+          </a:prstGeom>
+          <a:solidFill>
+            <a:srgbClr val="856404"/>
+          </a:solidFill>
+          <a:ln w="25400">
+            <a:solidFill>
+              <a:srgbClr val="856404"/>
+            </a:solidFill>
+            <a:prstDash val="solid"/>
+          </a:ln>
+        </p:spPr>
+      </p:sp>
+      <p:sp>
+        <p:nvSpPr>
+          <p:cNvPr id="26" name="RC2_0"/>
+          <p:cNvSpPr/>
+          <p:nvPr/>
+        </p:nvSpPr>
+        <p:spPr>
+          <a:xfrm>
+            <a:off x="380000" y="2145800"/>
+            <a:ext cx="1740000" cy="360000"/>
+          </a:xfrm>
+          <a:prstGeom prst="rect">
+            <a:avLst/>
+          </a:prstGeom>
+          <a:noFill/>
+          <a:ln/>
+        </p:spPr>
+        <p:txBody>
+          <a:bodyPr wrap="square" rtlCol="0" anchor="ctr"/>
+          <a:lstStyle/>
+          <a:p>
+            <a:pPr algn="l" indent="0" marL="0">
+              <a:buNone/>
+            </a:pPr>
+            <a:r>
+              <a:rPr lang="it-IT" sz="1050" b="1" dirty="0">
+                <a:solidFill>
+                  <a:srgbClr val="856404"/>
+                </a:solidFill>
+                <a:latin typeface="Calibri" pitchFamily="34" charset="0"/>
+              </a:rPr>
+              <a:t>STATO</a:t>
+            </a:r>
+            <a:endParaRPr lang="it-IT" sz="1050" dirty="0"/>
+          </a:p>
+        </p:txBody>
+      </p:sp>
+      <p:sp>
+        <p:nvSpPr>
+          <p:cNvPr id="27" name="RC2_1"/>
+          <p:cNvSpPr/>
+          <p:nvPr/>
+        </p:nvSpPr>
+        <p:spPr>
+          <a:xfrm>
+            <a:off x="2180000" y="2145800"/>
+            <a:ext cx="390000" cy="360000"/>
+          </a:xfrm>
+          <a:prstGeom prst="rect">
+            <a:avLst/>
+          </a:prstGeom>
+          <a:noFill/>
+          <a:ln/>
+        </p:spPr>
+        <p:txBody>
+          <a:bodyPr wrap="square" rtlCol="0" anchor="ctr"/>
+          <a:lstStyle/>
+          <a:p>
+            <a:pPr algn="ctr" indent="0" marL="0">
+              <a:buNone/>
+            </a:pPr>
+            <a:r>
+              <a:rPr lang="it-IT" sz="1050" dirty="0">
+                <a:solidFill>
+                  <a:srgbClr val="333333"/>
+                </a:solidFill>
+                <a:latin typeface="Calibri" pitchFamily="34" charset="0"/>
+              </a:rPr>
+              <a:t>11</a:t>
+            </a:r>
+            <a:endParaRPr lang="it-IT" sz="1050" dirty="0"/>
+          </a:p>
+        </p:txBody>
+      </p:sp>
+      <p:sp>
+        <p:nvSpPr>
+          <p:cNvPr id="28" name="RC2_2"/>
+          <p:cNvSpPr/>
+          <p:nvPr/>
+        </p:nvSpPr>
+        <p:spPr>
+          <a:xfrm>
+            <a:off x="2630000" y="2145800"/>
+            <a:ext cx="640000" cy="360000"/>
+          </a:xfrm>
+          <a:prstGeom prst="rect">
+            <a:avLst/>
+          </a:prstGeom>
+          <a:noFill/>
+          <a:ln/>
+        </p:spPr>
+        <p:txBody>
+          <a:bodyPr wrap="square" rtlCol="0" anchor="ctr"/>
+          <a:lstStyle/>
+          <a:p>
+            <a:pPr algn="ctr" indent="0" marL="0">
+              <a:buNone/>
+            </a:pPr>
+            <a:r>
+              <a:rPr lang="it-IT" sz="1050" dirty="0">
+                <a:solidFill>
+                  <a:srgbClr val="333333"/>
+                </a:solidFill>
+                <a:latin typeface="Calibri" pitchFamily="34" charset="0"/>
+              </a:rPr>
+              <a:t>~19%</a:t>
+            </a:r>
+            <a:endParaRPr lang="it-IT" sz="1050" dirty="0"/>
+          </a:p>
+        </p:txBody>
+      </p:sp>
+      <p:sp>
+        <p:nvSpPr>
+          <p:cNvPr id="29" name="RC2_3"/>
+          <p:cNvSpPr/>
+          <p:nvPr/>
+        </p:nvSpPr>
+        <p:spPr>
+          <a:xfrm>
+            <a:off x="3330000" y="2145800"/>
+            <a:ext cx="1440000" cy="360000"/>
+          </a:xfrm>
+          <a:prstGeom prst="rect">
+            <a:avLst/>
+          </a:prstGeom>
+          <a:noFill/>
+          <a:ln/>
+        </p:spPr>
+        <p:txBody>
+          <a:bodyPr wrap="square" rtlCol="0" anchor="ctr"/>
+          <a:lstStyle/>
+          <a:p>
+            <a:pPr algn="ctr" indent="0" marL="0">
+              <a:buNone/>
+            </a:pPr>
+            <a:r>
+              <a:rPr lang="it-IT" sz="1000" dirty="0">
+                <a:solidFill>
+                  <a:srgbClr val="333333"/>
+                </a:solidFill>
+                <a:latin typeface="Calibri" pitchFamily="34" charset="0"/>
+              </a:rPr>
+              <a:t>ansia, dolore, gioia, tristezza...</a:t>
+            </a:r>
+            <a:endParaRPr lang="it-IT" sz="1000" dirty="0"/>
+          </a:p>
+        </p:txBody>
+      </p:sp>
+      <p:sp>
+        <p:nvSpPr>
+          <p:cNvPr id="30" name="RowBg3"/>
+          <p:cNvSpPr/>
+          <p:nvPr/>
+        </p:nvSpPr>
+        <p:spPr>
+          <a:xfrm>
+            <a:off x="320000" y="2505800"/>
+            <a:ext cx="4600000" cy="360000"/>
+          </a:xfrm>
+          <a:prstGeom prst="rect">
+            <a:avLst/>
+          </a:prstGeom>
+          <a:solidFill>
+            <a:srgbClr val="FCE4EC"/>
+          </a:solidFill>
+          <a:ln w="12700">
+            <a:solidFill>
+              <a:srgbClr val="CADCFC"/>
+            </a:solidFill>
+            <a:prstDash val="solid"/>
+          </a:ln>
+        </p:spPr>
+      </p:sp>
+      <p:sp>
+        <p:nvSpPr>
+          <p:cNvPr id="31" name="RowAccent3"/>
+          <p:cNvSpPr/>
+          <p:nvPr/>
+        </p:nvSpPr>
+        <p:spPr>
+          <a:xfrm>
+            <a:off x="320000" y="2505800"/>
+            <a:ext cx="30000" cy="360000"/>
+          </a:xfrm>
+          <a:prstGeom prst="rect">
+            <a:avLst/>
+          </a:prstGeom>
+          <a:solidFill>
+            <a:srgbClr val="B71C1C"/>
+          </a:solidFill>
+          <a:ln w="25400">
+            <a:solidFill>
+              <a:srgbClr val="B71C1C"/>
+            </a:solidFill>
+            <a:prstDash val="solid"/>
+          </a:ln>
+        </p:spPr>
+      </p:sp>
+      <p:sp>
+        <p:nvSpPr>
+          <p:cNvPr id="32" name="RC3_0"/>
+          <p:cNvSpPr/>
+          <p:nvPr/>
+        </p:nvSpPr>
+        <p:spPr>
+          <a:xfrm>
+            <a:off x="380000" y="2505800"/>
+            <a:ext cx="1740000" cy="360000"/>
+          </a:xfrm>
+          <a:prstGeom prst="rect">
+            <a:avLst/>
+          </a:prstGeom>
+          <a:noFill/>
+          <a:ln/>
+        </p:spPr>
+        <p:txBody>
+          <a:bodyPr wrap="square" rtlCol="0" anchor="ctr"/>
+          <a:lstStyle/>
+          <a:p>
+            <a:pPr algn="l" indent="0" marL="0">
+              <a:buNone/>
+            </a:pPr>
+            <a:r>
+              <a:rPr lang="it-IT" sz="1050" b="1" dirty="0">
+                <a:solidFill>
+                  <a:srgbClr val="B71C1C"/>
+                </a:solidFill>
+                <a:latin typeface="Calibri" pitchFamily="34" charset="0"/>
+              </a:rPr>
+              <a:t>CONCRETO</a:t>
+            </a:r>
+            <a:endParaRPr lang="it-IT" sz="1050" dirty="0"/>
+          </a:p>
+        </p:txBody>
+      </p:sp>
+      <p:sp>
+        <p:nvSpPr>
+          <p:cNvPr id="33" name="RC3_1"/>
+          <p:cNvSpPr/>
+          <p:nvPr/>
+        </p:nvSpPr>
+        <p:spPr>
+          <a:xfrm>
+            <a:off x="2180000" y="2505800"/>
+            <a:ext cx="390000" cy="360000"/>
+          </a:xfrm>
+          <a:prstGeom prst="rect">
+            <a:avLst/>
+          </a:prstGeom>
+          <a:noFill/>
+          <a:ln/>
+        </p:spPr>
+        <p:txBody>
+          <a:bodyPr wrap="square" rtlCol="0" anchor="ctr"/>
+          <a:lstStyle/>
+          <a:p>
+            <a:pPr algn="ctr" indent="0" marL="0">
+              <a:buNone/>
+            </a:pPr>
+            <a:r>
+              <a:rPr lang="it-IT" sz="1050" dirty="0">
+                <a:solidFill>
+                  <a:srgbClr val="333333"/>
+                </a:solidFill>
+                <a:latin typeface="Calibri" pitchFamily="34" charset="0"/>
+              </a:rPr>
+              <a:t>15</a:t>
+            </a:r>
+            <a:endParaRPr lang="it-IT" sz="1050" dirty="0"/>
+          </a:p>
+        </p:txBody>
+      </p:sp>
+      <p:sp>
+        <p:nvSpPr>
+          <p:cNvPr id="34" name="RC3_2"/>
+          <p:cNvSpPr/>
+          <p:nvPr/>
+        </p:nvSpPr>
+        <p:spPr>
+          <a:xfrm>
+            <a:off x="2630000" y="2505800"/>
+            <a:ext cx="640000" cy="360000"/>
+          </a:xfrm>
+          <a:prstGeom prst="rect">
+            <a:avLst/>
+          </a:prstGeom>
+          <a:noFill/>
+          <a:ln/>
+        </p:spPr>
+        <p:txBody>
+          <a:bodyPr wrap="square" rtlCol="0" anchor="ctr"/>
+          <a:lstStyle/>
+          <a:p>
+            <a:pPr algn="ctr" indent="0" marL="0">
+              <a:buNone/>
+            </a:pPr>
+            <a:r>
+              <a:rPr lang="it-IT" sz="1050" dirty="0">
+                <a:solidFill>
+                  <a:srgbClr val="333333"/>
+                </a:solidFill>
+                <a:latin typeface="Calibri" pitchFamily="34" charset="0"/>
+              </a:rPr>
+              <a:t>~16%</a:t>
+            </a:r>
+            <a:endParaRPr lang="it-IT" sz="1050" dirty="0"/>
+          </a:p>
+        </p:txBody>
+      </p:sp>
+      <p:sp>
+        <p:nvSpPr>
+          <p:cNvPr id="35" name="RC3_3"/>
+          <p:cNvSpPr/>
+          <p:nvPr/>
+        </p:nvSpPr>
+        <p:spPr>
+          <a:xfrm>
+            <a:off x="3330000" y="2505800"/>
+            <a:ext cx="1440000" cy="360000"/>
+          </a:xfrm>
+          <a:prstGeom prst="rect">
+            <a:avLst/>
+          </a:prstGeom>
+          <a:noFill/>
+          <a:ln/>
+        </p:spPr>
+        <p:txBody>
+          <a:bodyPr wrap="square" rtlCol="0" anchor="ctr"/>
+          <a:lstStyle/>
+          <a:p>
+            <a:pPr algn="ctr" indent="0" marL="0">
+              <a:buNone/>
+            </a:pPr>
+            <a:r>
+              <a:rPr lang="it-IT" sz="1000" dirty="0">
+                <a:solidFill>
+                  <a:srgbClr val="333333"/>
+                </a:solidFill>
+                <a:latin typeface="Calibri" pitchFamily="34" charset="0"/>
+              </a:rPr>
+              <a:t>acqua, computer, macchina, bagno...</a:t>
+            </a:r>
+            <a:endParaRPr lang="it-IT" sz="1000" dirty="0"/>
+          </a:p>
+        </p:txBody>
+      </p:sp>
+      <p:sp>
+        <p:nvSpPr>
+          <p:cNvPr id="36" name="ImbalBg"/>
+          <p:cNvSpPr/>
+          <p:nvPr/>
+        </p:nvSpPr>
+        <p:spPr>
+          <a:xfrm>
+            <a:off x="320000" y="2945800"/>
+            <a:ext cx="4600000" cy="320000"/>
+          </a:xfrm>
+          <a:prstGeom prst="rect">
+            <a:avLst/>
+          </a:prstGeom>
+          <a:solidFill>
+            <a:srgbClr val="FFF3CD"/>
+          </a:solidFill>
+          <a:ln w="19050">
+            <a:solidFill>
+              <a:srgbClr val="F0AD4E"/>
+            </a:solidFill>
+            <a:prstDash val="solid"/>
+          </a:ln>
+        </p:spPr>
+      </p:sp>
+      <p:sp>
+        <p:nvSpPr>
+          <p:cNvPr id="37" name="ImbalTxt"/>
+          <p:cNvSpPr/>
+          <p:nvPr/>
+        </p:nvSpPr>
+        <p:spPr>
+          <a:xfrm>
+            <a:off x="420000" y="2995800"/>
+            <a:ext cx="4400000" cy="220000"/>
+          </a:xfrm>
+          <a:prstGeom prst="rect">
+            <a:avLst/>
+          </a:prstGeom>
+          <a:noFill/>
+          <a:ln/>
+        </p:spPr>
+        <p:txBody>
+          <a:bodyPr wrap="square" rtlCol="0" anchor="t"/>
+          <a:lstStyle/>
+          <a:p>
+            <a:pPr algn="l" indent="0" marL="0">
+              <a:buNone/>
+            </a:pPr>
+            <a:r>
+              <a:rPr lang="it-IT" sz="1000" dirty="0">
+                <a:solidFill>
+                  <a:srgbClr val="856404"/>
+                </a:solidFill>
+                <a:latin typeface="Calibri" pitchFamily="34" charset="0"/>
+              </a:rPr>
+              <a:t>Sbilanciamento gestito: class weights (1/freq) a training time + Balanced Accuracy per evaluation</a:t>
+            </a:r>
+            <a:endParaRPr lang="it-IT" sz="1000" dirty="0"/>
+          </a:p>
+          <a:p>
+            <a:pPr algn="l" indent="0" marL="0">
+              <a:buNone/>
+            </a:pPr>
+            <a:r>
+              <a:rPr lang="it-IT" sz="1000" b="1" dirty="0">
+                <a:solidFill>
+                  <a:srgbClr val="856404"/>
+                </a:solidFill>
+                <a:latin typeface="Calibri" pitchFamily="34" charset="0"/>
+              </a:rPr>
+              <a:t>→ chance level = 25% indipendentemente dalla distribuzione delle classi</a:t>
+            </a:r>
+            <a:endParaRPr lang="it-IT" sz="1000" dirty="0"/>
+          </a:p>
+        </p:txBody>
+      </p:sp>
+      <p:sp>
+        <p:nvSpPr>
+          <p:cNvPr id="38" name="RHdrBg"/>
+          <p:cNvSpPr/>
+          <p:nvPr/>
+        </p:nvSpPr>
+        <p:spPr>
+          <a:xfrm>
+            <a:off x="5120000" y="845800"/>
+            <a:ext cx="3844000" cy="300000"/>
+          </a:xfrm>
+          <a:prstGeom prst="rect">
+            <a:avLst/>
+          </a:prstGeom>
+          <a:solidFill>
+            <a:srgbClr val="1E2761"/>
+          </a:solidFill>
+          <a:ln w="25400">
+            <a:solidFill>
+              <a:srgbClr val="1E2761"/>
+            </a:solidFill>
+            <a:prstDash val="solid"/>
+          </a:ln>
+        </p:spPr>
+      </p:sp>
+      <p:sp>
+        <p:nvSpPr>
+          <p:cNvPr id="39" name="RHdrTxt"/>
+          <p:cNvSpPr/>
+          <p:nvPr/>
+        </p:nvSpPr>
+        <p:spPr>
+          <a:xfrm>
+            <a:off x="5120000" y="845800"/>
+            <a:ext cx="3844000" cy="300000"/>
+          </a:xfrm>
+          <a:prstGeom prst="rect">
+            <a:avLst/>
+          </a:prstGeom>
+          <a:noFill/>
+          <a:ln/>
+        </p:spPr>
+        <p:txBody>
+          <a:bodyPr wrap="square" rtlCol="0" anchor="ctr"/>
+          <a:lstStyle/>
+          <a:p>
+            <a:pPr algn="ctr" indent="0" marL="0">
+              <a:buNone/>
+            </a:pPr>
+            <a:r>
+              <a:rPr lang="it-IT" sz="1200" b="1" dirty="0">
+                <a:solidFill>
+                  <a:srgbClr val="CADCFC"/>
+                </a:solidFill>
+                <a:latin typeface="Calibri" pitchFamily="34" charset="0"/>
+              </a:rPr>
+              <a:t>Perche e un buon schema?</a:t>
+            </a:r>
+            <a:endParaRPr lang="it-IT" sz="1200" dirty="0"/>
+          </a:p>
+        </p:txBody>
+      </p:sp>
+      <p:sp>
+        <p:nvSpPr>
+          <p:cNvPr id="40" name="ReasonBg0"/>
+          <p:cNvSpPr/>
+          <p:nvPr/>
+        </p:nvSpPr>
+        <p:spPr>
+          <a:xfrm>
+            <a:off x="5120000" y="1225800"/>
+            <a:ext cx="3844000" cy="700000"/>
+          </a:xfrm>
+          <a:prstGeom prst="rect">
+            <a:avLst/>
+          </a:prstGeom>
+          <a:solidFill>
+            <a:srgbClr val="E8EDF8"/>
+          </a:solidFill>
+          <a:ln w="15875">
+            <a:solidFill>
+              <a:srgbClr val="CADCFC"/>
+            </a:solidFill>
+            <a:prstDash val="solid"/>
+          </a:ln>
+        </p:spPr>
+      </p:sp>
+      <p:sp>
+        <p:nvSpPr>
+          <p:cNvPr id="41" name="ReasonAcc0"/>
+          <p:cNvSpPr/>
+          <p:nvPr/>
+        </p:nvSpPr>
+        <p:spPr>
+          <a:xfrm>
+            <a:off x="5120000" y="1225800"/>
+            <a:ext cx="25000" cy="700000"/>
+          </a:xfrm>
+          <a:prstGeom prst="rect">
+            <a:avLst/>
+          </a:prstGeom>
+          <a:solidFill>
+            <a:srgbClr val="1E2761"/>
+          </a:solidFill>
+          <a:ln w="25400">
+            <a:solidFill>
+              <a:srgbClr val="1E2761"/>
+            </a:solidFill>
+            <a:prstDash val="solid"/>
+          </a:ln>
+        </p:spPr>
+      </p:sp>
+      <p:sp>
+        <p:nvSpPr>
+          <p:cNvPr id="42" name="ReasonTitle0"/>
+          <p:cNvSpPr/>
+          <p:nvPr/>
+        </p:nvSpPr>
+        <p:spPr>
+          <a:xfrm>
+            <a:off x="5200000" y="1275800"/>
+            <a:ext cx="3724000" cy="220000"/>
+          </a:xfrm>
+          <a:prstGeom prst="rect">
+            <a:avLst/>
+          </a:prstGeom>
+          <a:noFill/>
+          <a:ln/>
+        </p:spPr>
+        <p:txBody>
+          <a:bodyPr wrap="square" rtlCol="0" anchor="t"/>
+          <a:lstStyle/>
+          <a:p>
+            <a:pPr algn="l" indent="0" marL="0">
+              <a:buNone/>
+            </a:pPr>
+            <a:r>
+              <a:rPr lang="it-IT" sz="1100" b="1" dirty="0">
+                <a:solidFill>
+                  <a:srgbClr val="1E2761"/>
+                </a:solidFill>
+                <a:latin typeface="Calibri" pitchFamily="34" charset="0"/>
+              </a:rPr>
+              <a:t>1 — Validita psycolinguistica</a:t>
+            </a:r>
+            <a:endParaRPr lang="it-IT" sz="1100" dirty="0"/>
+          </a:p>
+        </p:txBody>
+      </p:sp>
+      <p:sp>
+        <p:nvSpPr>
+          <p:cNvPr id="43" name="ReasonBody0"/>
+          <p:cNvSpPr/>
+          <p:nvPr/>
+        </p:nvSpPr>
+        <p:spPr>
+          <a:xfrm>
+            <a:off x="5200000" y="1485800"/>
+            <a:ext cx="3724000" cy="390000"/>
+          </a:xfrm>
+          <a:prstGeom prst="rect">
+            <a:avLst/>
+          </a:prstGeom>
+          <a:noFill/>
+          <a:ln/>
+        </p:spPr>
+        <p:txBody>
+          <a:bodyPr wrap="square" rtlCol="0" anchor="t"/>
+          <a:lstStyle/>
+          <a:p>
+            <a:pPr algn="l" indent="0" marL="0">
+              <a:buNone/>
+            </a:pPr>
+            <a:r>
+              <a:rPr lang="it-IT" sz="1000" dirty="0">
+                <a:solidFill>
+                  <a:srgbClr val="333333"/>
+                </a:solidFill>
+                <a:latin typeface="Calibri" pitchFamily="34" charset="0"/>
+              </a:rPr>
+              <a:t>Basato su Brysbaert et al. (2014): concreteness ratings validati su migliaia di parlanti. Non e arbitrario: ogni parola ha uno score numerico di concretezza.</a:t>
+            </a:r>
+            <a:endParaRPr lang="it-IT" sz="1000" dirty="0"/>
+          </a:p>
+        </p:txBody>
+      </p:sp>
+      <p:sp>
+        <p:nvSpPr>
+          <p:cNvPr id="44" name="ReasonBg1"/>
+          <p:cNvSpPr/>
+          <p:nvPr/>
+        </p:nvSpPr>
+        <p:spPr>
+          <a:xfrm>
+            <a:off x="5120000" y="1985800"/>
+            <a:ext cx="3844000" cy="700000"/>
+          </a:xfrm>
+          <a:prstGeom prst="rect">
+            <a:avLst/>
+          </a:prstGeom>
+          <a:solidFill>
+            <a:srgbClr val="E8F5E9"/>
+          </a:solidFill>
+          <a:ln w="15875">
+            <a:solidFill>
+              <a:srgbClr val="CADCFC"/>
+            </a:solidFill>
+            <a:prstDash val="solid"/>
+          </a:ln>
+        </p:spPr>
+      </p:sp>
+      <p:sp>
+        <p:nvSpPr>
+          <p:cNvPr id="45" name="ReasonAcc1"/>
+          <p:cNvSpPr/>
+          <p:nvPr/>
+        </p:nvSpPr>
+        <p:spPr>
+          <a:xfrm>
+            <a:off x="5120000" y="1985800"/>
+            <a:ext cx="25000" cy="700000"/>
+          </a:xfrm>
+          <a:prstGeom prst="rect">
+            <a:avLst/>
+          </a:prstGeom>
+          <a:solidFill>
+            <a:srgbClr val="1E7E34"/>
+          </a:solidFill>
+          <a:ln w="25400">
+            <a:solidFill>
+              <a:srgbClr val="1E7E34"/>
+            </a:solidFill>
+            <a:prstDash val="solid"/>
+          </a:ln>
+        </p:spPr>
+      </p:sp>
+      <p:sp>
+        <p:nvSpPr>
+          <p:cNvPr id="46" name="ReasonTitle1"/>
+          <p:cNvSpPr/>
+          <p:nvPr/>
+        </p:nvSpPr>
+        <p:spPr>
+          <a:xfrm>
+            <a:off x="5200000" y="2035800"/>
+            <a:ext cx="3724000" cy="220000"/>
+          </a:xfrm>
+          <a:prstGeom prst="rect">
+            <a:avLst/>
+          </a:prstGeom>
+          <a:noFill/>
+          <a:ln/>
+        </p:spPr>
+        <p:txBody>
+          <a:bodyPr wrap="square" rtlCol="0" anchor="t"/>
+          <a:lstStyle/>
+          <a:p>
+            <a:pPr algn="l" indent="0" marL="0">
+              <a:buNone/>
+            </a:pPr>
+            <a:r>
+              <a:rPr lang="it-IT" sz="1100" b="1" dirty="0">
+                <a:solidFill>
+                  <a:srgbClr val="1E7E34"/>
+                </a:solidFill>
+                <a:latin typeface="Calibri" pitchFamily="34" charset="0"/>
+              </a:rPr>
+              <a:t>2 — Correlati neurali distinti</a:t>
+            </a:r>
+            <a:endParaRPr lang="it-IT" sz="1100" dirty="0"/>
+          </a:p>
+        </p:txBody>
+      </p:sp>
+      <p:sp>
+        <p:nvSpPr>
+          <p:cNvPr id="47" name="ReasonBody1"/>
+          <p:cNvSpPr/>
+          <p:nvPr/>
+        </p:nvSpPr>
+        <p:spPr>
+          <a:xfrm>
+            <a:off x="5200000" y="2245800"/>
+            <a:ext cx="3724000" cy="390000"/>
+          </a:xfrm>
+          <a:prstGeom prst="rect">
+            <a:avLst/>
+          </a:prstGeom>
+          <a:noFill/>
+          <a:ln/>
+        </p:spPr>
+        <p:txBody>
+          <a:bodyPr wrap="square" rtlCol="0" anchor="t"/>
+          <a:lstStyle/>
+          <a:p>
+            <a:pPr algn="l" indent="0" marL="0">
+              <a:buNone/>
+            </a:pPr>
+            <a:r>
+              <a:rPr lang="it-IT" sz="1000" dirty="0">
+                <a:solidFill>
+                  <a:srgbClr val="333333"/>
+                </a:solidFill>
+                <a:latin typeface="Calibri" pitchFamily="34" charset="0"/>
+              </a:rPr>
+              <a:t>Parole concrete vs astratte attivano reti cerebrali diverse (sensorimotor cortex vs DMN). Le 4 classi riflettono processi cognitivi realmente distinti durante l'imagined speech.</a:t>
+            </a:r>
+            <a:endParaRPr lang="it-IT" sz="1000" dirty="0"/>
+          </a:p>
+        </p:txBody>
+      </p:sp>
+      <p:sp>
+        <p:nvSpPr>
+          <p:cNvPr id="48" name="ReasonBg2"/>
+          <p:cNvSpPr/>
+          <p:nvPr/>
+        </p:nvSpPr>
+        <p:spPr>
+          <a:xfrm>
+            <a:off x="5120000" y="2745800"/>
+            <a:ext cx="3844000" cy="700000"/>
+          </a:xfrm>
+          <a:prstGeom prst="rect">
+            <a:avLst/>
+          </a:prstGeom>
+          <a:solidFill>
+            <a:srgbClr val="FFF8E1"/>
+          </a:solidFill>
+          <a:ln w="15875">
+            <a:solidFill>
+              <a:srgbClr val="CADCFC"/>
+            </a:solidFill>
+            <a:prstDash val="solid"/>
+          </a:ln>
+        </p:spPr>
+      </p:sp>
+      <p:sp>
+        <p:nvSpPr>
+          <p:cNvPr id="49" name="ReasonAcc2"/>
+          <p:cNvSpPr/>
+          <p:nvPr/>
+        </p:nvSpPr>
+        <p:spPr>
+          <a:xfrm>
+            <a:off x="5120000" y="2745800"/>
+            <a:ext cx="25000" cy="700000"/>
+          </a:xfrm>
+          <a:prstGeom prst="rect">
+            <a:avLst/>
+          </a:prstGeom>
+          <a:solidFill>
+            <a:srgbClr val="856404"/>
+          </a:solidFill>
+          <a:ln w="25400">
+            <a:solidFill>
+              <a:srgbClr val="856404"/>
+            </a:solidFill>
+            <a:prstDash val="solid"/>
+          </a:ln>
+        </p:spPr>
+      </p:sp>
+      <p:sp>
+        <p:nvSpPr>
+          <p:cNvPr id="50" name="ReasonTitle2"/>
+          <p:cNvSpPr/>
+          <p:nvPr/>
+        </p:nvSpPr>
+        <p:spPr>
+          <a:xfrm>
+            <a:off x="5200000" y="2795800"/>
+            <a:ext cx="3724000" cy="220000"/>
+          </a:xfrm>
+          <a:prstGeom prst="rect">
+            <a:avLst/>
+          </a:prstGeom>
+          <a:noFill/>
+          <a:ln/>
+        </p:spPr>
+        <p:txBody>
+          <a:bodyPr wrap="square" rtlCol="0" anchor="t"/>
+          <a:lstStyle/>
+          <a:p>
+            <a:pPr algn="l" indent="0" marL="0">
+              <a:buNone/>
+            </a:pPr>
+            <a:r>
+              <a:rPr lang="it-IT" sz="1100" b="1" dirty="0">
+                <a:solidFill>
+                  <a:srgbClr val="856404"/>
+                </a:solidFill>
+                <a:latin typeface="Calibri" pitchFamily="34" charset="0"/>
+              </a:rPr>
+              <a:t>3 — Stabile cross-subject</a:t>
+            </a:r>
+            <a:endParaRPr lang="it-IT" sz="1100" dirty="0"/>
+          </a:p>
+        </p:txBody>
+      </p:sp>
+      <p:sp>
+        <p:nvSpPr>
+          <p:cNvPr id="51" name="ReasonBody2"/>
+          <p:cNvSpPr/>
+          <p:nvPr/>
+        </p:nvSpPr>
+        <p:spPr>
+          <a:xfrm>
+            <a:off x="5200000" y="3005800"/>
+            <a:ext cx="3724000" cy="390000"/>
+          </a:xfrm>
+          <a:prstGeom prst="rect">
+            <a:avLst/>
+          </a:prstGeom>
+          <a:noFill/>
+          <a:ln/>
+        </p:spPr>
+        <p:txBody>
+          <a:bodyPr wrap="square" rtlCol="0" anchor="t"/>
+          <a:lstStyle/>
+          <a:p>
+            <a:pPr algn="l" indent="0" marL="0">
+              <a:buNone/>
+            </a:pPr>
+            <a:r>
+              <a:rPr lang="it-IT" sz="1000" dirty="0">
+                <a:solidFill>
+                  <a:srgbClr val="333333"/>
+                </a:solidFill>
+                <a:latin typeface="Calibri" pitchFamily="34" charset="0"/>
+              </a:rPr>
+              <a:t>Schema fisso, non data-driven: uguale per tutti i 70 soggetti. Ward clustering (ARI cross-sogg. ~0) fallisce perche dipende dai dati EEG di ogni soggetto.</a:t>
+            </a:r>
+            <a:endParaRPr lang="it-IT" sz="1000" dirty="0"/>
+          </a:p>
+        </p:txBody>
+      </p:sp>
+      <p:sp>
+        <p:nvSpPr>
+          <p:cNvPr id="52" name="ReasonBg3"/>
+          <p:cNvSpPr/>
+          <p:nvPr/>
+        </p:nvSpPr>
+        <p:spPr>
+          <a:xfrm>
+            <a:off x="5120000" y="3505800"/>
+            <a:ext cx="3844000" cy="700000"/>
+          </a:xfrm>
+          <a:prstGeom prst="rect">
+            <a:avLst/>
+          </a:prstGeom>
+          <a:solidFill>
+            <a:srgbClr val="FCE4EC"/>
+          </a:solidFill>
+          <a:ln w="15875">
+            <a:solidFill>
+              <a:srgbClr val="CADCFC"/>
+            </a:solidFill>
+            <a:prstDash val="solid"/>
+          </a:ln>
+        </p:spPr>
+      </p:sp>
+      <p:sp>
+        <p:nvSpPr>
+          <p:cNvPr id="53" name="ReasonAcc3"/>
+          <p:cNvSpPr/>
+          <p:nvPr/>
+        </p:nvSpPr>
+        <p:spPr>
+          <a:xfrm>
+            <a:off x="5120000" y="3505800"/>
+            <a:ext cx="25000" cy="700000"/>
+          </a:xfrm>
+          <a:prstGeom prst="rect">
+            <a:avLst/>
+          </a:prstGeom>
+          <a:solidFill>
+            <a:srgbClr val="B71C1C"/>
+          </a:solidFill>
+          <a:ln w="25400">
+            <a:solidFill>
+              <a:srgbClr val="B71C1C"/>
+            </a:solidFill>
+            <a:prstDash val="solid"/>
+          </a:ln>
+        </p:spPr>
+      </p:sp>
+      <p:sp>
+        <p:nvSpPr>
+          <p:cNvPr id="54" name="ReasonTitle3"/>
+          <p:cNvSpPr/>
+          <p:nvPr/>
+        </p:nvSpPr>
+        <p:spPr>
+          <a:xfrm>
+            <a:off x="5200000" y="3555800"/>
+            <a:ext cx="3724000" cy="220000"/>
+          </a:xfrm>
+          <a:prstGeom prst="rect">
+            <a:avLst/>
+          </a:prstGeom>
+          <a:noFill/>
+          <a:ln/>
+        </p:spPr>
+        <p:txBody>
+          <a:bodyPr wrap="square" rtlCol="0" anchor="t"/>
+          <a:lstStyle/>
+          <a:p>
+            <a:pPr algn="l" indent="0" marL="0">
+              <a:buNone/>
+            </a:pPr>
+            <a:r>
+              <a:rPr lang="it-IT" sz="1100" b="1" dirty="0">
+                <a:solidFill>
+                  <a:srgbClr val="B71C1C"/>
+                </a:solidFill>
+                <a:latin typeface="Calibri" pitchFamily="34" charset="0"/>
+              </a:rPr>
+              <a:t>4 — Migliore di 110 classi</a:t>
+            </a:r>
+            <a:endParaRPr lang="it-IT" sz="1100" dirty="0"/>
+          </a:p>
+        </p:txBody>
+      </p:sp>
+      <p:sp>
+        <p:nvSpPr>
+          <p:cNvPr id="55" name="ReasonBody3"/>
+          <p:cNvSpPr/>
+          <p:nvPr/>
+        </p:nvSpPr>
+        <p:spPr>
+          <a:xfrm>
+            <a:off x="5200000" y="3765800"/>
+            <a:ext cx="3724000" cy="390000"/>
+          </a:xfrm>
+          <a:prstGeom prst="rect">
+            <a:avLst/>
+          </a:prstGeom>
+          <a:noFill/>
+          <a:ln/>
+        </p:spPr>
+        <p:txBody>
+          <a:bodyPr wrap="square" rtlCol="0" anchor="t"/>
+          <a:lstStyle/>
+          <a:p>
+            <a:pPr algn="l" indent="0" marL="0">
+              <a:buNone/>
+            </a:pPr>
+            <a:r>
+              <a:rPr lang="it-IT" sz="1000" dirty="0">
+                <a:solidFill>
+                  <a:srgbClr val="333333"/>
+                </a:solidFill>
+                <a:latin typeface="Calibri" pitchFamily="34" charset="0"/>
+              </a:rPr>
+              <a:t>110 classi = ~3 trial/parola per test subject. 4 classi = numero di trial sufficiente per stima robusta della performance. Task piu realistico e misurabile.</a:t>
+            </a:r>
+            <a:endParaRPr lang="it-IT" sz="1000" dirty="0"/>
+          </a:p>
+        </p:txBody>
+      </p:sp>
+    </p:spTree>
+  </p:cSld>
+  <p:clrMapOvr>
+    <a:masterClrMapping/>
+  </p:clrMapOvr>
+</p:sld>
+</file>
+
 <file path=ppt/slides/slide2.xml><?xml version="1.0" encoding="utf-8"?>
 <p:sld xmlns:a="http://schemas.openxmlformats.org/drawingml/2006/main" xmlns:r="http://schemas.openxmlformats.org/officeDocument/2006/relationships" xmlns:p="http://schemas.openxmlformats.org/presentationml/2006/main">
   <p:cSld name="Slide 2">

</xml_diff>